<commit_message>
Track sales_fact parquet and outstanding remote-work pack.
Allowlist derived sales/pricing parquets for holiday clones; keep raw billing XLSX off git. Refresh sales_fact.csv and push pending dashboards, pricing, meetings, and tools.

Co-authored-by: Cursor <cursoragent@cursor.com>
</commit_message>
<xml_diff>
--- a/09_meetings/IBX_Sales_Review_2026/ISZE_IBX_Sales_Review_FY2027_share.pptx
+++ b/09_meetings/IBX_Sales_Review_2026/ISZE_IBX_Sales_Review_FY2027_share.pptx
@@ -5,42 +5,42 @@
     <p:sldMasterId id="2147483648" r:id="rId1"/>
   </p:sldMasterIdLst>
   <p:sldIdLst>
-    <p:sldId id="256" r:id="rId7"/>
-    <p:sldId id="257" r:id="rId8"/>
-    <p:sldId id="258" r:id="rId9"/>
-    <p:sldId id="259" r:id="rId10"/>
-    <p:sldId id="260" r:id="rId11"/>
-    <p:sldId id="261" r:id="rId12"/>
-    <p:sldId id="262" r:id="rId13"/>
-    <p:sldId id="263" r:id="rId14"/>
-    <p:sldId id="264" r:id="rId15"/>
-    <p:sldId id="265" r:id="rId16"/>
-    <p:sldId id="266" r:id="rId17"/>
-    <p:sldId id="267" r:id="rId18"/>
-    <p:sldId id="268" r:id="rId19"/>
-    <p:sldId id="269" r:id="rId20"/>
-    <p:sldId id="270" r:id="rId21"/>
-    <p:sldId id="271" r:id="rId22"/>
-    <p:sldId id="272" r:id="rId23"/>
-    <p:sldId id="273" r:id="rId24"/>
-    <p:sldId id="274" r:id="rId25"/>
-    <p:sldId id="275" r:id="rId26"/>
-    <p:sldId id="276" r:id="rId27"/>
-    <p:sldId id="277" r:id="rId28"/>
-    <p:sldId id="278" r:id="rId29"/>
-    <p:sldId id="279" r:id="rId30"/>
-    <p:sldId id="280" r:id="rId31"/>
-    <p:sldId id="281" r:id="rId32"/>
-    <p:sldId id="282" r:id="rId33"/>
-    <p:sldId id="283" r:id="rId34"/>
-    <p:sldId id="284" r:id="rId35"/>
-    <p:sldId id="285" r:id="rId36"/>
-    <p:sldId id="286" r:id="rId37"/>
-    <p:sldId id="287" r:id="rId38"/>
-    <p:sldId id="288" r:id="rId39"/>
-    <p:sldId id="289" r:id="rId40"/>
+    <p:sldId id="256" r:id="rId2"/>
+    <p:sldId id="257" r:id="rId3"/>
+    <p:sldId id="258" r:id="rId4"/>
+    <p:sldId id="259" r:id="rId5"/>
+    <p:sldId id="260" r:id="rId6"/>
+    <p:sldId id="261" r:id="rId7"/>
+    <p:sldId id="262" r:id="rId8"/>
+    <p:sldId id="263" r:id="rId9"/>
+    <p:sldId id="264" r:id="rId10"/>
+    <p:sldId id="265" r:id="rId11"/>
+    <p:sldId id="266" r:id="rId12"/>
+    <p:sldId id="267" r:id="rId13"/>
+    <p:sldId id="268" r:id="rId14"/>
+    <p:sldId id="269" r:id="rId15"/>
+    <p:sldId id="270" r:id="rId16"/>
+    <p:sldId id="271" r:id="rId17"/>
+    <p:sldId id="272" r:id="rId18"/>
+    <p:sldId id="273" r:id="rId19"/>
+    <p:sldId id="274" r:id="rId20"/>
+    <p:sldId id="275" r:id="rId21"/>
+    <p:sldId id="276" r:id="rId22"/>
+    <p:sldId id="277" r:id="rId23"/>
+    <p:sldId id="278" r:id="rId24"/>
+    <p:sldId id="279" r:id="rId25"/>
+    <p:sldId id="280" r:id="rId26"/>
+    <p:sldId id="281" r:id="rId27"/>
+    <p:sldId id="282" r:id="rId28"/>
+    <p:sldId id="283" r:id="rId29"/>
+    <p:sldId id="284" r:id="rId30"/>
+    <p:sldId id="285" r:id="rId31"/>
+    <p:sldId id="286" r:id="rId32"/>
+    <p:sldId id="287" r:id="rId33"/>
+    <p:sldId id="288" r:id="rId34"/>
+    <p:sldId id="289" r:id="rId35"/>
   </p:sldIdLst>
-  <p:sldSz cx="12188952" cy="6858000" type="screen4x3"/>
+  <p:sldSz cx="12188825" cy="6858000"/>
   <p:notesSz cx="6858000" cy="9144000"/>
   <p:defaultTextStyle>
     <a:defPPr>
@@ -137,6 +137,22 @@
       </a:defRPr>
     </a:lvl9pPr>
   </p:defaultTextStyle>
+  <p:extLst>
+    <p:ext uri="{EFAFB233-063F-42B5-8137-9DF3F51BA10A}">
+      <p15:sldGuideLst xmlns:p15="http://schemas.microsoft.com/office/powerpoint/2012/main">
+        <p15:guide id="1" orient="horz" pos="2160">
+          <p15:clr>
+            <a:srgbClr val="A4A3A4"/>
+          </p15:clr>
+        </p15:guide>
+        <p15:guide id="2" pos="2880">
+          <p15:clr>
+            <a:srgbClr val="A4A3A4"/>
+          </p15:clr>
+        </p15:guide>
+      </p15:sldGuideLst>
+    </p:ext>
+  </p:extLst>
 </p:presentation>
 </file>
 
@@ -178,10 +194,9 @@
           <a:lstStyle/>
           <a:p>
             <a:r>
-              <a:rPr lang="en-US" smtClean="0"/>
+              <a:rPr lang="en-US"/>
               <a:t>Click to edit Master title style</a:t>
             </a:r>
-            <a:endParaRPr lang="en-US"/>
           </a:p>
         </p:txBody>
       </p:sp>
@@ -297,10 +312,9 @@
           </a:lstStyle>
           <a:p>
             <a:r>
-              <a:rPr lang="en-US" smtClean="0"/>
+              <a:rPr lang="en-US"/>
               <a:t>Click to edit Master subtitle style</a:t>
             </a:r>
-            <a:endParaRPr lang="en-US"/>
           </a:p>
         </p:txBody>
       </p:sp>
@@ -321,7 +335,7 @@
           <a:p>
             <a:fld id="{5BCAD085-E8A6-8845-BD4E-CB4CCA059FC4}" type="datetimeFigureOut">
               <a:rPr lang="en-US" smtClean="0"/>
-              <a:t>1/27/13</a:t>
+              <a:t>8/11/2026</a:t>
             </a:fld>
             <a:endParaRPr lang="en-US"/>
           </a:p>
@@ -415,10 +429,9 @@
           <a:lstStyle/>
           <a:p>
             <a:r>
-              <a:rPr lang="en-US" smtClean="0"/>
+              <a:rPr lang="en-US"/>
               <a:t>Click to edit Master title style</a:t>
             </a:r>
-            <a:endParaRPr lang="en-US"/>
           </a:p>
         </p:txBody>
       </p:sp>
@@ -439,38 +452,37 @@
           <a:p>
             <a:pPr lvl="0"/>
             <a:r>
-              <a:rPr lang="en-US" smtClean="0"/>
+              <a:rPr lang="en-US"/>
               <a:t>Click to edit Master text styles</a:t>
             </a:r>
           </a:p>
           <a:p>
             <a:pPr lvl="1"/>
             <a:r>
-              <a:rPr lang="en-US" smtClean="0"/>
+              <a:rPr lang="en-US"/>
               <a:t>Second level</a:t>
             </a:r>
           </a:p>
           <a:p>
             <a:pPr lvl="2"/>
             <a:r>
-              <a:rPr lang="en-US" smtClean="0"/>
+              <a:rPr lang="en-US"/>
               <a:t>Third level</a:t>
             </a:r>
           </a:p>
           <a:p>
             <a:pPr lvl="3"/>
             <a:r>
-              <a:rPr lang="en-US" smtClean="0"/>
+              <a:rPr lang="en-US"/>
               <a:t>Fourth level</a:t>
             </a:r>
           </a:p>
           <a:p>
             <a:pPr lvl="4"/>
             <a:r>
-              <a:rPr lang="en-US" smtClean="0"/>
+              <a:rPr lang="en-US"/>
               <a:t>Fifth level</a:t>
             </a:r>
-            <a:endParaRPr lang="en-US"/>
           </a:p>
         </p:txBody>
       </p:sp>
@@ -491,7 +503,7 @@
           <a:p>
             <a:fld id="{5BCAD085-E8A6-8845-BD4E-CB4CCA059FC4}" type="datetimeFigureOut">
               <a:rPr lang="en-US" smtClean="0"/>
-              <a:t>1/27/13</a:t>
+              <a:t>8/11/2026</a:t>
             </a:fld>
             <a:endParaRPr lang="en-US"/>
           </a:p>
@@ -590,10 +602,9 @@
           <a:lstStyle/>
           <a:p>
             <a:r>
-              <a:rPr lang="en-US" smtClean="0"/>
+              <a:rPr lang="en-US"/>
               <a:t>Click to edit Master title style</a:t>
             </a:r>
-            <a:endParaRPr lang="en-US"/>
           </a:p>
         </p:txBody>
       </p:sp>
@@ -619,38 +630,37 @@
           <a:p>
             <a:pPr lvl="0"/>
             <a:r>
-              <a:rPr lang="en-US" smtClean="0"/>
+              <a:rPr lang="en-US"/>
               <a:t>Click to edit Master text styles</a:t>
             </a:r>
           </a:p>
           <a:p>
             <a:pPr lvl="1"/>
             <a:r>
-              <a:rPr lang="en-US" smtClean="0"/>
+              <a:rPr lang="en-US"/>
               <a:t>Second level</a:t>
             </a:r>
           </a:p>
           <a:p>
             <a:pPr lvl="2"/>
             <a:r>
-              <a:rPr lang="en-US" smtClean="0"/>
+              <a:rPr lang="en-US"/>
               <a:t>Third level</a:t>
             </a:r>
           </a:p>
           <a:p>
             <a:pPr lvl="3"/>
             <a:r>
-              <a:rPr lang="en-US" smtClean="0"/>
+              <a:rPr lang="en-US"/>
               <a:t>Fourth level</a:t>
             </a:r>
           </a:p>
           <a:p>
             <a:pPr lvl="4"/>
             <a:r>
-              <a:rPr lang="en-US" smtClean="0"/>
+              <a:rPr lang="en-US"/>
               <a:t>Fifth level</a:t>
             </a:r>
-            <a:endParaRPr lang="en-US"/>
           </a:p>
         </p:txBody>
       </p:sp>
@@ -671,7 +681,7 @@
           <a:p>
             <a:fld id="{5BCAD085-E8A6-8845-BD4E-CB4CCA059FC4}" type="datetimeFigureOut">
               <a:rPr lang="en-US" smtClean="0"/>
-              <a:t>1/27/13</a:t>
+              <a:t>8/11/2026</a:t>
             </a:fld>
             <a:endParaRPr lang="en-US"/>
           </a:p>
@@ -765,10 +775,9 @@
           <a:lstStyle/>
           <a:p>
             <a:r>
-              <a:rPr lang="en-US" smtClean="0"/>
+              <a:rPr lang="en-US"/>
               <a:t>Click to edit Master title style</a:t>
             </a:r>
-            <a:endParaRPr lang="en-US"/>
           </a:p>
         </p:txBody>
       </p:sp>
@@ -789,38 +798,37 @@
           <a:p>
             <a:pPr lvl="0"/>
             <a:r>
-              <a:rPr lang="en-US" smtClean="0"/>
+              <a:rPr lang="en-US"/>
               <a:t>Click to edit Master text styles</a:t>
             </a:r>
           </a:p>
           <a:p>
             <a:pPr lvl="1"/>
             <a:r>
-              <a:rPr lang="en-US" smtClean="0"/>
+              <a:rPr lang="en-US"/>
               <a:t>Second level</a:t>
             </a:r>
           </a:p>
           <a:p>
             <a:pPr lvl="2"/>
             <a:r>
-              <a:rPr lang="en-US" smtClean="0"/>
+              <a:rPr lang="en-US"/>
               <a:t>Third level</a:t>
             </a:r>
           </a:p>
           <a:p>
             <a:pPr lvl="3"/>
             <a:r>
-              <a:rPr lang="en-US" smtClean="0"/>
+              <a:rPr lang="en-US"/>
               <a:t>Fourth level</a:t>
             </a:r>
           </a:p>
           <a:p>
             <a:pPr lvl="4"/>
             <a:r>
-              <a:rPr lang="en-US" smtClean="0"/>
+              <a:rPr lang="en-US"/>
               <a:t>Fifth level</a:t>
             </a:r>
-            <a:endParaRPr lang="en-US"/>
           </a:p>
         </p:txBody>
       </p:sp>
@@ -841,7 +849,7 @@
           <a:p>
             <a:fld id="{5BCAD085-E8A6-8845-BD4E-CB4CCA059FC4}" type="datetimeFigureOut">
               <a:rPr lang="en-US" smtClean="0"/>
-              <a:t>1/27/13</a:t>
+              <a:t>8/11/2026</a:t>
             </a:fld>
             <a:endParaRPr lang="en-US"/>
           </a:p>
@@ -944,10 +952,9 @@
           </a:lstStyle>
           <a:p>
             <a:r>
-              <a:rPr lang="en-US" smtClean="0"/>
+              <a:rPr lang="en-US"/>
               <a:t>Click to edit Master title style</a:t>
             </a:r>
-            <a:endParaRPr lang="en-US"/>
           </a:p>
         </p:txBody>
       </p:sp>
@@ -1064,7 +1071,7 @@
           <a:p>
             <a:pPr lvl="0"/>
             <a:r>
-              <a:rPr lang="en-US" smtClean="0"/>
+              <a:rPr lang="en-US"/>
               <a:t>Click to edit Master text styles</a:t>
             </a:r>
           </a:p>
@@ -1087,7 +1094,7 @@
           <a:p>
             <a:fld id="{5BCAD085-E8A6-8845-BD4E-CB4CCA059FC4}" type="datetimeFigureOut">
               <a:rPr lang="en-US" smtClean="0"/>
-              <a:t>1/27/13</a:t>
+              <a:t>8/11/2026</a:t>
             </a:fld>
             <a:endParaRPr lang="en-US"/>
           </a:p>
@@ -1181,10 +1188,9 @@
           <a:lstStyle/>
           <a:p>
             <a:r>
-              <a:rPr lang="en-US" smtClean="0"/>
+              <a:rPr lang="en-US"/>
               <a:t>Click to edit Master title style</a:t>
             </a:r>
-            <a:endParaRPr lang="en-US"/>
           </a:p>
         </p:txBody>
       </p:sp>
@@ -1238,38 +1244,37 @@
           <a:p>
             <a:pPr lvl="0"/>
             <a:r>
-              <a:rPr lang="en-US" smtClean="0"/>
+              <a:rPr lang="en-US"/>
               <a:t>Click to edit Master text styles</a:t>
             </a:r>
           </a:p>
           <a:p>
             <a:pPr lvl="1"/>
             <a:r>
-              <a:rPr lang="en-US" smtClean="0"/>
+              <a:rPr lang="en-US"/>
               <a:t>Second level</a:t>
             </a:r>
           </a:p>
           <a:p>
             <a:pPr lvl="2"/>
             <a:r>
-              <a:rPr lang="en-US" smtClean="0"/>
+              <a:rPr lang="en-US"/>
               <a:t>Third level</a:t>
             </a:r>
           </a:p>
           <a:p>
             <a:pPr lvl="3"/>
             <a:r>
-              <a:rPr lang="en-US" smtClean="0"/>
+              <a:rPr lang="en-US"/>
               <a:t>Fourth level</a:t>
             </a:r>
           </a:p>
           <a:p>
             <a:pPr lvl="4"/>
             <a:r>
-              <a:rPr lang="en-US" smtClean="0"/>
+              <a:rPr lang="en-US"/>
               <a:t>Fifth level</a:t>
             </a:r>
-            <a:endParaRPr lang="en-US"/>
           </a:p>
         </p:txBody>
       </p:sp>
@@ -1323,38 +1328,37 @@
           <a:p>
             <a:pPr lvl="0"/>
             <a:r>
-              <a:rPr lang="en-US" smtClean="0"/>
+              <a:rPr lang="en-US"/>
               <a:t>Click to edit Master text styles</a:t>
             </a:r>
           </a:p>
           <a:p>
             <a:pPr lvl="1"/>
             <a:r>
-              <a:rPr lang="en-US" smtClean="0"/>
+              <a:rPr lang="en-US"/>
               <a:t>Second level</a:t>
             </a:r>
           </a:p>
           <a:p>
             <a:pPr lvl="2"/>
             <a:r>
-              <a:rPr lang="en-US" smtClean="0"/>
+              <a:rPr lang="en-US"/>
               <a:t>Third level</a:t>
             </a:r>
           </a:p>
           <a:p>
             <a:pPr lvl="3"/>
             <a:r>
-              <a:rPr lang="en-US" smtClean="0"/>
+              <a:rPr lang="en-US"/>
               <a:t>Fourth level</a:t>
             </a:r>
           </a:p>
           <a:p>
             <a:pPr lvl="4"/>
             <a:r>
-              <a:rPr lang="en-US" smtClean="0"/>
+              <a:rPr lang="en-US"/>
               <a:t>Fifth level</a:t>
             </a:r>
-            <a:endParaRPr lang="en-US"/>
           </a:p>
         </p:txBody>
       </p:sp>
@@ -1375,7 +1379,7 @@
           <a:p>
             <a:fld id="{5BCAD085-E8A6-8845-BD4E-CB4CCA059FC4}" type="datetimeFigureOut">
               <a:rPr lang="en-US" smtClean="0"/>
-              <a:t>1/27/13</a:t>
+              <a:t>8/11/2026</a:t>
             </a:fld>
             <a:endParaRPr lang="en-US"/>
           </a:p>
@@ -1473,10 +1477,9 @@
           </a:lstStyle>
           <a:p>
             <a:r>
-              <a:rPr lang="en-US" smtClean="0"/>
+              <a:rPr lang="en-US"/>
               <a:t>Click to edit Master title style</a:t>
             </a:r>
-            <a:endParaRPr lang="en-US"/>
           </a:p>
         </p:txBody>
       </p:sp>
@@ -1539,7 +1542,7 @@
           <a:p>
             <a:pPr lvl="0"/>
             <a:r>
-              <a:rPr lang="en-US" smtClean="0"/>
+              <a:rPr lang="en-US"/>
               <a:t>Click to edit Master text styles</a:t>
             </a:r>
           </a:p>
@@ -1595,38 +1598,37 @@
           <a:p>
             <a:pPr lvl="0"/>
             <a:r>
-              <a:rPr lang="en-US" smtClean="0"/>
+              <a:rPr lang="en-US"/>
               <a:t>Click to edit Master text styles</a:t>
             </a:r>
           </a:p>
           <a:p>
             <a:pPr lvl="1"/>
             <a:r>
-              <a:rPr lang="en-US" smtClean="0"/>
+              <a:rPr lang="en-US"/>
               <a:t>Second level</a:t>
             </a:r>
           </a:p>
           <a:p>
             <a:pPr lvl="2"/>
             <a:r>
-              <a:rPr lang="en-US" smtClean="0"/>
+              <a:rPr lang="en-US"/>
               <a:t>Third level</a:t>
             </a:r>
           </a:p>
           <a:p>
             <a:pPr lvl="3"/>
             <a:r>
-              <a:rPr lang="en-US" smtClean="0"/>
+              <a:rPr lang="en-US"/>
               <a:t>Fourth level</a:t>
             </a:r>
           </a:p>
           <a:p>
             <a:pPr lvl="4"/>
             <a:r>
-              <a:rPr lang="en-US" smtClean="0"/>
+              <a:rPr lang="en-US"/>
               <a:t>Fifth level</a:t>
             </a:r>
-            <a:endParaRPr lang="en-US"/>
           </a:p>
         </p:txBody>
       </p:sp>
@@ -1689,7 +1691,7 @@
           <a:p>
             <a:pPr lvl="0"/>
             <a:r>
-              <a:rPr lang="en-US" smtClean="0"/>
+              <a:rPr lang="en-US"/>
               <a:t>Click to edit Master text styles</a:t>
             </a:r>
           </a:p>
@@ -1745,38 +1747,37 @@
           <a:p>
             <a:pPr lvl="0"/>
             <a:r>
-              <a:rPr lang="en-US" smtClean="0"/>
+              <a:rPr lang="en-US"/>
               <a:t>Click to edit Master text styles</a:t>
             </a:r>
           </a:p>
           <a:p>
             <a:pPr lvl="1"/>
             <a:r>
-              <a:rPr lang="en-US" smtClean="0"/>
+              <a:rPr lang="en-US"/>
               <a:t>Second level</a:t>
             </a:r>
           </a:p>
           <a:p>
             <a:pPr lvl="2"/>
             <a:r>
-              <a:rPr lang="en-US" smtClean="0"/>
+              <a:rPr lang="en-US"/>
               <a:t>Third level</a:t>
             </a:r>
           </a:p>
           <a:p>
             <a:pPr lvl="3"/>
             <a:r>
-              <a:rPr lang="en-US" smtClean="0"/>
+              <a:rPr lang="en-US"/>
               <a:t>Fourth level</a:t>
             </a:r>
           </a:p>
           <a:p>
             <a:pPr lvl="4"/>
             <a:r>
-              <a:rPr lang="en-US" smtClean="0"/>
+              <a:rPr lang="en-US"/>
               <a:t>Fifth level</a:t>
             </a:r>
-            <a:endParaRPr lang="en-US"/>
           </a:p>
         </p:txBody>
       </p:sp>
@@ -1797,7 +1798,7 @@
           <a:p>
             <a:fld id="{5BCAD085-E8A6-8845-BD4E-CB4CCA059FC4}" type="datetimeFigureOut">
               <a:rPr lang="en-US" smtClean="0"/>
-              <a:t>1/27/13</a:t>
+              <a:t>8/11/2026</a:t>
             </a:fld>
             <a:endParaRPr lang="en-US"/>
           </a:p>
@@ -1891,10 +1892,9 @@
           <a:lstStyle/>
           <a:p>
             <a:r>
-              <a:rPr lang="en-US" smtClean="0"/>
+              <a:rPr lang="en-US"/>
               <a:t>Click to edit Master title style</a:t>
             </a:r>
-            <a:endParaRPr lang="en-US"/>
           </a:p>
         </p:txBody>
       </p:sp>
@@ -1915,7 +1915,7 @@
           <a:p>
             <a:fld id="{5BCAD085-E8A6-8845-BD4E-CB4CCA059FC4}" type="datetimeFigureOut">
               <a:rPr lang="en-US" smtClean="0"/>
-              <a:t>1/27/13</a:t>
+              <a:t>8/11/2026</a:t>
             </a:fld>
             <a:endParaRPr lang="en-US"/>
           </a:p>
@@ -2010,7 +2010,7 @@
           <a:p>
             <a:fld id="{5BCAD085-E8A6-8845-BD4E-CB4CCA059FC4}" type="datetimeFigureOut">
               <a:rPr lang="en-US" smtClean="0"/>
-              <a:t>1/27/13</a:t>
+              <a:t>8/11/2026</a:t>
             </a:fld>
             <a:endParaRPr lang="en-US"/>
           </a:p>
@@ -2113,10 +2113,9 @@
           </a:lstStyle>
           <a:p>
             <a:r>
-              <a:rPr lang="en-US" smtClean="0"/>
+              <a:rPr lang="en-US"/>
               <a:t>Click to edit Master title style</a:t>
             </a:r>
-            <a:endParaRPr lang="en-US"/>
           </a:p>
         </p:txBody>
       </p:sp>
@@ -2170,38 +2169,37 @@
           <a:p>
             <a:pPr lvl="0"/>
             <a:r>
-              <a:rPr lang="en-US" smtClean="0"/>
+              <a:rPr lang="en-US"/>
               <a:t>Click to edit Master text styles</a:t>
             </a:r>
           </a:p>
           <a:p>
             <a:pPr lvl="1"/>
             <a:r>
-              <a:rPr lang="en-US" smtClean="0"/>
+              <a:rPr lang="en-US"/>
               <a:t>Second level</a:t>
             </a:r>
           </a:p>
           <a:p>
             <a:pPr lvl="2"/>
             <a:r>
-              <a:rPr lang="en-US" smtClean="0"/>
+              <a:rPr lang="en-US"/>
               <a:t>Third level</a:t>
             </a:r>
           </a:p>
           <a:p>
             <a:pPr lvl="3"/>
             <a:r>
-              <a:rPr lang="en-US" smtClean="0"/>
+              <a:rPr lang="en-US"/>
               <a:t>Fourth level</a:t>
             </a:r>
           </a:p>
           <a:p>
             <a:pPr lvl="4"/>
             <a:r>
-              <a:rPr lang="en-US" smtClean="0"/>
+              <a:rPr lang="en-US"/>
               <a:t>Fifth level</a:t>
             </a:r>
-            <a:endParaRPr lang="en-US"/>
           </a:p>
         </p:txBody>
       </p:sp>
@@ -2264,7 +2262,7 @@
           <a:p>
             <a:pPr lvl="0"/>
             <a:r>
-              <a:rPr lang="en-US" smtClean="0"/>
+              <a:rPr lang="en-US"/>
               <a:t>Click to edit Master text styles</a:t>
             </a:r>
           </a:p>
@@ -2287,7 +2285,7 @@
           <a:p>
             <a:fld id="{5BCAD085-E8A6-8845-BD4E-CB4CCA059FC4}" type="datetimeFigureOut">
               <a:rPr lang="en-US" smtClean="0"/>
-              <a:t>1/27/13</a:t>
+              <a:t>8/11/2026</a:t>
             </a:fld>
             <a:endParaRPr lang="en-US"/>
           </a:p>
@@ -2390,10 +2388,9 @@
           </a:lstStyle>
           <a:p>
             <a:r>
-              <a:rPr lang="en-US" smtClean="0"/>
+              <a:rPr lang="en-US"/>
               <a:t>Click to edit Master title style</a:t>
             </a:r>
-            <a:endParaRPr lang="en-US"/>
           </a:p>
         </p:txBody>
       </p:sp>
@@ -2517,7 +2514,7 @@
           <a:p>
             <a:pPr lvl="0"/>
             <a:r>
-              <a:rPr lang="en-US" smtClean="0"/>
+              <a:rPr lang="en-US"/>
               <a:t>Click to edit Master text styles</a:t>
             </a:r>
           </a:p>
@@ -2540,7 +2537,7 @@
           <a:p>
             <a:fld id="{5BCAD085-E8A6-8845-BD4E-CB4CCA059FC4}" type="datetimeFigureOut">
               <a:rPr lang="en-US" smtClean="0"/>
-              <a:t>1/27/13</a:t>
+              <a:t>8/11/2026</a:t>
             </a:fld>
             <a:endParaRPr lang="en-US"/>
           </a:p>
@@ -2649,10 +2646,9 @@
           <a:lstStyle/>
           <a:p>
             <a:r>
-              <a:rPr lang="en-US" smtClean="0"/>
+              <a:rPr lang="en-US"/>
               <a:t>Click to edit Master title style</a:t>
             </a:r>
-            <a:endParaRPr lang="en-US"/>
           </a:p>
         </p:txBody>
       </p:sp>
@@ -2683,38 +2679,37 @@
           <a:p>
             <a:pPr lvl="0"/>
             <a:r>
-              <a:rPr lang="en-US" smtClean="0"/>
+              <a:rPr lang="en-US"/>
               <a:t>Click to edit Master text styles</a:t>
             </a:r>
           </a:p>
           <a:p>
             <a:pPr lvl="1"/>
             <a:r>
-              <a:rPr lang="en-US" smtClean="0"/>
+              <a:rPr lang="en-US"/>
               <a:t>Second level</a:t>
             </a:r>
           </a:p>
           <a:p>
             <a:pPr lvl="2"/>
             <a:r>
-              <a:rPr lang="en-US" smtClean="0"/>
+              <a:rPr lang="en-US"/>
               <a:t>Third level</a:t>
             </a:r>
           </a:p>
           <a:p>
             <a:pPr lvl="3"/>
             <a:r>
-              <a:rPr lang="en-US" smtClean="0"/>
+              <a:rPr lang="en-US"/>
               <a:t>Fourth level</a:t>
             </a:r>
           </a:p>
           <a:p>
             <a:pPr lvl="4"/>
             <a:r>
-              <a:rPr lang="en-US" smtClean="0"/>
+              <a:rPr lang="en-US"/>
               <a:t>Fifth level</a:t>
             </a:r>
-            <a:endParaRPr lang="en-US"/>
           </a:p>
         </p:txBody>
       </p:sp>
@@ -2753,7 +2748,7 @@
           <a:p>
             <a:fld id="{5BCAD085-E8A6-8845-BD4E-CB4CCA059FC4}" type="datetimeFigureOut">
               <a:rPr lang="en-US" smtClean="0"/>
-              <a:t>1/27/13</a:t>
+              <a:t>8/11/2026</a:t>
             </a:fld>
             <a:endParaRPr lang="en-US"/>
           </a:p>
@@ -3112,7 +3107,7 @@
 </file>
 
 <file path=ppt/slides/slide1.xml><?xml version="1.0" encoding="utf-8"?>
-<p:sld xmlns:a="http://schemas.openxmlformats.org/drawingml/2006/main" xmlns:p="http://schemas.openxmlformats.org/presentationml/2006/main" xmlns:r="http://schemas.openxmlformats.org/officeDocument/2006/relationships">
+<p:sld xmlns:a="http://schemas.openxmlformats.org/drawingml/2006/main" xmlns:r="http://schemas.openxmlformats.org/officeDocument/2006/relationships" xmlns:p="http://schemas.openxmlformats.org/presentationml/2006/main">
   <p:cSld>
     <p:bg>
       <p:bgPr>
@@ -3128,7 +3123,14 @@
         <p:cNvGrpSpPr/>
         <p:nvPr/>
       </p:nvGrpSpPr>
-      <p:grpSpPr/>
+      <p:grpSpPr>
+        <a:xfrm>
+          <a:off x="0" y="0"/>
+          <a:ext cx="0" cy="0"/>
+          <a:chOff x="0" y="0"/>
+          <a:chExt cx="0" cy="0"/>
+        </a:xfrm>
+      </p:grpSpPr>
       <p:sp>
         <p:nvSpPr>
           <p:cNvPr id="2" name="Rectangle 1"/>
@@ -3169,6 +3171,7 @@
           <a:lstStyle/>
           <a:p>
             <a:pPr algn="ctr"/>
+            <a:endParaRPr/>
           </a:p>
         </p:txBody>
       </p:sp>
@@ -3342,6 +3345,7 @@
           <a:lstStyle/>
           <a:p>
             <a:pPr algn="ctr"/>
+            <a:endParaRPr/>
           </a:p>
         </p:txBody>
       </p:sp>
@@ -3354,7 +3358,7 @@
 </file>
 
 <file path=ppt/slides/slide10.xml><?xml version="1.0" encoding="utf-8"?>
-<p:sld xmlns:a="http://schemas.openxmlformats.org/drawingml/2006/main" xmlns:p="http://schemas.openxmlformats.org/presentationml/2006/main" xmlns:r="http://schemas.openxmlformats.org/officeDocument/2006/relationships">
+<p:sld xmlns:a="http://schemas.openxmlformats.org/drawingml/2006/main" xmlns:r="http://schemas.openxmlformats.org/officeDocument/2006/relationships" xmlns:p="http://schemas.openxmlformats.org/presentationml/2006/main">
   <p:cSld>
     <p:bg>
       <p:bgPr>
@@ -3370,7 +3374,14 @@
         <p:cNvGrpSpPr/>
         <p:nvPr/>
       </p:nvGrpSpPr>
-      <p:grpSpPr/>
+      <p:grpSpPr>
+        <a:xfrm>
+          <a:off x="0" y="0"/>
+          <a:ext cx="0" cy="0"/>
+          <a:chOff x="0" y="0"/>
+          <a:chExt cx="0" cy="0"/>
+        </a:xfrm>
+      </p:grpSpPr>
       <p:pic>
         <p:nvPicPr>
           <p:cNvPr id="2" name="Picture 1" descr="isuzu_logo_red.png"/>
@@ -3435,6 +3446,7 @@
           <a:lstStyle/>
           <a:p>
             <a:pPr algn="ctr"/>
+            <a:endParaRPr/>
           </a:p>
         </p:txBody>
       </p:sp>
@@ -3548,6 +3560,7 @@
           <a:lstStyle/>
           <a:p>
             <a:pPr algn="ctr"/>
+            <a:endParaRPr/>
           </a:p>
         </p:txBody>
       </p:sp>
@@ -3730,7 +3743,7 @@
 </file>
 
 <file path=ppt/slides/slide11.xml><?xml version="1.0" encoding="utf-8"?>
-<p:sld xmlns:a="http://schemas.openxmlformats.org/drawingml/2006/main" xmlns:p="http://schemas.openxmlformats.org/presentationml/2006/main" xmlns:r="http://schemas.openxmlformats.org/officeDocument/2006/relationships">
+<p:sld xmlns:a="http://schemas.openxmlformats.org/drawingml/2006/main" xmlns:r="http://schemas.openxmlformats.org/officeDocument/2006/relationships" xmlns:p="http://schemas.openxmlformats.org/presentationml/2006/main">
   <p:cSld>
     <p:bg>
       <p:bgPr>
@@ -3746,7 +3759,14 @@
         <p:cNvGrpSpPr/>
         <p:nvPr/>
       </p:nvGrpSpPr>
-      <p:grpSpPr/>
+      <p:grpSpPr>
+        <a:xfrm>
+          <a:off x="0" y="0"/>
+          <a:ext cx="0" cy="0"/>
+          <a:chOff x="0" y="0"/>
+          <a:chExt cx="0" cy="0"/>
+        </a:xfrm>
+      </p:grpSpPr>
       <p:pic>
         <p:nvPicPr>
           <p:cNvPr id="2" name="Picture 1" descr="isuzu_logo_red.png"/>
@@ -3811,6 +3831,7 @@
           <a:lstStyle/>
           <a:p>
             <a:pPr algn="ctr"/>
+            <a:endParaRPr/>
           </a:p>
         </p:txBody>
       </p:sp>
@@ -3924,6 +3945,7 @@
           <a:lstStyle/>
           <a:p>
             <a:pPr algn="ctr"/>
+            <a:endParaRPr/>
           </a:p>
         </p:txBody>
       </p:sp>
@@ -4026,6 +4048,7 @@
           <a:lstStyle/>
           <a:p>
             <a:pPr algn="ctr"/>
+            <a:endParaRPr/>
           </a:p>
         </p:txBody>
       </p:sp>
@@ -4208,7 +4231,7 @@
 </file>
 
 <file path=ppt/slides/slide12.xml><?xml version="1.0" encoding="utf-8"?>
-<p:sld xmlns:a="http://schemas.openxmlformats.org/drawingml/2006/main" xmlns:p="http://schemas.openxmlformats.org/presentationml/2006/main" xmlns:r="http://schemas.openxmlformats.org/officeDocument/2006/relationships">
+<p:sld xmlns:a="http://schemas.openxmlformats.org/drawingml/2006/main" xmlns:r="http://schemas.openxmlformats.org/officeDocument/2006/relationships" xmlns:p="http://schemas.openxmlformats.org/presentationml/2006/main">
   <p:cSld>
     <p:bg>
       <p:bgPr>
@@ -4224,7 +4247,14 @@
         <p:cNvGrpSpPr/>
         <p:nvPr/>
       </p:nvGrpSpPr>
-      <p:grpSpPr/>
+      <p:grpSpPr>
+        <a:xfrm>
+          <a:off x="0" y="0"/>
+          <a:ext cx="0" cy="0"/>
+          <a:chOff x="0" y="0"/>
+          <a:chExt cx="0" cy="0"/>
+        </a:xfrm>
+      </p:grpSpPr>
       <p:pic>
         <p:nvPicPr>
           <p:cNvPr id="2" name="Picture 1" descr="isuzu_logo_red.png"/>
@@ -4289,6 +4319,7 @@
           <a:lstStyle/>
           <a:p>
             <a:pPr algn="ctr"/>
+            <a:endParaRPr/>
           </a:p>
         </p:txBody>
       </p:sp>
@@ -4402,6 +4433,7 @@
           <a:lstStyle/>
           <a:p>
             <a:pPr algn="ctr"/>
+            <a:endParaRPr/>
           </a:p>
         </p:txBody>
       </p:sp>
@@ -4459,9 +4491,27 @@
                 <a:tableStyleId>{5C22544A-7EE6-4342-B048-85BDC9FD1C3A}</a:tableStyleId>
               </a:tblPr>
               <a:tblGrid>
-                <a:gridCol w="6492240"/>
-                <a:gridCol w="2560320"/>
-                <a:gridCol w="2560320"/>
+                <a:gridCol w="6492240">
+                  <a:extLst>
+                    <a:ext uri="{9D8B030D-6E8A-4147-A177-3AD203B41FA5}">
+                      <a16:colId xmlns:a16="http://schemas.microsoft.com/office/drawing/2014/main" val="20000"/>
+                    </a:ext>
+                  </a:extLst>
+                </a:gridCol>
+                <a:gridCol w="2560320">
+                  <a:extLst>
+                    <a:ext uri="{9D8B030D-6E8A-4147-A177-3AD203B41FA5}">
+                      <a16:colId xmlns:a16="http://schemas.microsoft.com/office/drawing/2014/main" val="20001"/>
+                    </a:ext>
+                  </a:extLst>
+                </a:gridCol>
+                <a:gridCol w="2560320">
+                  <a:extLst>
+                    <a:ext uri="{9D8B030D-6E8A-4147-A177-3AD203B41FA5}">
+                      <a16:colId xmlns:a16="http://schemas.microsoft.com/office/drawing/2014/main" val="20002"/>
+                    </a:ext>
+                  </a:extLst>
+                </a:gridCol>
               </a:tblGrid>
               <a:tr h="304800">
                 <a:tc>
@@ -4481,7 +4531,7 @@
                       </a:r>
                     </a:p>
                   </a:txBody>
-                  <a:tcPr anchor="ctr" marL="73152" marR="73152">
+                  <a:tcPr marL="73152" marR="73152" anchor="ctr">
                     <a:solidFill>
                       <a:srgbClr val="CC0E1E"/>
                     </a:solidFill>
@@ -4504,7 +4554,7 @@
                       </a:r>
                     </a:p>
                   </a:txBody>
-                  <a:tcPr anchor="ctr" marL="73152" marR="73152">
+                  <a:tcPr marL="73152" marR="73152" anchor="ctr">
                     <a:solidFill>
                       <a:srgbClr val="CC0E1E"/>
                     </a:solidFill>
@@ -4527,12 +4577,17 @@
                       </a:r>
                     </a:p>
                   </a:txBody>
-                  <a:tcPr anchor="ctr" marL="73152" marR="73152">
+                  <a:tcPr marL="73152" marR="73152" anchor="ctr">
                     <a:solidFill>
                       <a:srgbClr val="CC0E1E"/>
                     </a:solidFill>
                   </a:tcPr>
                 </a:tc>
+                <a:extLst>
+                  <a:ext uri="{0D108BD9-81ED-4DB2-BD59-A6C34878D82A}">
+                    <a16:rowId xmlns:a16="http://schemas.microsoft.com/office/drawing/2014/main" val="10000"/>
+                  </a:ext>
+                </a:extLst>
               </a:tr>
               <a:tr h="304800">
                 <a:tc>
@@ -4552,7 +4607,7 @@
                       </a:r>
                     </a:p>
                   </a:txBody>
-                  <a:tcPr anchor="ctr" marL="73152" marR="73152">
+                  <a:tcPr marL="73152" marR="73152" anchor="ctr">
                     <a:solidFill>
                       <a:srgbClr val="FFFFFF"/>
                     </a:solidFill>
@@ -4575,7 +4630,7 @@
                       </a:r>
                     </a:p>
                   </a:txBody>
-                  <a:tcPr anchor="ctr" marL="73152" marR="73152">
+                  <a:tcPr marL="73152" marR="73152" anchor="ctr">
                     <a:solidFill>
                       <a:srgbClr val="FFFFFF"/>
                     </a:solidFill>
@@ -4598,12 +4653,17 @@
                       </a:r>
                     </a:p>
                   </a:txBody>
-                  <a:tcPr anchor="ctr" marL="73152" marR="73152">
+                  <a:tcPr marL="73152" marR="73152" anchor="ctr">
                     <a:solidFill>
                       <a:srgbClr val="FFFFFF"/>
                     </a:solidFill>
                   </a:tcPr>
                 </a:tc>
+                <a:extLst>
+                  <a:ext uri="{0D108BD9-81ED-4DB2-BD59-A6C34878D82A}">
+                    <a16:rowId xmlns:a16="http://schemas.microsoft.com/office/drawing/2014/main" val="10001"/>
+                  </a:ext>
+                </a:extLst>
               </a:tr>
               <a:tr h="304800">
                 <a:tc>
@@ -4623,7 +4683,7 @@
                       </a:r>
                     </a:p>
                   </a:txBody>
-                  <a:tcPr anchor="ctr" marL="73152" marR="73152">
+                  <a:tcPr marL="73152" marR="73152" anchor="ctr">
                     <a:solidFill>
                       <a:srgbClr val="ECECEC"/>
                     </a:solidFill>
@@ -4646,7 +4706,7 @@
                       </a:r>
                     </a:p>
                   </a:txBody>
-                  <a:tcPr anchor="ctr" marL="73152" marR="73152">
+                  <a:tcPr marL="73152" marR="73152" anchor="ctr">
                     <a:solidFill>
                       <a:srgbClr val="ECECEC"/>
                     </a:solidFill>
@@ -4669,12 +4729,17 @@
                       </a:r>
                     </a:p>
                   </a:txBody>
-                  <a:tcPr anchor="ctr" marL="73152" marR="73152">
+                  <a:tcPr marL="73152" marR="73152" anchor="ctr">
                     <a:solidFill>
                       <a:srgbClr val="ECECEC"/>
                     </a:solidFill>
                   </a:tcPr>
                 </a:tc>
+                <a:extLst>
+                  <a:ext uri="{0D108BD9-81ED-4DB2-BD59-A6C34878D82A}">
+                    <a16:rowId xmlns:a16="http://schemas.microsoft.com/office/drawing/2014/main" val="10002"/>
+                  </a:ext>
+                </a:extLst>
               </a:tr>
               <a:tr h="304800">
                 <a:tc>
@@ -4694,7 +4759,7 @@
                       </a:r>
                     </a:p>
                   </a:txBody>
-                  <a:tcPr anchor="ctr" marL="73152" marR="73152">
+                  <a:tcPr marL="73152" marR="73152" anchor="ctr">
                     <a:solidFill>
                       <a:srgbClr val="FFFFFF"/>
                     </a:solidFill>
@@ -4717,7 +4782,7 @@
                       </a:r>
                     </a:p>
                   </a:txBody>
-                  <a:tcPr anchor="ctr" marL="73152" marR="73152">
+                  <a:tcPr marL="73152" marR="73152" anchor="ctr">
                     <a:solidFill>
                       <a:srgbClr val="FFFFFF"/>
                     </a:solidFill>
@@ -4740,12 +4805,17 @@
                       </a:r>
                     </a:p>
                   </a:txBody>
-                  <a:tcPr anchor="ctr" marL="73152" marR="73152">
+                  <a:tcPr marL="73152" marR="73152" anchor="ctr">
                     <a:solidFill>
                       <a:srgbClr val="FFFFFF"/>
                     </a:solidFill>
                   </a:tcPr>
                 </a:tc>
+                <a:extLst>
+                  <a:ext uri="{0D108BD9-81ED-4DB2-BD59-A6C34878D82A}">
+                    <a16:rowId xmlns:a16="http://schemas.microsoft.com/office/drawing/2014/main" val="10003"/>
+                  </a:ext>
+                </a:extLst>
               </a:tr>
               <a:tr h="304800">
                 <a:tc>
@@ -4765,7 +4835,7 @@
                       </a:r>
                     </a:p>
                   </a:txBody>
-                  <a:tcPr anchor="ctr" marL="73152" marR="73152">
+                  <a:tcPr marL="73152" marR="73152" anchor="ctr">
                     <a:solidFill>
                       <a:srgbClr val="ECECEC"/>
                     </a:solidFill>
@@ -4788,7 +4858,7 @@
                       </a:r>
                     </a:p>
                   </a:txBody>
-                  <a:tcPr anchor="ctr" marL="73152" marR="73152">
+                  <a:tcPr marL="73152" marR="73152" anchor="ctr">
                     <a:solidFill>
                       <a:srgbClr val="ECECEC"/>
                     </a:solidFill>
@@ -4811,12 +4881,17 @@
                       </a:r>
                     </a:p>
                   </a:txBody>
-                  <a:tcPr anchor="ctr" marL="73152" marR="73152">
+                  <a:tcPr marL="73152" marR="73152" anchor="ctr">
                     <a:solidFill>
                       <a:srgbClr val="ECECEC"/>
                     </a:solidFill>
                   </a:tcPr>
                 </a:tc>
+                <a:extLst>
+                  <a:ext uri="{0D108BD9-81ED-4DB2-BD59-A6C34878D82A}">
+                    <a16:rowId xmlns:a16="http://schemas.microsoft.com/office/drawing/2014/main" val="10004"/>
+                  </a:ext>
+                </a:extLst>
               </a:tr>
               <a:tr h="304800">
                 <a:tc>
@@ -4836,7 +4911,7 @@
                       </a:r>
                     </a:p>
                   </a:txBody>
-                  <a:tcPr anchor="ctr" marL="73152" marR="73152">
+                  <a:tcPr marL="73152" marR="73152" anchor="ctr">
                     <a:solidFill>
                       <a:srgbClr val="FFFFFF"/>
                     </a:solidFill>
@@ -4859,7 +4934,7 @@
                       </a:r>
                     </a:p>
                   </a:txBody>
-                  <a:tcPr anchor="ctr" marL="73152" marR="73152">
+                  <a:tcPr marL="73152" marR="73152" anchor="ctr">
                     <a:solidFill>
                       <a:srgbClr val="FFFFFF"/>
                     </a:solidFill>
@@ -4882,12 +4957,17 @@
                       </a:r>
                     </a:p>
                   </a:txBody>
-                  <a:tcPr anchor="ctr" marL="73152" marR="73152">
+                  <a:tcPr marL="73152" marR="73152" anchor="ctr">
                     <a:solidFill>
                       <a:srgbClr val="FFFFFF"/>
                     </a:solidFill>
                   </a:tcPr>
                 </a:tc>
+                <a:extLst>
+                  <a:ext uri="{0D108BD9-81ED-4DB2-BD59-A6C34878D82A}">
+                    <a16:rowId xmlns:a16="http://schemas.microsoft.com/office/drawing/2014/main" val="10005"/>
+                  </a:ext>
+                </a:extLst>
               </a:tr>
               <a:tr h="304800">
                 <a:tc>
@@ -4907,7 +4987,7 @@
                       </a:r>
                     </a:p>
                   </a:txBody>
-                  <a:tcPr anchor="ctr" marL="73152" marR="73152">
+                  <a:tcPr marL="73152" marR="73152" anchor="ctr">
                     <a:solidFill>
                       <a:srgbClr val="ECECEC"/>
                     </a:solidFill>
@@ -4930,7 +5010,7 @@
                       </a:r>
                     </a:p>
                   </a:txBody>
-                  <a:tcPr anchor="ctr" marL="73152" marR="73152">
+                  <a:tcPr marL="73152" marR="73152" anchor="ctr">
                     <a:solidFill>
                       <a:srgbClr val="ECECEC"/>
                     </a:solidFill>
@@ -4953,12 +5033,17 @@
                       </a:r>
                     </a:p>
                   </a:txBody>
-                  <a:tcPr anchor="ctr" marL="73152" marR="73152">
+                  <a:tcPr marL="73152" marR="73152" anchor="ctr">
                     <a:solidFill>
                       <a:srgbClr val="ECECEC"/>
                     </a:solidFill>
                   </a:tcPr>
                 </a:tc>
+                <a:extLst>
+                  <a:ext uri="{0D108BD9-81ED-4DB2-BD59-A6C34878D82A}">
+                    <a16:rowId xmlns:a16="http://schemas.microsoft.com/office/drawing/2014/main" val="10006"/>
+                  </a:ext>
+                </a:extLst>
               </a:tr>
               <a:tr h="304800">
                 <a:tc>
@@ -4978,7 +5063,7 @@
                       </a:r>
                     </a:p>
                   </a:txBody>
-                  <a:tcPr anchor="ctr" marL="73152" marR="73152">
+                  <a:tcPr marL="73152" marR="73152" anchor="ctr">
                     <a:solidFill>
                       <a:srgbClr val="FFFFFF"/>
                     </a:solidFill>
@@ -5001,7 +5086,7 @@
                       </a:r>
                     </a:p>
                   </a:txBody>
-                  <a:tcPr anchor="ctr" marL="73152" marR="73152">
+                  <a:tcPr marL="73152" marR="73152" anchor="ctr">
                     <a:solidFill>
                       <a:srgbClr val="FFFFFF"/>
                     </a:solidFill>
@@ -5024,12 +5109,17 @@
                       </a:r>
                     </a:p>
                   </a:txBody>
-                  <a:tcPr anchor="ctr" marL="73152" marR="73152">
+                  <a:tcPr marL="73152" marR="73152" anchor="ctr">
                     <a:solidFill>
                       <a:srgbClr val="FFFFFF"/>
                     </a:solidFill>
                   </a:tcPr>
                 </a:tc>
+                <a:extLst>
+                  <a:ext uri="{0D108BD9-81ED-4DB2-BD59-A6C34878D82A}">
+                    <a16:rowId xmlns:a16="http://schemas.microsoft.com/office/drawing/2014/main" val="10007"/>
+                  </a:ext>
+                </a:extLst>
               </a:tr>
               <a:tr h="304800">
                 <a:tc>
@@ -5049,7 +5139,7 @@
                       </a:r>
                     </a:p>
                   </a:txBody>
-                  <a:tcPr anchor="ctr" marL="73152" marR="73152">
+                  <a:tcPr marL="73152" marR="73152" anchor="ctr">
                     <a:solidFill>
                       <a:srgbClr val="ECECEC"/>
                     </a:solidFill>
@@ -5072,7 +5162,7 @@
                       </a:r>
                     </a:p>
                   </a:txBody>
-                  <a:tcPr anchor="ctr" marL="73152" marR="73152">
+                  <a:tcPr marL="73152" marR="73152" anchor="ctr">
                     <a:solidFill>
                       <a:srgbClr val="ECECEC"/>
                     </a:solidFill>
@@ -5095,12 +5185,17 @@
                       </a:r>
                     </a:p>
                   </a:txBody>
-                  <a:tcPr anchor="ctr" marL="73152" marR="73152">
+                  <a:tcPr marL="73152" marR="73152" anchor="ctr">
                     <a:solidFill>
                       <a:srgbClr val="ECECEC"/>
                     </a:solidFill>
                   </a:tcPr>
                 </a:tc>
+                <a:extLst>
+                  <a:ext uri="{0D108BD9-81ED-4DB2-BD59-A6C34878D82A}">
+                    <a16:rowId xmlns:a16="http://schemas.microsoft.com/office/drawing/2014/main" val="10008"/>
+                  </a:ext>
+                </a:extLst>
               </a:tr>
             </a:tbl>
           </a:graphicData>
@@ -5250,7 +5345,7 @@
 </file>
 
 <file path=ppt/slides/slide13.xml><?xml version="1.0" encoding="utf-8"?>
-<p:sld xmlns:a="http://schemas.openxmlformats.org/drawingml/2006/main" xmlns:p="http://schemas.openxmlformats.org/presentationml/2006/main" xmlns:r="http://schemas.openxmlformats.org/officeDocument/2006/relationships">
+<p:sld xmlns:a="http://schemas.openxmlformats.org/drawingml/2006/main" xmlns:r="http://schemas.openxmlformats.org/officeDocument/2006/relationships" xmlns:p="http://schemas.openxmlformats.org/presentationml/2006/main">
   <p:cSld>
     <p:bg>
       <p:bgPr>
@@ -5266,7 +5361,14 @@
         <p:cNvGrpSpPr/>
         <p:nvPr/>
       </p:nvGrpSpPr>
-      <p:grpSpPr/>
+      <p:grpSpPr>
+        <a:xfrm>
+          <a:off x="0" y="0"/>
+          <a:ext cx="0" cy="0"/>
+          <a:chOff x="0" y="0"/>
+          <a:chExt cx="0" cy="0"/>
+        </a:xfrm>
+      </p:grpSpPr>
       <p:pic>
         <p:nvPicPr>
           <p:cNvPr id="2" name="Picture 1" descr="isuzu_logo_red.png"/>
@@ -5331,6 +5433,7 @@
           <a:lstStyle/>
           <a:p>
             <a:pPr algn="ctr"/>
+            <a:endParaRPr/>
           </a:p>
         </p:txBody>
       </p:sp>
@@ -5444,6 +5547,7 @@
           <a:lstStyle/>
           <a:p>
             <a:pPr algn="ctr"/>
+            <a:endParaRPr/>
           </a:p>
         </p:txBody>
       </p:sp>
@@ -5546,6 +5650,7 @@
           <a:lstStyle/>
           <a:p>
             <a:pPr algn="ctr"/>
+            <a:endParaRPr/>
           </a:p>
         </p:txBody>
       </p:sp>
@@ -5756,7 +5861,7 @@
 </file>
 
 <file path=ppt/slides/slide14.xml><?xml version="1.0" encoding="utf-8"?>
-<p:sld xmlns:a="http://schemas.openxmlformats.org/drawingml/2006/main" xmlns:p="http://schemas.openxmlformats.org/presentationml/2006/main" xmlns:r="http://schemas.openxmlformats.org/officeDocument/2006/relationships">
+<p:sld xmlns:a="http://schemas.openxmlformats.org/drawingml/2006/main" xmlns:r="http://schemas.openxmlformats.org/officeDocument/2006/relationships" xmlns:p="http://schemas.openxmlformats.org/presentationml/2006/main">
   <p:cSld>
     <p:bg>
       <p:bgPr>
@@ -5772,7 +5877,14 @@
         <p:cNvGrpSpPr/>
         <p:nvPr/>
       </p:nvGrpSpPr>
-      <p:grpSpPr/>
+      <p:grpSpPr>
+        <a:xfrm>
+          <a:off x="0" y="0"/>
+          <a:ext cx="0" cy="0"/>
+          <a:chOff x="0" y="0"/>
+          <a:chExt cx="0" cy="0"/>
+        </a:xfrm>
+      </p:grpSpPr>
       <p:pic>
         <p:nvPicPr>
           <p:cNvPr id="2" name="Picture 1" descr="isuzu_logo_red.png"/>
@@ -5837,6 +5949,7 @@
           <a:lstStyle/>
           <a:p>
             <a:pPr algn="ctr"/>
+            <a:endParaRPr/>
           </a:p>
         </p:txBody>
       </p:sp>
@@ -5950,6 +6063,7 @@
           <a:lstStyle/>
           <a:p>
             <a:pPr algn="ctr"/>
+            <a:endParaRPr/>
           </a:p>
         </p:txBody>
       </p:sp>
@@ -6042,8 +6156,20 @@
                 <a:tableStyleId>{5C22544A-7EE6-4342-B048-85BDC9FD1C3A}</a:tableStyleId>
               </a:tblPr>
               <a:tblGrid>
-                <a:gridCol w="5669280"/>
-                <a:gridCol w="2926080"/>
+                <a:gridCol w="5669280">
+                  <a:extLst>
+                    <a:ext uri="{9D8B030D-6E8A-4147-A177-3AD203B41FA5}">
+                      <a16:colId xmlns:a16="http://schemas.microsoft.com/office/drawing/2014/main" val="20000"/>
+                    </a:ext>
+                  </a:extLst>
+                </a:gridCol>
+                <a:gridCol w="2926080">
+                  <a:extLst>
+                    <a:ext uri="{9D8B030D-6E8A-4147-A177-3AD203B41FA5}">
+                      <a16:colId xmlns:a16="http://schemas.microsoft.com/office/drawing/2014/main" val="20001"/>
+                    </a:ext>
+                  </a:extLst>
+                </a:gridCol>
               </a:tblGrid>
               <a:tr h="429768">
                 <a:tc>
@@ -6063,7 +6189,7 @@
                       </a:r>
                     </a:p>
                   </a:txBody>
-                  <a:tcPr anchor="ctr" marL="73152" marR="73152">
+                  <a:tcPr marL="73152" marR="73152" anchor="ctr">
                     <a:solidFill>
                       <a:srgbClr val="CC0E1E"/>
                     </a:solidFill>
@@ -6086,12 +6212,17 @@
                       </a:r>
                     </a:p>
                   </a:txBody>
-                  <a:tcPr anchor="ctr" marL="73152" marR="73152">
+                  <a:tcPr marL="73152" marR="73152" anchor="ctr">
                     <a:solidFill>
                       <a:srgbClr val="CC0E1E"/>
                     </a:solidFill>
                   </a:tcPr>
                 </a:tc>
+                <a:extLst>
+                  <a:ext uri="{0D108BD9-81ED-4DB2-BD59-A6C34878D82A}">
+                    <a16:rowId xmlns:a16="http://schemas.microsoft.com/office/drawing/2014/main" val="10000"/>
+                  </a:ext>
+                </a:extLst>
               </a:tr>
               <a:tr h="429768">
                 <a:tc>
@@ -6111,7 +6242,7 @@
                       </a:r>
                     </a:p>
                   </a:txBody>
-                  <a:tcPr anchor="ctr" marL="73152" marR="73152">
+                  <a:tcPr marL="73152" marR="73152" anchor="ctr">
                     <a:solidFill>
                       <a:srgbClr val="FFFFFF"/>
                     </a:solidFill>
@@ -6134,12 +6265,17 @@
                       </a:r>
                     </a:p>
                   </a:txBody>
-                  <a:tcPr anchor="ctr" marL="73152" marR="73152">
+                  <a:tcPr marL="73152" marR="73152" anchor="ctr">
                     <a:solidFill>
                       <a:srgbClr val="FFFFFF"/>
                     </a:solidFill>
                   </a:tcPr>
                 </a:tc>
+                <a:extLst>
+                  <a:ext uri="{0D108BD9-81ED-4DB2-BD59-A6C34878D82A}">
+                    <a16:rowId xmlns:a16="http://schemas.microsoft.com/office/drawing/2014/main" val="10001"/>
+                  </a:ext>
+                </a:extLst>
               </a:tr>
               <a:tr h="429768">
                 <a:tc>
@@ -6159,7 +6295,7 @@
                       </a:r>
                     </a:p>
                   </a:txBody>
-                  <a:tcPr anchor="ctr" marL="73152" marR="73152">
+                  <a:tcPr marL="73152" marR="73152" anchor="ctr">
                     <a:solidFill>
                       <a:srgbClr val="ECECEC"/>
                     </a:solidFill>
@@ -6182,12 +6318,17 @@
                       </a:r>
                     </a:p>
                   </a:txBody>
-                  <a:tcPr anchor="ctr" marL="73152" marR="73152">
+                  <a:tcPr marL="73152" marR="73152" anchor="ctr">
                     <a:solidFill>
                       <a:srgbClr val="ECECEC"/>
                     </a:solidFill>
                   </a:tcPr>
                 </a:tc>
+                <a:extLst>
+                  <a:ext uri="{0D108BD9-81ED-4DB2-BD59-A6C34878D82A}">
+                    <a16:rowId xmlns:a16="http://schemas.microsoft.com/office/drawing/2014/main" val="10002"/>
+                  </a:ext>
+                </a:extLst>
               </a:tr>
               <a:tr h="429768">
                 <a:tc>
@@ -6207,7 +6348,7 @@
                       </a:r>
                     </a:p>
                   </a:txBody>
-                  <a:tcPr anchor="ctr" marL="73152" marR="73152">
+                  <a:tcPr marL="73152" marR="73152" anchor="ctr">
                     <a:solidFill>
                       <a:srgbClr val="FFFFFF"/>
                     </a:solidFill>
@@ -6230,12 +6371,17 @@
                       </a:r>
                     </a:p>
                   </a:txBody>
-                  <a:tcPr anchor="ctr" marL="73152" marR="73152">
+                  <a:tcPr marL="73152" marR="73152" anchor="ctr">
                     <a:solidFill>
                       <a:srgbClr val="FFFFFF"/>
                     </a:solidFill>
                   </a:tcPr>
                 </a:tc>
+                <a:extLst>
+                  <a:ext uri="{0D108BD9-81ED-4DB2-BD59-A6C34878D82A}">
+                    <a16:rowId xmlns:a16="http://schemas.microsoft.com/office/drawing/2014/main" val="10003"/>
+                  </a:ext>
+                </a:extLst>
               </a:tr>
               <a:tr h="429768">
                 <a:tc>
@@ -6255,7 +6401,7 @@
                       </a:r>
                     </a:p>
                   </a:txBody>
-                  <a:tcPr anchor="ctr" marL="73152" marR="73152">
+                  <a:tcPr marL="73152" marR="73152" anchor="ctr">
                     <a:solidFill>
                       <a:srgbClr val="ECECEC"/>
                     </a:solidFill>
@@ -6278,12 +6424,17 @@
                       </a:r>
                     </a:p>
                   </a:txBody>
-                  <a:tcPr anchor="ctr" marL="73152" marR="73152">
+                  <a:tcPr marL="73152" marR="73152" anchor="ctr">
                     <a:solidFill>
                       <a:srgbClr val="ECECEC"/>
                     </a:solidFill>
                   </a:tcPr>
                 </a:tc>
+                <a:extLst>
+                  <a:ext uri="{0D108BD9-81ED-4DB2-BD59-A6C34878D82A}">
+                    <a16:rowId xmlns:a16="http://schemas.microsoft.com/office/drawing/2014/main" val="10004"/>
+                  </a:ext>
+                </a:extLst>
               </a:tr>
             </a:tbl>
           </a:graphicData>
@@ -6377,7 +6528,7 @@
 </file>
 
 <file path=ppt/slides/slide15.xml><?xml version="1.0" encoding="utf-8"?>
-<p:sld xmlns:a="http://schemas.openxmlformats.org/drawingml/2006/main" xmlns:p="http://schemas.openxmlformats.org/presentationml/2006/main" xmlns:r="http://schemas.openxmlformats.org/officeDocument/2006/relationships">
+<p:sld xmlns:a="http://schemas.openxmlformats.org/drawingml/2006/main" xmlns:r="http://schemas.openxmlformats.org/officeDocument/2006/relationships" xmlns:p="http://schemas.openxmlformats.org/presentationml/2006/main">
   <p:cSld>
     <p:bg>
       <p:bgPr>
@@ -6393,7 +6544,14 @@
         <p:cNvGrpSpPr/>
         <p:nvPr/>
       </p:nvGrpSpPr>
-      <p:grpSpPr/>
+      <p:grpSpPr>
+        <a:xfrm>
+          <a:off x="0" y="0"/>
+          <a:ext cx="0" cy="0"/>
+          <a:chOff x="0" y="0"/>
+          <a:chExt cx="0" cy="0"/>
+        </a:xfrm>
+      </p:grpSpPr>
       <p:pic>
         <p:nvPicPr>
           <p:cNvPr id="2" name="Picture 1" descr="isuzu_logo_red.png"/>
@@ -6458,6 +6616,7 @@
           <a:lstStyle/>
           <a:p>
             <a:pPr algn="ctr"/>
+            <a:endParaRPr/>
           </a:p>
         </p:txBody>
       </p:sp>
@@ -6571,6 +6730,7 @@
           <a:lstStyle/>
           <a:p>
             <a:pPr algn="ctr"/>
+            <a:endParaRPr/>
           </a:p>
         </p:txBody>
       </p:sp>
@@ -6652,6 +6812,7 @@
           <a:lstStyle/>
           <a:p>
             <a:pPr algn="ctr"/>
+            <a:endParaRPr/>
           </a:p>
         </p:txBody>
       </p:sp>
@@ -6692,7 +6853,7 @@
           </a:fontRef>
         </p:style>
         <p:txBody>
-          <a:bodyPr rtlCol="0" anchor="ctr" lIns="0" rIns="0" tIns="0" bIns="0"/>
+          <a:bodyPr lIns="0" tIns="0" rIns="0" bIns="0" rtlCol="0" anchor="ctr"/>
           <a:lstStyle/>
           <a:p>
             <a:pPr algn="ctr"/>
@@ -6837,6 +6998,7 @@
           <a:lstStyle/>
           <a:p>
             <a:pPr algn="ctr"/>
+            <a:endParaRPr/>
           </a:p>
         </p:txBody>
       </p:sp>
@@ -6877,7 +7039,7 @@
           </a:fontRef>
         </p:style>
         <p:txBody>
-          <a:bodyPr rtlCol="0" anchor="ctr" lIns="0" rIns="0" tIns="0" bIns="0"/>
+          <a:bodyPr lIns="0" tIns="0" rIns="0" bIns="0" rtlCol="0" anchor="ctr"/>
           <a:lstStyle/>
           <a:p>
             <a:pPr algn="ctr"/>
@@ -7061,8 +7223,20 @@
                 <a:tableStyleId>{5C22544A-7EE6-4342-B048-85BDC9FD1C3A}</a:tableStyleId>
               </a:tblPr>
               <a:tblGrid>
-                <a:gridCol w="5029200"/>
-                <a:gridCol w="3566160"/>
+                <a:gridCol w="5029200">
+                  <a:extLst>
+                    <a:ext uri="{9D8B030D-6E8A-4147-A177-3AD203B41FA5}">
+                      <a16:colId xmlns:a16="http://schemas.microsoft.com/office/drawing/2014/main" val="20000"/>
+                    </a:ext>
+                  </a:extLst>
+                </a:gridCol>
+                <a:gridCol w="3566160">
+                  <a:extLst>
+                    <a:ext uri="{9D8B030D-6E8A-4147-A177-3AD203B41FA5}">
+                      <a16:colId xmlns:a16="http://schemas.microsoft.com/office/drawing/2014/main" val="20001"/>
+                    </a:ext>
+                  </a:extLst>
+                </a:gridCol>
               </a:tblGrid>
               <a:tr h="411480">
                 <a:tc>
@@ -7082,7 +7256,7 @@
                       </a:r>
                     </a:p>
                   </a:txBody>
-                  <a:tcPr anchor="ctr" marL="73152" marR="73152">
+                  <a:tcPr marL="73152" marR="73152" anchor="ctr">
                     <a:solidFill>
                       <a:srgbClr val="CC0E1E"/>
                     </a:solidFill>
@@ -7105,12 +7279,17 @@
                       </a:r>
                     </a:p>
                   </a:txBody>
-                  <a:tcPr anchor="ctr" marL="73152" marR="73152">
+                  <a:tcPr marL="73152" marR="73152" anchor="ctr">
                     <a:solidFill>
                       <a:srgbClr val="CC0E1E"/>
                     </a:solidFill>
                   </a:tcPr>
                 </a:tc>
+                <a:extLst>
+                  <a:ext uri="{0D108BD9-81ED-4DB2-BD59-A6C34878D82A}">
+                    <a16:rowId xmlns:a16="http://schemas.microsoft.com/office/drawing/2014/main" val="10000"/>
+                  </a:ext>
+                </a:extLst>
               </a:tr>
               <a:tr h="411480">
                 <a:tc>
@@ -7130,7 +7309,7 @@
                       </a:r>
                     </a:p>
                   </a:txBody>
-                  <a:tcPr anchor="ctr" marL="73152" marR="73152">
+                  <a:tcPr marL="73152" marR="73152" anchor="ctr">
                     <a:solidFill>
                       <a:srgbClr val="FFFFFF"/>
                     </a:solidFill>
@@ -7153,12 +7332,17 @@
                       </a:r>
                     </a:p>
                   </a:txBody>
-                  <a:tcPr anchor="ctr" marL="73152" marR="73152">
+                  <a:tcPr marL="73152" marR="73152" anchor="ctr">
                     <a:solidFill>
                       <a:srgbClr val="FFFFFF"/>
                     </a:solidFill>
                   </a:tcPr>
                 </a:tc>
+                <a:extLst>
+                  <a:ext uri="{0D108BD9-81ED-4DB2-BD59-A6C34878D82A}">
+                    <a16:rowId xmlns:a16="http://schemas.microsoft.com/office/drawing/2014/main" val="10001"/>
+                  </a:ext>
+                </a:extLst>
               </a:tr>
               <a:tr h="411480">
                 <a:tc>
@@ -7178,7 +7362,7 @@
                       </a:r>
                     </a:p>
                   </a:txBody>
-                  <a:tcPr anchor="ctr" marL="73152" marR="73152">
+                  <a:tcPr marL="73152" marR="73152" anchor="ctr">
                     <a:solidFill>
                       <a:srgbClr val="ECECEC"/>
                     </a:solidFill>
@@ -7201,12 +7385,17 @@
                       </a:r>
                     </a:p>
                   </a:txBody>
-                  <a:tcPr anchor="ctr" marL="73152" marR="73152">
+                  <a:tcPr marL="73152" marR="73152" anchor="ctr">
                     <a:solidFill>
                       <a:srgbClr val="ECECEC"/>
                     </a:solidFill>
                   </a:tcPr>
                 </a:tc>
+                <a:extLst>
+                  <a:ext uri="{0D108BD9-81ED-4DB2-BD59-A6C34878D82A}">
+                    <a16:rowId xmlns:a16="http://schemas.microsoft.com/office/drawing/2014/main" val="10002"/>
+                  </a:ext>
+                </a:extLst>
               </a:tr>
             </a:tbl>
           </a:graphicData>
@@ -7300,7 +7489,7 @@
 </file>
 
 <file path=ppt/slides/slide16.xml><?xml version="1.0" encoding="utf-8"?>
-<p:sld xmlns:a="http://schemas.openxmlformats.org/drawingml/2006/main" xmlns:p="http://schemas.openxmlformats.org/presentationml/2006/main" xmlns:r="http://schemas.openxmlformats.org/officeDocument/2006/relationships">
+<p:sld xmlns:a="http://schemas.openxmlformats.org/drawingml/2006/main" xmlns:r="http://schemas.openxmlformats.org/officeDocument/2006/relationships" xmlns:p="http://schemas.openxmlformats.org/presentationml/2006/main">
   <p:cSld>
     <p:bg>
       <p:bgPr>
@@ -7316,7 +7505,14 @@
         <p:cNvGrpSpPr/>
         <p:nvPr/>
       </p:nvGrpSpPr>
-      <p:grpSpPr/>
+      <p:grpSpPr>
+        <a:xfrm>
+          <a:off x="0" y="0"/>
+          <a:ext cx="0" cy="0"/>
+          <a:chOff x="0" y="0"/>
+          <a:chExt cx="0" cy="0"/>
+        </a:xfrm>
+      </p:grpSpPr>
       <p:pic>
         <p:nvPicPr>
           <p:cNvPr id="2" name="Picture 1" descr="isuzu_logo_red.png"/>
@@ -7381,6 +7577,7 @@
           <a:lstStyle/>
           <a:p>
             <a:pPr algn="ctr"/>
+            <a:endParaRPr/>
           </a:p>
         </p:txBody>
       </p:sp>
@@ -7494,6 +7691,7 @@
           <a:lstStyle/>
           <a:p>
             <a:pPr algn="ctr"/>
+            <a:endParaRPr/>
           </a:p>
         </p:txBody>
       </p:sp>
@@ -7575,6 +7773,7 @@
           <a:lstStyle/>
           <a:p>
             <a:pPr algn="ctr"/>
+            <a:endParaRPr/>
           </a:p>
         </p:txBody>
       </p:sp>
@@ -7615,7 +7814,7 @@
           </a:fontRef>
         </p:style>
         <p:txBody>
-          <a:bodyPr rtlCol="0" anchor="ctr" lIns="0" rIns="0" tIns="0" bIns="0"/>
+          <a:bodyPr lIns="0" tIns="0" rIns="0" bIns="0" rtlCol="0" anchor="ctr"/>
           <a:lstStyle/>
           <a:p>
             <a:pPr algn="ctr"/>
@@ -7760,6 +7959,7 @@
           <a:lstStyle/>
           <a:p>
             <a:pPr algn="ctr"/>
+            <a:endParaRPr/>
           </a:p>
         </p:txBody>
       </p:sp>
@@ -7800,7 +8000,7 @@
           </a:fontRef>
         </p:style>
         <p:txBody>
-          <a:bodyPr rtlCol="0" anchor="ctr" lIns="0" rIns="0" tIns="0" bIns="0"/>
+          <a:bodyPr lIns="0" tIns="0" rIns="0" bIns="0" rtlCol="0" anchor="ctr"/>
           <a:lstStyle/>
           <a:p>
             <a:pPr algn="ctr"/>
@@ -7945,6 +8145,7 @@
           <a:lstStyle/>
           <a:p>
             <a:pPr algn="ctr"/>
+            <a:endParaRPr/>
           </a:p>
         </p:txBody>
       </p:sp>
@@ -7985,7 +8186,7 @@
           </a:fontRef>
         </p:style>
         <p:txBody>
-          <a:bodyPr rtlCol="0" anchor="ctr" lIns="0" rIns="0" tIns="0" bIns="0"/>
+          <a:bodyPr lIns="0" tIns="0" rIns="0" bIns="0" rtlCol="0" anchor="ctr"/>
           <a:lstStyle/>
           <a:p>
             <a:pPr algn="ctr"/>
@@ -8130,6 +8331,7 @@
           <a:lstStyle/>
           <a:p>
             <a:pPr algn="ctr"/>
+            <a:endParaRPr/>
           </a:p>
         </p:txBody>
       </p:sp>
@@ -8170,7 +8372,7 @@
           </a:fontRef>
         </p:style>
         <p:txBody>
-          <a:bodyPr rtlCol="0" anchor="ctr" lIns="0" rIns="0" tIns="0" bIns="0"/>
+          <a:bodyPr lIns="0" tIns="0" rIns="0" bIns="0" rtlCol="0" anchor="ctr"/>
           <a:lstStyle/>
           <a:p>
             <a:pPr algn="ctr"/>
@@ -8316,7 +8518,7 @@
 </file>
 
 <file path=ppt/slides/slide17.xml><?xml version="1.0" encoding="utf-8"?>
-<p:sld xmlns:a="http://schemas.openxmlformats.org/drawingml/2006/main" xmlns:p="http://schemas.openxmlformats.org/presentationml/2006/main" xmlns:r="http://schemas.openxmlformats.org/officeDocument/2006/relationships">
+<p:sld xmlns:a="http://schemas.openxmlformats.org/drawingml/2006/main" xmlns:r="http://schemas.openxmlformats.org/officeDocument/2006/relationships" xmlns:p="http://schemas.openxmlformats.org/presentationml/2006/main">
   <p:cSld>
     <p:bg>
       <p:bgPr>
@@ -8332,7 +8534,14 @@
         <p:cNvGrpSpPr/>
         <p:nvPr/>
       </p:nvGrpSpPr>
-      <p:grpSpPr/>
+      <p:grpSpPr>
+        <a:xfrm>
+          <a:off x="0" y="0"/>
+          <a:ext cx="0" cy="0"/>
+          <a:chOff x="0" y="0"/>
+          <a:chExt cx="0" cy="0"/>
+        </a:xfrm>
+      </p:grpSpPr>
       <p:pic>
         <p:nvPicPr>
           <p:cNvPr id="2" name="Picture 1" descr="isuzu_logo_red.png"/>
@@ -8397,6 +8606,7 @@
           <a:lstStyle/>
           <a:p>
             <a:pPr algn="ctr"/>
+            <a:endParaRPr/>
           </a:p>
         </p:txBody>
       </p:sp>
@@ -8510,6 +8720,7 @@
           <a:lstStyle/>
           <a:p>
             <a:pPr algn="ctr"/>
+            <a:endParaRPr/>
           </a:p>
         </p:txBody>
       </p:sp>
@@ -8591,6 +8802,7 @@
           <a:lstStyle/>
           <a:p>
             <a:pPr algn="ctr"/>
+            <a:endParaRPr/>
           </a:p>
         </p:txBody>
       </p:sp>
@@ -8631,7 +8843,7 @@
           </a:fontRef>
         </p:style>
         <p:txBody>
-          <a:bodyPr rtlCol="0" anchor="ctr" lIns="0" rIns="0" tIns="0" bIns="0"/>
+          <a:bodyPr lIns="0" tIns="0" rIns="0" bIns="0" rtlCol="0" anchor="ctr"/>
           <a:lstStyle/>
           <a:p>
             <a:pPr algn="ctr"/>
@@ -8860,6 +9072,7 @@
           <a:lstStyle/>
           <a:p>
             <a:pPr algn="ctr"/>
+            <a:endParaRPr/>
           </a:p>
         </p:txBody>
       </p:sp>
@@ -8900,7 +9113,7 @@
           </a:fontRef>
         </p:style>
         <p:txBody>
-          <a:bodyPr rtlCol="0" anchor="ctr" lIns="0" rIns="0" tIns="0" bIns="0"/>
+          <a:bodyPr lIns="0" tIns="0" rIns="0" bIns="0" rtlCol="0" anchor="ctr"/>
           <a:lstStyle/>
           <a:p>
             <a:pPr algn="ctr"/>
@@ -9095,7 +9308,7 @@
 </file>
 
 <file path=ppt/slides/slide18.xml><?xml version="1.0" encoding="utf-8"?>
-<p:sld xmlns:a="http://schemas.openxmlformats.org/drawingml/2006/main" xmlns:p="http://schemas.openxmlformats.org/presentationml/2006/main" xmlns:r="http://schemas.openxmlformats.org/officeDocument/2006/relationships">
+<p:sld xmlns:a="http://schemas.openxmlformats.org/drawingml/2006/main" xmlns:r="http://schemas.openxmlformats.org/officeDocument/2006/relationships" xmlns:p="http://schemas.openxmlformats.org/presentationml/2006/main">
   <p:cSld>
     <p:bg>
       <p:bgPr>
@@ -9111,7 +9324,14 @@
         <p:cNvGrpSpPr/>
         <p:nvPr/>
       </p:nvGrpSpPr>
-      <p:grpSpPr/>
+      <p:grpSpPr>
+        <a:xfrm>
+          <a:off x="0" y="0"/>
+          <a:ext cx="0" cy="0"/>
+          <a:chOff x="0" y="0"/>
+          <a:chExt cx="0" cy="0"/>
+        </a:xfrm>
+      </p:grpSpPr>
       <p:pic>
         <p:nvPicPr>
           <p:cNvPr id="2" name="Picture 1" descr="isuzu_logo_red.png"/>
@@ -9176,6 +9396,7 @@
           <a:lstStyle/>
           <a:p>
             <a:pPr algn="ctr"/>
+            <a:endParaRPr/>
           </a:p>
         </p:txBody>
       </p:sp>
@@ -9289,6 +9510,7 @@
           <a:lstStyle/>
           <a:p>
             <a:pPr algn="ctr"/>
+            <a:endParaRPr/>
           </a:p>
         </p:txBody>
       </p:sp>
@@ -9370,6 +9592,7 @@
           <a:lstStyle/>
           <a:p>
             <a:pPr algn="ctr"/>
+            <a:endParaRPr/>
           </a:p>
         </p:txBody>
       </p:sp>
@@ -9410,7 +9633,7 @@
           </a:fontRef>
         </p:style>
         <p:txBody>
-          <a:bodyPr rtlCol="0" anchor="ctr" lIns="0" rIns="0" tIns="0" bIns="0"/>
+          <a:bodyPr lIns="0" tIns="0" rIns="0" bIns="0" rtlCol="0" anchor="ctr"/>
           <a:lstStyle/>
           <a:p>
             <a:pPr algn="ctr"/>
@@ -9555,6 +9778,7 @@
           <a:lstStyle/>
           <a:p>
             <a:pPr algn="ctr"/>
+            <a:endParaRPr/>
           </a:p>
         </p:txBody>
       </p:sp>
@@ -9595,7 +9819,7 @@
           </a:fontRef>
         </p:style>
         <p:txBody>
-          <a:bodyPr rtlCol="0" anchor="ctr" lIns="0" rIns="0" tIns="0" bIns="0"/>
+          <a:bodyPr lIns="0" tIns="0" rIns="0" bIns="0" rtlCol="0" anchor="ctr"/>
           <a:lstStyle/>
           <a:p>
             <a:pPr algn="ctr"/>
@@ -9740,6 +9964,7 @@
           <a:lstStyle/>
           <a:p>
             <a:pPr algn="ctr"/>
+            <a:endParaRPr/>
           </a:p>
         </p:txBody>
       </p:sp>
@@ -9780,7 +10005,7 @@
           </a:fontRef>
         </p:style>
         <p:txBody>
-          <a:bodyPr rtlCol="0" anchor="ctr" lIns="0" rIns="0" tIns="0" bIns="0"/>
+          <a:bodyPr lIns="0" tIns="0" rIns="0" bIns="0" rtlCol="0" anchor="ctr"/>
           <a:lstStyle/>
           <a:p>
             <a:pPr algn="ctr"/>
@@ -9926,7 +10151,7 @@
 </file>
 
 <file path=ppt/slides/slide19.xml><?xml version="1.0" encoding="utf-8"?>
-<p:sld xmlns:a="http://schemas.openxmlformats.org/drawingml/2006/main" xmlns:p="http://schemas.openxmlformats.org/presentationml/2006/main" xmlns:r="http://schemas.openxmlformats.org/officeDocument/2006/relationships">
+<p:sld xmlns:a="http://schemas.openxmlformats.org/drawingml/2006/main" xmlns:r="http://schemas.openxmlformats.org/officeDocument/2006/relationships" xmlns:p="http://schemas.openxmlformats.org/presentationml/2006/main">
   <p:cSld>
     <p:bg>
       <p:bgPr>
@@ -9942,7 +10167,14 @@
         <p:cNvGrpSpPr/>
         <p:nvPr/>
       </p:nvGrpSpPr>
-      <p:grpSpPr/>
+      <p:grpSpPr>
+        <a:xfrm>
+          <a:off x="0" y="0"/>
+          <a:ext cx="0" cy="0"/>
+          <a:chOff x="0" y="0"/>
+          <a:chExt cx="0" cy="0"/>
+        </a:xfrm>
+      </p:grpSpPr>
       <p:pic>
         <p:nvPicPr>
           <p:cNvPr id="2" name="Picture 1" descr="isuzu_logo_red.png"/>
@@ -10007,6 +10239,7 @@
           <a:lstStyle/>
           <a:p>
             <a:pPr algn="ctr"/>
+            <a:endParaRPr/>
           </a:p>
         </p:txBody>
       </p:sp>
@@ -10120,6 +10353,7 @@
           <a:lstStyle/>
           <a:p>
             <a:pPr algn="ctr"/>
+            <a:endParaRPr/>
           </a:p>
         </p:txBody>
       </p:sp>
@@ -10358,7 +10592,7 @@
 </file>
 
 <file path=ppt/slides/slide2.xml><?xml version="1.0" encoding="utf-8"?>
-<p:sld xmlns:a="http://schemas.openxmlformats.org/drawingml/2006/main" xmlns:p="http://schemas.openxmlformats.org/presentationml/2006/main" xmlns:r="http://schemas.openxmlformats.org/officeDocument/2006/relationships">
+<p:sld xmlns:a="http://schemas.openxmlformats.org/drawingml/2006/main" xmlns:r="http://schemas.openxmlformats.org/officeDocument/2006/relationships" xmlns:p="http://schemas.openxmlformats.org/presentationml/2006/main">
   <p:cSld>
     <p:bg>
       <p:bgPr>
@@ -10374,7 +10608,14 @@
         <p:cNvGrpSpPr/>
         <p:nvPr/>
       </p:nvGrpSpPr>
-      <p:grpSpPr/>
+      <p:grpSpPr>
+        <a:xfrm>
+          <a:off x="0" y="0"/>
+          <a:ext cx="0" cy="0"/>
+          <a:chOff x="0" y="0"/>
+          <a:chExt cx="0" cy="0"/>
+        </a:xfrm>
+      </p:grpSpPr>
       <p:pic>
         <p:nvPicPr>
           <p:cNvPr id="2" name="Picture 1" descr="isuzu_logo_red.png"/>
@@ -10439,6 +10680,7 @@
           <a:lstStyle/>
           <a:p>
             <a:pPr algn="ctr"/>
+            <a:endParaRPr/>
           </a:p>
         </p:txBody>
       </p:sp>
@@ -10552,6 +10794,7 @@
           <a:lstStyle/>
           <a:p>
             <a:pPr algn="ctr"/>
+            <a:endParaRPr/>
           </a:p>
         </p:txBody>
       </p:sp>
@@ -11042,7 +11285,7 @@
 </file>
 
 <file path=ppt/slides/slide20.xml><?xml version="1.0" encoding="utf-8"?>
-<p:sld xmlns:a="http://schemas.openxmlformats.org/drawingml/2006/main" xmlns:p="http://schemas.openxmlformats.org/presentationml/2006/main" xmlns:r="http://schemas.openxmlformats.org/officeDocument/2006/relationships">
+<p:sld xmlns:a="http://schemas.openxmlformats.org/drawingml/2006/main" xmlns:r="http://schemas.openxmlformats.org/officeDocument/2006/relationships" xmlns:p="http://schemas.openxmlformats.org/presentationml/2006/main">
   <p:cSld>
     <p:bg>
       <p:bgPr>
@@ -11058,7 +11301,14 @@
         <p:cNvGrpSpPr/>
         <p:nvPr/>
       </p:nvGrpSpPr>
-      <p:grpSpPr/>
+      <p:grpSpPr>
+        <a:xfrm>
+          <a:off x="0" y="0"/>
+          <a:ext cx="0" cy="0"/>
+          <a:chOff x="0" y="0"/>
+          <a:chExt cx="0" cy="0"/>
+        </a:xfrm>
+      </p:grpSpPr>
       <p:sp>
         <p:nvSpPr>
           <p:cNvPr id="2" name="Rectangle 1"/>
@@ -11099,6 +11349,7 @@
           <a:lstStyle/>
           <a:p>
             <a:pPr algn="ctr"/>
+            <a:endParaRPr/>
           </a:p>
         </p:txBody>
       </p:sp>
@@ -11170,7 +11421,7 @@
 </file>
 
 <file path=ppt/slides/slide21.xml><?xml version="1.0" encoding="utf-8"?>
-<p:sld xmlns:a="http://schemas.openxmlformats.org/drawingml/2006/main" xmlns:p="http://schemas.openxmlformats.org/presentationml/2006/main" xmlns:r="http://schemas.openxmlformats.org/officeDocument/2006/relationships">
+<p:sld xmlns:a="http://schemas.openxmlformats.org/drawingml/2006/main" xmlns:r="http://schemas.openxmlformats.org/officeDocument/2006/relationships" xmlns:p="http://schemas.openxmlformats.org/presentationml/2006/main">
   <p:cSld>
     <p:bg>
       <p:bgPr>
@@ -11186,7 +11437,14 @@
         <p:cNvGrpSpPr/>
         <p:nvPr/>
       </p:nvGrpSpPr>
-      <p:grpSpPr/>
+      <p:grpSpPr>
+        <a:xfrm>
+          <a:off x="0" y="0"/>
+          <a:ext cx="0" cy="0"/>
+          <a:chOff x="0" y="0"/>
+          <a:chExt cx="0" cy="0"/>
+        </a:xfrm>
+      </p:grpSpPr>
       <p:pic>
         <p:nvPicPr>
           <p:cNvPr id="2" name="Picture 1" descr="image.png"/>
@@ -11251,6 +11509,7 @@
           <a:lstStyle/>
           <a:p>
             <a:pPr algn="ctr"/>
+            <a:endParaRPr/>
           </a:p>
         </p:txBody>
       </p:sp>
@@ -11364,6 +11623,7 @@
           <a:lstStyle/>
           <a:p>
             <a:pPr algn="ctr"/>
+            <a:endParaRPr/>
           </a:p>
         </p:txBody>
       </p:sp>
@@ -11546,7 +11806,7 @@
 </file>
 
 <file path=ppt/slides/slide22.xml><?xml version="1.0" encoding="utf-8"?>
-<p:sld xmlns:a="http://schemas.openxmlformats.org/drawingml/2006/main" xmlns:p="http://schemas.openxmlformats.org/presentationml/2006/main" xmlns:r="http://schemas.openxmlformats.org/officeDocument/2006/relationships">
+<p:sld xmlns:a="http://schemas.openxmlformats.org/drawingml/2006/main" xmlns:r="http://schemas.openxmlformats.org/officeDocument/2006/relationships" xmlns:p="http://schemas.openxmlformats.org/presentationml/2006/main">
   <p:cSld>
     <p:bg>
       <p:bgPr>
@@ -11562,7 +11822,14 @@
         <p:cNvGrpSpPr/>
         <p:nvPr/>
       </p:nvGrpSpPr>
-      <p:grpSpPr/>
+      <p:grpSpPr>
+        <a:xfrm>
+          <a:off x="0" y="0"/>
+          <a:ext cx="0" cy="0"/>
+          <a:chOff x="0" y="0"/>
+          <a:chExt cx="0" cy="0"/>
+        </a:xfrm>
+      </p:grpSpPr>
       <p:pic>
         <p:nvPicPr>
           <p:cNvPr id="2" name="Picture 1" descr="image.png"/>
@@ -11627,6 +11894,7 @@
           <a:lstStyle/>
           <a:p>
             <a:pPr algn="ctr"/>
+            <a:endParaRPr/>
           </a:p>
         </p:txBody>
       </p:sp>
@@ -11740,6 +12008,7 @@
           <a:lstStyle/>
           <a:p>
             <a:pPr algn="ctr"/>
+            <a:endParaRPr/>
           </a:p>
         </p:txBody>
       </p:sp>
@@ -12034,7 +12303,7 @@
 </file>
 
 <file path=ppt/slides/slide23.xml><?xml version="1.0" encoding="utf-8"?>
-<p:sld xmlns:a="http://schemas.openxmlformats.org/drawingml/2006/main" xmlns:p="http://schemas.openxmlformats.org/presentationml/2006/main" xmlns:r="http://schemas.openxmlformats.org/officeDocument/2006/relationships">
+<p:sld xmlns:a="http://schemas.openxmlformats.org/drawingml/2006/main" xmlns:r="http://schemas.openxmlformats.org/officeDocument/2006/relationships" xmlns:p="http://schemas.openxmlformats.org/presentationml/2006/main">
   <p:cSld>
     <p:bg>
       <p:bgPr>
@@ -12050,7 +12319,14 @@
         <p:cNvGrpSpPr/>
         <p:nvPr/>
       </p:nvGrpSpPr>
-      <p:grpSpPr/>
+      <p:grpSpPr>
+        <a:xfrm>
+          <a:off x="0" y="0"/>
+          <a:ext cx="0" cy="0"/>
+          <a:chOff x="0" y="0"/>
+          <a:chExt cx="0" cy="0"/>
+        </a:xfrm>
+      </p:grpSpPr>
       <p:pic>
         <p:nvPicPr>
           <p:cNvPr id="2" name="Picture 1" descr="image.png"/>
@@ -12115,6 +12391,7 @@
           <a:lstStyle/>
           <a:p>
             <a:pPr algn="ctr"/>
+            <a:endParaRPr/>
           </a:p>
         </p:txBody>
       </p:sp>
@@ -12228,6 +12505,7 @@
           <a:lstStyle/>
           <a:p>
             <a:pPr algn="ctr"/>
+            <a:endParaRPr/>
           </a:p>
         </p:txBody>
       </p:sp>
@@ -12330,6 +12608,7 @@
           <a:lstStyle/>
           <a:p>
             <a:pPr algn="ctr"/>
+            <a:endParaRPr/>
           </a:p>
         </p:txBody>
       </p:sp>
@@ -12512,7 +12791,7 @@
 </file>
 
 <file path=ppt/slides/slide24.xml><?xml version="1.0" encoding="utf-8"?>
-<p:sld xmlns:a="http://schemas.openxmlformats.org/drawingml/2006/main" xmlns:p="http://schemas.openxmlformats.org/presentationml/2006/main" xmlns:r="http://schemas.openxmlformats.org/officeDocument/2006/relationships">
+<p:sld xmlns:a="http://schemas.openxmlformats.org/drawingml/2006/main" xmlns:r="http://schemas.openxmlformats.org/officeDocument/2006/relationships" xmlns:p="http://schemas.openxmlformats.org/presentationml/2006/main">
   <p:cSld>
     <p:bg>
       <p:bgPr>
@@ -12528,7 +12807,14 @@
         <p:cNvGrpSpPr/>
         <p:nvPr/>
       </p:nvGrpSpPr>
-      <p:grpSpPr/>
+      <p:grpSpPr>
+        <a:xfrm>
+          <a:off x="0" y="0"/>
+          <a:ext cx="0" cy="0"/>
+          <a:chOff x="0" y="0"/>
+          <a:chExt cx="0" cy="0"/>
+        </a:xfrm>
+      </p:grpSpPr>
       <p:pic>
         <p:nvPicPr>
           <p:cNvPr id="2" name="Picture 1" descr="image.png"/>
@@ -12593,6 +12879,7 @@
           <a:lstStyle/>
           <a:p>
             <a:pPr algn="ctr"/>
+            <a:endParaRPr/>
           </a:p>
         </p:txBody>
       </p:sp>
@@ -12706,6 +12993,7 @@
           <a:lstStyle/>
           <a:p>
             <a:pPr algn="ctr"/>
+            <a:endParaRPr/>
           </a:p>
         </p:txBody>
       </p:sp>
@@ -12912,7 +13200,7 @@
 </file>
 
 <file path=ppt/slides/slide25.xml><?xml version="1.0" encoding="utf-8"?>
-<p:sld xmlns:a="http://schemas.openxmlformats.org/drawingml/2006/main" xmlns:p="http://schemas.openxmlformats.org/presentationml/2006/main" xmlns:r="http://schemas.openxmlformats.org/officeDocument/2006/relationships">
+<p:sld xmlns:a="http://schemas.openxmlformats.org/drawingml/2006/main" xmlns:r="http://schemas.openxmlformats.org/officeDocument/2006/relationships" xmlns:p="http://schemas.openxmlformats.org/presentationml/2006/main">
   <p:cSld>
     <p:bg>
       <p:bgPr>
@@ -12928,7 +13216,14 @@
         <p:cNvGrpSpPr/>
         <p:nvPr/>
       </p:nvGrpSpPr>
-      <p:grpSpPr/>
+      <p:grpSpPr>
+        <a:xfrm>
+          <a:off x="0" y="0"/>
+          <a:ext cx="0" cy="0"/>
+          <a:chOff x="0" y="0"/>
+          <a:chExt cx="0" cy="0"/>
+        </a:xfrm>
+      </p:grpSpPr>
       <p:pic>
         <p:nvPicPr>
           <p:cNvPr id="2" name="Picture 1" descr="image.png"/>
@@ -12993,6 +13288,7 @@
           <a:lstStyle/>
           <a:p>
             <a:pPr algn="ctr"/>
+            <a:endParaRPr/>
           </a:p>
         </p:txBody>
       </p:sp>
@@ -13106,6 +13402,7 @@
           <a:lstStyle/>
           <a:p>
             <a:pPr algn="ctr"/>
+            <a:endParaRPr/>
           </a:p>
         </p:txBody>
       </p:sp>
@@ -13163,10 +13460,34 @@
                 <a:tableStyleId>{5C22544A-7EE6-4342-B048-85BDC9FD1C3A}</a:tableStyleId>
               </a:tblPr>
               <a:tblGrid>
-                <a:gridCol w="3657600"/>
-                <a:gridCol w="2468880"/>
-                <a:gridCol w="2468880"/>
-                <a:gridCol w="2834640"/>
+                <a:gridCol w="3657600">
+                  <a:extLst>
+                    <a:ext uri="{9D8B030D-6E8A-4147-A177-3AD203B41FA5}">
+                      <a16:colId xmlns:a16="http://schemas.microsoft.com/office/drawing/2014/main" val="20000"/>
+                    </a:ext>
+                  </a:extLst>
+                </a:gridCol>
+                <a:gridCol w="2468880">
+                  <a:extLst>
+                    <a:ext uri="{9D8B030D-6E8A-4147-A177-3AD203B41FA5}">
+                      <a16:colId xmlns:a16="http://schemas.microsoft.com/office/drawing/2014/main" val="20001"/>
+                    </a:ext>
+                  </a:extLst>
+                </a:gridCol>
+                <a:gridCol w="2468880">
+                  <a:extLst>
+                    <a:ext uri="{9D8B030D-6E8A-4147-A177-3AD203B41FA5}">
+                      <a16:colId xmlns:a16="http://schemas.microsoft.com/office/drawing/2014/main" val="20002"/>
+                    </a:ext>
+                  </a:extLst>
+                </a:gridCol>
+                <a:gridCol w="2834640">
+                  <a:extLst>
+                    <a:ext uri="{9D8B030D-6E8A-4147-A177-3AD203B41FA5}">
+                      <a16:colId xmlns:a16="http://schemas.microsoft.com/office/drawing/2014/main" val="20003"/>
+                    </a:ext>
+                  </a:extLst>
+                </a:gridCol>
               </a:tblGrid>
               <a:tr h="487680">
                 <a:tc>
@@ -13186,7 +13507,7 @@
                       </a:r>
                     </a:p>
                   </a:txBody>
-                  <a:tcPr anchor="ctr" marL="73152" marR="73152">
+                  <a:tcPr marL="73152" marR="73152" anchor="ctr">
                     <a:solidFill>
                       <a:srgbClr val="CC0E1E"/>
                     </a:solidFill>
@@ -13209,7 +13530,7 @@
                       </a:r>
                     </a:p>
                   </a:txBody>
-                  <a:tcPr anchor="ctr" marL="73152" marR="73152">
+                  <a:tcPr marL="73152" marR="73152" anchor="ctr">
                     <a:solidFill>
                       <a:srgbClr val="CC0E1E"/>
                     </a:solidFill>
@@ -13232,7 +13553,7 @@
                       </a:r>
                     </a:p>
                   </a:txBody>
-                  <a:tcPr anchor="ctr" marL="73152" marR="73152">
+                  <a:tcPr marL="73152" marR="73152" anchor="ctr">
                     <a:solidFill>
                       <a:srgbClr val="CC0E1E"/>
                     </a:solidFill>
@@ -13255,12 +13576,17 @@
                       </a:r>
                     </a:p>
                   </a:txBody>
-                  <a:tcPr anchor="ctr" marL="73152" marR="73152">
+                  <a:tcPr marL="73152" marR="73152" anchor="ctr">
                     <a:solidFill>
                       <a:srgbClr val="CC0E1E"/>
                     </a:solidFill>
                   </a:tcPr>
                 </a:tc>
+                <a:extLst>
+                  <a:ext uri="{0D108BD9-81ED-4DB2-BD59-A6C34878D82A}">
+                    <a16:rowId xmlns:a16="http://schemas.microsoft.com/office/drawing/2014/main" val="10000"/>
+                  </a:ext>
+                </a:extLst>
               </a:tr>
               <a:tr h="487680">
                 <a:tc>
@@ -13280,7 +13606,7 @@
                       </a:r>
                     </a:p>
                   </a:txBody>
-                  <a:tcPr anchor="ctr" marL="73152" marR="73152">
+                  <a:tcPr marL="73152" marR="73152" anchor="ctr">
                     <a:solidFill>
                       <a:srgbClr val="FFFFFF"/>
                     </a:solidFill>
@@ -13303,7 +13629,7 @@
                       </a:r>
                     </a:p>
                   </a:txBody>
-                  <a:tcPr anchor="ctr" marL="73152" marR="73152">
+                  <a:tcPr marL="73152" marR="73152" anchor="ctr">
                     <a:solidFill>
                       <a:srgbClr val="FFFFFF"/>
                     </a:solidFill>
@@ -13326,7 +13652,7 @@
                       </a:r>
                     </a:p>
                   </a:txBody>
-                  <a:tcPr anchor="ctr" marL="73152" marR="73152">
+                  <a:tcPr marL="73152" marR="73152" anchor="ctr">
                     <a:solidFill>
                       <a:srgbClr val="FFFFFF"/>
                     </a:solidFill>
@@ -13349,12 +13675,17 @@
                       </a:r>
                     </a:p>
                   </a:txBody>
-                  <a:tcPr anchor="ctr" marL="73152" marR="73152">
+                  <a:tcPr marL="73152" marR="73152" anchor="ctr">
                     <a:solidFill>
                       <a:srgbClr val="FFFFFF"/>
                     </a:solidFill>
                   </a:tcPr>
                 </a:tc>
+                <a:extLst>
+                  <a:ext uri="{0D108BD9-81ED-4DB2-BD59-A6C34878D82A}">
+                    <a16:rowId xmlns:a16="http://schemas.microsoft.com/office/drawing/2014/main" val="10001"/>
+                  </a:ext>
+                </a:extLst>
               </a:tr>
               <a:tr h="487680">
                 <a:tc>
@@ -13374,7 +13705,7 @@
                       </a:r>
                     </a:p>
                   </a:txBody>
-                  <a:tcPr anchor="ctr" marL="73152" marR="73152">
+                  <a:tcPr marL="73152" marR="73152" anchor="ctr">
                     <a:solidFill>
                       <a:srgbClr val="ECECEC"/>
                     </a:solidFill>
@@ -13397,7 +13728,7 @@
                       </a:r>
                     </a:p>
                   </a:txBody>
-                  <a:tcPr anchor="ctr" marL="73152" marR="73152">
+                  <a:tcPr marL="73152" marR="73152" anchor="ctr">
                     <a:solidFill>
                       <a:srgbClr val="ECECEC"/>
                     </a:solidFill>
@@ -13420,7 +13751,7 @@
                       </a:r>
                     </a:p>
                   </a:txBody>
-                  <a:tcPr anchor="ctr" marL="73152" marR="73152">
+                  <a:tcPr marL="73152" marR="73152" anchor="ctr">
                     <a:solidFill>
                       <a:srgbClr val="ECECEC"/>
                     </a:solidFill>
@@ -13443,12 +13774,17 @@
                       </a:r>
                     </a:p>
                   </a:txBody>
-                  <a:tcPr anchor="ctr" marL="73152" marR="73152">
+                  <a:tcPr marL="73152" marR="73152" anchor="ctr">
                     <a:solidFill>
                       <a:srgbClr val="ECECEC"/>
                     </a:solidFill>
                   </a:tcPr>
                 </a:tc>
+                <a:extLst>
+                  <a:ext uri="{0D108BD9-81ED-4DB2-BD59-A6C34878D82A}">
+                    <a16:rowId xmlns:a16="http://schemas.microsoft.com/office/drawing/2014/main" val="10002"/>
+                  </a:ext>
+                </a:extLst>
               </a:tr>
               <a:tr h="487680">
                 <a:tc>
@@ -13468,7 +13804,7 @@
                       </a:r>
                     </a:p>
                   </a:txBody>
-                  <a:tcPr anchor="ctr" marL="73152" marR="73152">
+                  <a:tcPr marL="73152" marR="73152" anchor="ctr">
                     <a:solidFill>
                       <a:srgbClr val="FFFFFF"/>
                     </a:solidFill>
@@ -13491,7 +13827,7 @@
                       </a:r>
                     </a:p>
                   </a:txBody>
-                  <a:tcPr anchor="ctr" marL="73152" marR="73152">
+                  <a:tcPr marL="73152" marR="73152" anchor="ctr">
                     <a:solidFill>
                       <a:srgbClr val="FFFFFF"/>
                     </a:solidFill>
@@ -13514,7 +13850,7 @@
                       </a:r>
                     </a:p>
                   </a:txBody>
-                  <a:tcPr anchor="ctr" marL="73152" marR="73152">
+                  <a:tcPr marL="73152" marR="73152" anchor="ctr">
                     <a:solidFill>
                       <a:srgbClr val="FFFFFF"/>
                     </a:solidFill>
@@ -13537,12 +13873,17 @@
                       </a:r>
                     </a:p>
                   </a:txBody>
-                  <a:tcPr anchor="ctr" marL="73152" marR="73152">
+                  <a:tcPr marL="73152" marR="73152" anchor="ctr">
                     <a:solidFill>
                       <a:srgbClr val="FFFFFF"/>
                     </a:solidFill>
                   </a:tcPr>
                 </a:tc>
+                <a:extLst>
+                  <a:ext uri="{0D108BD9-81ED-4DB2-BD59-A6C34878D82A}">
+                    <a16:rowId xmlns:a16="http://schemas.microsoft.com/office/drawing/2014/main" val="10003"/>
+                  </a:ext>
+                </a:extLst>
               </a:tr>
               <a:tr h="487680">
                 <a:tc>
@@ -13562,7 +13903,7 @@
                       </a:r>
                     </a:p>
                   </a:txBody>
-                  <a:tcPr anchor="ctr" marL="73152" marR="73152">
+                  <a:tcPr marL="73152" marR="73152" anchor="ctr">
                     <a:solidFill>
                       <a:srgbClr val="ECECEC"/>
                     </a:solidFill>
@@ -13585,7 +13926,7 @@
                       </a:r>
                     </a:p>
                   </a:txBody>
-                  <a:tcPr anchor="ctr" marL="73152" marR="73152">
+                  <a:tcPr marL="73152" marR="73152" anchor="ctr">
                     <a:solidFill>
                       <a:srgbClr val="ECECEC"/>
                     </a:solidFill>
@@ -13608,7 +13949,7 @@
                       </a:r>
                     </a:p>
                   </a:txBody>
-                  <a:tcPr anchor="ctr" marL="73152" marR="73152">
+                  <a:tcPr marL="73152" marR="73152" anchor="ctr">
                     <a:solidFill>
                       <a:srgbClr val="ECECEC"/>
                     </a:solidFill>
@@ -13631,12 +13972,17 @@
                       </a:r>
                     </a:p>
                   </a:txBody>
-                  <a:tcPr anchor="ctr" marL="73152" marR="73152">
+                  <a:tcPr marL="73152" marR="73152" anchor="ctr">
                     <a:solidFill>
                       <a:srgbClr val="ECECEC"/>
                     </a:solidFill>
                   </a:tcPr>
                 </a:tc>
+                <a:extLst>
+                  <a:ext uri="{0D108BD9-81ED-4DB2-BD59-A6C34878D82A}">
+                    <a16:rowId xmlns:a16="http://schemas.microsoft.com/office/drawing/2014/main" val="10004"/>
+                  </a:ext>
+                </a:extLst>
               </a:tr>
               <a:tr h="487680">
                 <a:tc>
@@ -13656,7 +14002,7 @@
                       </a:r>
                     </a:p>
                   </a:txBody>
-                  <a:tcPr anchor="ctr" marL="73152" marR="73152">
+                  <a:tcPr marL="73152" marR="73152" anchor="ctr">
                     <a:solidFill>
                       <a:srgbClr val="FFFFFF"/>
                     </a:solidFill>
@@ -13679,7 +14025,7 @@
                       </a:r>
                     </a:p>
                   </a:txBody>
-                  <a:tcPr anchor="ctr" marL="73152" marR="73152">
+                  <a:tcPr marL="73152" marR="73152" anchor="ctr">
                     <a:solidFill>
                       <a:srgbClr val="FFFFFF"/>
                     </a:solidFill>
@@ -13702,7 +14048,7 @@
                       </a:r>
                     </a:p>
                   </a:txBody>
-                  <a:tcPr anchor="ctr" marL="73152" marR="73152">
+                  <a:tcPr marL="73152" marR="73152" anchor="ctr">
                     <a:solidFill>
                       <a:srgbClr val="FFFFFF"/>
                     </a:solidFill>
@@ -13725,12 +14071,17 @@
                       </a:r>
                     </a:p>
                   </a:txBody>
-                  <a:tcPr anchor="ctr" marL="73152" marR="73152">
+                  <a:tcPr marL="73152" marR="73152" anchor="ctr">
                     <a:solidFill>
                       <a:srgbClr val="FFFFFF"/>
                     </a:solidFill>
                   </a:tcPr>
                 </a:tc>
+                <a:extLst>
+                  <a:ext uri="{0D108BD9-81ED-4DB2-BD59-A6C34878D82A}">
+                    <a16:rowId xmlns:a16="http://schemas.microsoft.com/office/drawing/2014/main" val="10005"/>
+                  </a:ext>
+                </a:extLst>
               </a:tr>
             </a:tbl>
           </a:graphicData>
@@ -13745,7 +14096,7 @@
 </file>
 
 <file path=ppt/slides/slide26.xml><?xml version="1.0" encoding="utf-8"?>
-<p:sld xmlns:a="http://schemas.openxmlformats.org/drawingml/2006/main" xmlns:p="http://schemas.openxmlformats.org/presentationml/2006/main" xmlns:r="http://schemas.openxmlformats.org/officeDocument/2006/relationships">
+<p:sld xmlns:a="http://schemas.openxmlformats.org/drawingml/2006/main" xmlns:r="http://schemas.openxmlformats.org/officeDocument/2006/relationships" xmlns:p="http://schemas.openxmlformats.org/presentationml/2006/main">
   <p:cSld>
     <p:bg>
       <p:bgPr>
@@ -13761,7 +14112,14 @@
         <p:cNvGrpSpPr/>
         <p:nvPr/>
       </p:nvGrpSpPr>
-      <p:grpSpPr/>
+      <p:grpSpPr>
+        <a:xfrm>
+          <a:off x="0" y="0"/>
+          <a:ext cx="0" cy="0"/>
+          <a:chOff x="0" y="0"/>
+          <a:chExt cx="0" cy="0"/>
+        </a:xfrm>
+      </p:grpSpPr>
       <p:pic>
         <p:nvPicPr>
           <p:cNvPr id="2" name="Picture 1" descr="image.png"/>
@@ -13826,6 +14184,7 @@
           <a:lstStyle/>
           <a:p>
             <a:pPr algn="ctr"/>
+            <a:endParaRPr/>
           </a:p>
         </p:txBody>
       </p:sp>
@@ -13939,6 +14298,7 @@
           <a:lstStyle/>
           <a:p>
             <a:pPr algn="ctr"/>
+            <a:endParaRPr/>
           </a:p>
         </p:txBody>
       </p:sp>
@@ -14121,7 +14481,7 @@
 </file>
 
 <file path=ppt/slides/slide27.xml><?xml version="1.0" encoding="utf-8"?>
-<p:sld xmlns:a="http://schemas.openxmlformats.org/drawingml/2006/main" xmlns:p="http://schemas.openxmlformats.org/presentationml/2006/main" xmlns:r="http://schemas.openxmlformats.org/officeDocument/2006/relationships">
+<p:sld xmlns:a="http://schemas.openxmlformats.org/drawingml/2006/main" xmlns:r="http://schemas.openxmlformats.org/officeDocument/2006/relationships" xmlns:p="http://schemas.openxmlformats.org/presentationml/2006/main">
   <p:cSld>
     <p:bg>
       <p:bgPr>
@@ -14137,7 +14497,14 @@
         <p:cNvGrpSpPr/>
         <p:nvPr/>
       </p:nvGrpSpPr>
-      <p:grpSpPr/>
+      <p:grpSpPr>
+        <a:xfrm>
+          <a:off x="0" y="0"/>
+          <a:ext cx="0" cy="0"/>
+          <a:chOff x="0" y="0"/>
+          <a:chExt cx="0" cy="0"/>
+        </a:xfrm>
+      </p:grpSpPr>
       <p:pic>
         <p:nvPicPr>
           <p:cNvPr id="2" name="Picture 1" descr="image.png"/>
@@ -14202,6 +14569,7 @@
           <a:lstStyle/>
           <a:p>
             <a:pPr algn="ctr"/>
+            <a:endParaRPr/>
           </a:p>
         </p:txBody>
       </p:sp>
@@ -14315,6 +14683,7 @@
           <a:lstStyle/>
           <a:p>
             <a:pPr algn="ctr"/>
+            <a:endParaRPr/>
           </a:p>
         </p:txBody>
       </p:sp>
@@ -14372,9 +14741,27 @@
                 <a:tableStyleId>{5C22544A-7EE6-4342-B048-85BDC9FD1C3A}</a:tableStyleId>
               </a:tblPr>
               <a:tblGrid>
-                <a:gridCol w="2926080"/>
-                <a:gridCol w="5486400"/>
-                <a:gridCol w="3017520"/>
+                <a:gridCol w="2926080">
+                  <a:extLst>
+                    <a:ext uri="{9D8B030D-6E8A-4147-A177-3AD203B41FA5}">
+                      <a16:colId xmlns:a16="http://schemas.microsoft.com/office/drawing/2014/main" val="20000"/>
+                    </a:ext>
+                  </a:extLst>
+                </a:gridCol>
+                <a:gridCol w="5486400">
+                  <a:extLst>
+                    <a:ext uri="{9D8B030D-6E8A-4147-A177-3AD203B41FA5}">
+                      <a16:colId xmlns:a16="http://schemas.microsoft.com/office/drawing/2014/main" val="20001"/>
+                    </a:ext>
+                  </a:extLst>
+                </a:gridCol>
+                <a:gridCol w="3017520">
+                  <a:extLst>
+                    <a:ext uri="{9D8B030D-6E8A-4147-A177-3AD203B41FA5}">
+                      <a16:colId xmlns:a16="http://schemas.microsoft.com/office/drawing/2014/main" val="20002"/>
+                    </a:ext>
+                  </a:extLst>
+                </a:gridCol>
               </a:tblGrid>
               <a:tr h="434340">
                 <a:tc>
@@ -14394,7 +14781,7 @@
                       </a:r>
                     </a:p>
                   </a:txBody>
-                  <a:tcPr anchor="ctr" marL="73152" marR="73152">
+                  <a:tcPr marL="73152" marR="73152" anchor="ctr">
                     <a:solidFill>
                       <a:srgbClr val="CC0E1E"/>
                     </a:solidFill>
@@ -14417,7 +14804,7 @@
                       </a:r>
                     </a:p>
                   </a:txBody>
-                  <a:tcPr anchor="ctr" marL="73152" marR="73152">
+                  <a:tcPr marL="73152" marR="73152" anchor="ctr">
                     <a:solidFill>
                       <a:srgbClr val="CC0E1E"/>
                     </a:solidFill>
@@ -14440,12 +14827,17 @@
                       </a:r>
                     </a:p>
                   </a:txBody>
-                  <a:tcPr anchor="ctr" marL="73152" marR="73152">
+                  <a:tcPr marL="73152" marR="73152" anchor="ctr">
                     <a:solidFill>
                       <a:srgbClr val="CC0E1E"/>
                     </a:solidFill>
                   </a:tcPr>
                 </a:tc>
+                <a:extLst>
+                  <a:ext uri="{0D108BD9-81ED-4DB2-BD59-A6C34878D82A}">
+                    <a16:rowId xmlns:a16="http://schemas.microsoft.com/office/drawing/2014/main" val="10000"/>
+                  </a:ext>
+                </a:extLst>
               </a:tr>
               <a:tr h="434340">
                 <a:tc>
@@ -14465,7 +14857,7 @@
                       </a:r>
                     </a:p>
                   </a:txBody>
-                  <a:tcPr anchor="ctr" marL="73152" marR="73152">
+                  <a:tcPr marL="73152" marR="73152" anchor="ctr">
                     <a:solidFill>
                       <a:srgbClr val="FFFFFF"/>
                     </a:solidFill>
@@ -14488,7 +14880,7 @@
                       </a:r>
                     </a:p>
                   </a:txBody>
-                  <a:tcPr anchor="ctr" marL="73152" marR="73152">
+                  <a:tcPr marL="73152" marR="73152" anchor="ctr">
                     <a:solidFill>
                       <a:srgbClr val="FFFFFF"/>
                     </a:solidFill>
@@ -14511,12 +14903,17 @@
                       </a:r>
                     </a:p>
                   </a:txBody>
-                  <a:tcPr anchor="ctr" marL="73152" marR="73152">
+                  <a:tcPr marL="73152" marR="73152" anchor="ctr">
                     <a:solidFill>
                       <a:srgbClr val="FFFFFF"/>
                     </a:solidFill>
                   </a:tcPr>
                 </a:tc>
+                <a:extLst>
+                  <a:ext uri="{0D108BD9-81ED-4DB2-BD59-A6C34878D82A}">
+                    <a16:rowId xmlns:a16="http://schemas.microsoft.com/office/drawing/2014/main" val="10001"/>
+                  </a:ext>
+                </a:extLst>
               </a:tr>
               <a:tr h="434340">
                 <a:tc>
@@ -14536,7 +14933,7 @@
                       </a:r>
                     </a:p>
                   </a:txBody>
-                  <a:tcPr anchor="ctr" marL="73152" marR="73152">
+                  <a:tcPr marL="73152" marR="73152" anchor="ctr">
                     <a:solidFill>
                       <a:srgbClr val="ECECEC"/>
                     </a:solidFill>
@@ -14559,7 +14956,7 @@
                       </a:r>
                     </a:p>
                   </a:txBody>
-                  <a:tcPr anchor="ctr" marL="73152" marR="73152">
+                  <a:tcPr marL="73152" marR="73152" anchor="ctr">
                     <a:solidFill>
                       <a:srgbClr val="ECECEC"/>
                     </a:solidFill>
@@ -14582,12 +14979,17 @@
                       </a:r>
                     </a:p>
                   </a:txBody>
-                  <a:tcPr anchor="ctr" marL="73152" marR="73152">
+                  <a:tcPr marL="73152" marR="73152" anchor="ctr">
                     <a:solidFill>
                       <a:srgbClr val="ECECEC"/>
                     </a:solidFill>
                   </a:tcPr>
                 </a:tc>
+                <a:extLst>
+                  <a:ext uri="{0D108BD9-81ED-4DB2-BD59-A6C34878D82A}">
+                    <a16:rowId xmlns:a16="http://schemas.microsoft.com/office/drawing/2014/main" val="10002"/>
+                  </a:ext>
+                </a:extLst>
               </a:tr>
               <a:tr h="434340">
                 <a:tc>
@@ -14607,7 +15009,7 @@
                       </a:r>
                     </a:p>
                   </a:txBody>
-                  <a:tcPr anchor="ctr" marL="73152" marR="73152">
+                  <a:tcPr marL="73152" marR="73152" anchor="ctr">
                     <a:solidFill>
                       <a:srgbClr val="FFFFFF"/>
                     </a:solidFill>
@@ -14630,7 +15032,7 @@
                       </a:r>
                     </a:p>
                   </a:txBody>
-                  <a:tcPr anchor="ctr" marL="73152" marR="73152">
+                  <a:tcPr marL="73152" marR="73152" anchor="ctr">
                     <a:solidFill>
                       <a:srgbClr val="FFFFFF"/>
                     </a:solidFill>
@@ -14653,12 +15055,17 @@
                       </a:r>
                     </a:p>
                   </a:txBody>
-                  <a:tcPr anchor="ctr" marL="73152" marR="73152">
+                  <a:tcPr marL="73152" marR="73152" anchor="ctr">
                     <a:solidFill>
                       <a:srgbClr val="FFFFFF"/>
                     </a:solidFill>
                   </a:tcPr>
                 </a:tc>
+                <a:extLst>
+                  <a:ext uri="{0D108BD9-81ED-4DB2-BD59-A6C34878D82A}">
+                    <a16:rowId xmlns:a16="http://schemas.microsoft.com/office/drawing/2014/main" val="10003"/>
+                  </a:ext>
+                </a:extLst>
               </a:tr>
               <a:tr h="434340">
                 <a:tc>
@@ -14678,7 +15085,7 @@
                       </a:r>
                     </a:p>
                   </a:txBody>
-                  <a:tcPr anchor="ctr" marL="73152" marR="73152">
+                  <a:tcPr marL="73152" marR="73152" anchor="ctr">
                     <a:solidFill>
                       <a:srgbClr val="ECECEC"/>
                     </a:solidFill>
@@ -14701,7 +15108,7 @@
                       </a:r>
                     </a:p>
                   </a:txBody>
-                  <a:tcPr anchor="ctr" marL="73152" marR="73152">
+                  <a:tcPr marL="73152" marR="73152" anchor="ctr">
                     <a:solidFill>
                       <a:srgbClr val="ECECEC"/>
                     </a:solidFill>
@@ -14724,12 +15131,17 @@
                       </a:r>
                     </a:p>
                   </a:txBody>
-                  <a:tcPr anchor="ctr" marL="73152" marR="73152">
+                  <a:tcPr marL="73152" marR="73152" anchor="ctr">
                     <a:solidFill>
                       <a:srgbClr val="ECECEC"/>
                     </a:solidFill>
                   </a:tcPr>
                 </a:tc>
+                <a:extLst>
+                  <a:ext uri="{0D108BD9-81ED-4DB2-BD59-A6C34878D82A}">
+                    <a16:rowId xmlns:a16="http://schemas.microsoft.com/office/drawing/2014/main" val="10004"/>
+                  </a:ext>
+                </a:extLst>
               </a:tr>
               <a:tr h="434340">
                 <a:tc>
@@ -14749,7 +15161,7 @@
                       </a:r>
                     </a:p>
                   </a:txBody>
-                  <a:tcPr anchor="ctr" marL="73152" marR="73152">
+                  <a:tcPr marL="73152" marR="73152" anchor="ctr">
                     <a:solidFill>
                       <a:srgbClr val="FFFFFF"/>
                     </a:solidFill>
@@ -14772,7 +15184,7 @@
                       </a:r>
                     </a:p>
                   </a:txBody>
-                  <a:tcPr anchor="ctr" marL="73152" marR="73152">
+                  <a:tcPr marL="73152" marR="73152" anchor="ctr">
                     <a:solidFill>
                       <a:srgbClr val="FFFFFF"/>
                     </a:solidFill>
@@ -14795,12 +15207,17 @@
                       </a:r>
                     </a:p>
                   </a:txBody>
-                  <a:tcPr anchor="ctr" marL="73152" marR="73152">
+                  <a:tcPr marL="73152" marR="73152" anchor="ctr">
                     <a:solidFill>
                       <a:srgbClr val="FFFFFF"/>
                     </a:solidFill>
                   </a:tcPr>
                 </a:tc>
+                <a:extLst>
+                  <a:ext uri="{0D108BD9-81ED-4DB2-BD59-A6C34878D82A}">
+                    <a16:rowId xmlns:a16="http://schemas.microsoft.com/office/drawing/2014/main" val="10005"/>
+                  </a:ext>
+                </a:extLst>
               </a:tr>
               <a:tr h="434340">
                 <a:tc>
@@ -14820,7 +15237,7 @@
                       </a:r>
                     </a:p>
                   </a:txBody>
-                  <a:tcPr anchor="ctr" marL="73152" marR="73152">
+                  <a:tcPr marL="73152" marR="73152" anchor="ctr">
                     <a:solidFill>
                       <a:srgbClr val="ECECEC"/>
                     </a:solidFill>
@@ -14843,7 +15260,7 @@
                       </a:r>
                     </a:p>
                   </a:txBody>
-                  <a:tcPr anchor="ctr" marL="73152" marR="73152">
+                  <a:tcPr marL="73152" marR="73152" anchor="ctr">
                     <a:solidFill>
                       <a:srgbClr val="ECECEC"/>
                     </a:solidFill>
@@ -14866,12 +15283,17 @@
                       </a:r>
                     </a:p>
                   </a:txBody>
-                  <a:tcPr anchor="ctr" marL="73152" marR="73152">
+                  <a:tcPr marL="73152" marR="73152" anchor="ctr">
                     <a:solidFill>
                       <a:srgbClr val="ECECEC"/>
                     </a:solidFill>
                   </a:tcPr>
                 </a:tc>
+                <a:extLst>
+                  <a:ext uri="{0D108BD9-81ED-4DB2-BD59-A6C34878D82A}">
+                    <a16:rowId xmlns:a16="http://schemas.microsoft.com/office/drawing/2014/main" val="10006"/>
+                  </a:ext>
+                </a:extLst>
               </a:tr>
               <a:tr h="434340">
                 <a:tc>
@@ -14891,7 +15313,7 @@
                       </a:r>
                     </a:p>
                   </a:txBody>
-                  <a:tcPr anchor="ctr" marL="73152" marR="73152">
+                  <a:tcPr marL="73152" marR="73152" anchor="ctr">
                     <a:solidFill>
                       <a:srgbClr val="FFFFFF"/>
                     </a:solidFill>
@@ -14914,7 +15336,7 @@
                       </a:r>
                     </a:p>
                   </a:txBody>
-                  <a:tcPr anchor="ctr" marL="73152" marR="73152">
+                  <a:tcPr marL="73152" marR="73152" anchor="ctr">
                     <a:solidFill>
                       <a:srgbClr val="FFFFFF"/>
                     </a:solidFill>
@@ -14937,12 +15359,17 @@
                       </a:r>
                     </a:p>
                   </a:txBody>
-                  <a:tcPr anchor="ctr" marL="73152" marR="73152">
+                  <a:tcPr marL="73152" marR="73152" anchor="ctr">
                     <a:solidFill>
                       <a:srgbClr val="FFFFFF"/>
                     </a:solidFill>
                   </a:tcPr>
                 </a:tc>
+                <a:extLst>
+                  <a:ext uri="{0D108BD9-81ED-4DB2-BD59-A6C34878D82A}">
+                    <a16:rowId xmlns:a16="http://schemas.microsoft.com/office/drawing/2014/main" val="10007"/>
+                  </a:ext>
+                </a:extLst>
               </a:tr>
             </a:tbl>
           </a:graphicData>
@@ -15008,7 +15435,7 @@
 </file>
 
 <file path=ppt/slides/slide28.xml><?xml version="1.0" encoding="utf-8"?>
-<p:sld xmlns:a="http://schemas.openxmlformats.org/drawingml/2006/main" xmlns:p="http://schemas.openxmlformats.org/presentationml/2006/main" xmlns:r="http://schemas.openxmlformats.org/officeDocument/2006/relationships">
+<p:sld xmlns:a="http://schemas.openxmlformats.org/drawingml/2006/main" xmlns:r="http://schemas.openxmlformats.org/officeDocument/2006/relationships" xmlns:p="http://schemas.openxmlformats.org/presentationml/2006/main">
   <p:cSld>
     <p:bg>
       <p:bgPr>
@@ -15024,7 +15451,14 @@
         <p:cNvGrpSpPr/>
         <p:nvPr/>
       </p:nvGrpSpPr>
-      <p:grpSpPr/>
+      <p:grpSpPr>
+        <a:xfrm>
+          <a:off x="0" y="0"/>
+          <a:ext cx="0" cy="0"/>
+          <a:chOff x="0" y="0"/>
+          <a:chExt cx="0" cy="0"/>
+        </a:xfrm>
+      </p:grpSpPr>
       <p:pic>
         <p:nvPicPr>
           <p:cNvPr id="2" name="Picture 1" descr="image.png"/>
@@ -15089,6 +15523,7 @@
           <a:lstStyle/>
           <a:p>
             <a:pPr algn="ctr"/>
+            <a:endParaRPr/>
           </a:p>
         </p:txBody>
       </p:sp>
@@ -15202,6 +15637,7 @@
           <a:lstStyle/>
           <a:p>
             <a:pPr algn="ctr"/>
+            <a:endParaRPr/>
           </a:p>
         </p:txBody>
       </p:sp>
@@ -15304,6 +15740,7 @@
           <a:lstStyle/>
           <a:p>
             <a:pPr algn="ctr"/>
+            <a:endParaRPr/>
           </a:p>
         </p:txBody>
       </p:sp>
@@ -15486,7 +15923,7 @@
 </file>
 
 <file path=ppt/slides/slide29.xml><?xml version="1.0" encoding="utf-8"?>
-<p:sld xmlns:a="http://schemas.openxmlformats.org/drawingml/2006/main" xmlns:p="http://schemas.openxmlformats.org/presentationml/2006/main" xmlns:r="http://schemas.openxmlformats.org/officeDocument/2006/relationships">
+<p:sld xmlns:a="http://schemas.openxmlformats.org/drawingml/2006/main" xmlns:r="http://schemas.openxmlformats.org/officeDocument/2006/relationships" xmlns:p="http://schemas.openxmlformats.org/presentationml/2006/main">
   <p:cSld>
     <p:bg>
       <p:bgPr>
@@ -15502,7 +15939,14 @@
         <p:cNvGrpSpPr/>
         <p:nvPr/>
       </p:nvGrpSpPr>
-      <p:grpSpPr/>
+      <p:grpSpPr>
+        <a:xfrm>
+          <a:off x="0" y="0"/>
+          <a:ext cx="0" cy="0"/>
+          <a:chOff x="0" y="0"/>
+          <a:chExt cx="0" cy="0"/>
+        </a:xfrm>
+      </p:grpSpPr>
       <p:pic>
         <p:nvPicPr>
           <p:cNvPr id="2" name="Picture 1" descr="image.png"/>
@@ -15567,6 +16011,7 @@
           <a:lstStyle/>
           <a:p>
             <a:pPr algn="ctr"/>
+            <a:endParaRPr/>
           </a:p>
         </p:txBody>
       </p:sp>
@@ -15680,6 +16125,7 @@
           <a:lstStyle/>
           <a:p>
             <a:pPr algn="ctr"/>
+            <a:endParaRPr/>
           </a:p>
         </p:txBody>
       </p:sp>
@@ -15782,6 +16228,7 @@
           <a:lstStyle/>
           <a:p>
             <a:pPr algn="ctr"/>
+            <a:endParaRPr/>
           </a:p>
         </p:txBody>
       </p:sp>
@@ -15936,7 +16383,7 @@
 </file>
 
 <file path=ppt/slides/slide3.xml><?xml version="1.0" encoding="utf-8"?>
-<p:sld xmlns:a="http://schemas.openxmlformats.org/drawingml/2006/main" xmlns:p="http://schemas.openxmlformats.org/presentationml/2006/main" xmlns:r="http://schemas.openxmlformats.org/officeDocument/2006/relationships">
+<p:sld xmlns:a="http://schemas.openxmlformats.org/drawingml/2006/main" xmlns:r="http://schemas.openxmlformats.org/officeDocument/2006/relationships" xmlns:p="http://schemas.openxmlformats.org/presentationml/2006/main">
   <p:cSld>
     <p:bg>
       <p:bgPr>
@@ -15952,7 +16399,14 @@
         <p:cNvGrpSpPr/>
         <p:nvPr/>
       </p:nvGrpSpPr>
-      <p:grpSpPr/>
+      <p:grpSpPr>
+        <a:xfrm>
+          <a:off x="0" y="0"/>
+          <a:ext cx="0" cy="0"/>
+          <a:chOff x="0" y="0"/>
+          <a:chExt cx="0" cy="0"/>
+        </a:xfrm>
+      </p:grpSpPr>
       <p:pic>
         <p:nvPicPr>
           <p:cNvPr id="2" name="Picture 1" descr="isuzu_logo_red.png"/>
@@ -16017,6 +16471,7 @@
           <a:lstStyle/>
           <a:p>
             <a:pPr algn="ctr"/>
+            <a:endParaRPr/>
           </a:p>
         </p:txBody>
       </p:sp>
@@ -16130,6 +16585,7 @@
           <a:lstStyle/>
           <a:p>
             <a:pPr algn="ctr"/>
+            <a:endParaRPr/>
           </a:p>
         </p:txBody>
       </p:sp>
@@ -16232,6 +16688,7 @@
           <a:lstStyle/>
           <a:p>
             <a:pPr algn="ctr"/>
+            <a:endParaRPr/>
           </a:p>
         </p:txBody>
       </p:sp>
@@ -16414,7 +16871,7 @@
 </file>
 
 <file path=ppt/slides/slide30.xml><?xml version="1.0" encoding="utf-8"?>
-<p:sld xmlns:a="http://schemas.openxmlformats.org/drawingml/2006/main" xmlns:p="http://schemas.openxmlformats.org/presentationml/2006/main" xmlns:r="http://schemas.openxmlformats.org/officeDocument/2006/relationships">
+<p:sld xmlns:a="http://schemas.openxmlformats.org/drawingml/2006/main" xmlns:r="http://schemas.openxmlformats.org/officeDocument/2006/relationships" xmlns:p="http://schemas.openxmlformats.org/presentationml/2006/main">
   <p:cSld>
     <p:bg>
       <p:bgPr>
@@ -16430,7 +16887,14 @@
         <p:cNvGrpSpPr/>
         <p:nvPr/>
       </p:nvGrpSpPr>
-      <p:grpSpPr/>
+      <p:grpSpPr>
+        <a:xfrm>
+          <a:off x="0" y="0"/>
+          <a:ext cx="0" cy="0"/>
+          <a:chOff x="0" y="0"/>
+          <a:chExt cx="0" cy="0"/>
+        </a:xfrm>
+      </p:grpSpPr>
       <p:pic>
         <p:nvPicPr>
           <p:cNvPr id="2" name="Picture 1" descr="image.png"/>
@@ -16495,6 +16959,7 @@
           <a:lstStyle/>
           <a:p>
             <a:pPr algn="ctr"/>
+            <a:endParaRPr/>
           </a:p>
         </p:txBody>
       </p:sp>
@@ -16608,6 +17073,7 @@
           <a:lstStyle/>
           <a:p>
             <a:pPr algn="ctr"/>
+            <a:endParaRPr/>
           </a:p>
         </p:txBody>
       </p:sp>
@@ -16665,9 +17131,27 @@
                 <a:tableStyleId>{5C22544A-7EE6-4342-B048-85BDC9FD1C3A}</a:tableStyleId>
               </a:tblPr>
               <a:tblGrid>
-                <a:gridCol w="3291840"/>
-                <a:gridCol w="1645920"/>
-                <a:gridCol w="1645920"/>
+                <a:gridCol w="3291840">
+                  <a:extLst>
+                    <a:ext uri="{9D8B030D-6E8A-4147-A177-3AD203B41FA5}">
+                      <a16:colId xmlns:a16="http://schemas.microsoft.com/office/drawing/2014/main" val="20000"/>
+                    </a:ext>
+                  </a:extLst>
+                </a:gridCol>
+                <a:gridCol w="1645920">
+                  <a:extLst>
+                    <a:ext uri="{9D8B030D-6E8A-4147-A177-3AD203B41FA5}">
+                      <a16:colId xmlns:a16="http://schemas.microsoft.com/office/drawing/2014/main" val="20001"/>
+                    </a:ext>
+                  </a:extLst>
+                </a:gridCol>
+                <a:gridCol w="1645920">
+                  <a:extLst>
+                    <a:ext uri="{9D8B030D-6E8A-4147-A177-3AD203B41FA5}">
+                      <a16:colId xmlns:a16="http://schemas.microsoft.com/office/drawing/2014/main" val="20002"/>
+                    </a:ext>
+                  </a:extLst>
+                </a:gridCol>
               </a:tblGrid>
               <a:tr h="548640">
                 <a:tc>
@@ -16687,7 +17171,7 @@
                       </a:r>
                     </a:p>
                   </a:txBody>
-                  <a:tcPr anchor="ctr" marL="73152" marR="73152">
+                  <a:tcPr marL="73152" marR="73152" anchor="ctr">
                     <a:solidFill>
                       <a:srgbClr val="CC0E1E"/>
                     </a:solidFill>
@@ -16710,7 +17194,7 @@
                       </a:r>
                     </a:p>
                   </a:txBody>
-                  <a:tcPr anchor="ctr" marL="73152" marR="73152">
+                  <a:tcPr marL="73152" marR="73152" anchor="ctr">
                     <a:solidFill>
                       <a:srgbClr val="CC0E1E"/>
                     </a:solidFill>
@@ -16733,12 +17217,17 @@
                       </a:r>
                     </a:p>
                   </a:txBody>
-                  <a:tcPr anchor="ctr" marL="73152" marR="73152">
+                  <a:tcPr marL="73152" marR="73152" anchor="ctr">
                     <a:solidFill>
                       <a:srgbClr val="CC0E1E"/>
                     </a:solidFill>
                   </a:tcPr>
                 </a:tc>
+                <a:extLst>
+                  <a:ext uri="{0D108BD9-81ED-4DB2-BD59-A6C34878D82A}">
+                    <a16:rowId xmlns:a16="http://schemas.microsoft.com/office/drawing/2014/main" val="10000"/>
+                  </a:ext>
+                </a:extLst>
               </a:tr>
               <a:tr h="548640">
                 <a:tc>
@@ -16758,7 +17247,7 @@
                       </a:r>
                     </a:p>
                   </a:txBody>
-                  <a:tcPr anchor="ctr" marL="73152" marR="73152">
+                  <a:tcPr marL="73152" marR="73152" anchor="ctr">
                     <a:solidFill>
                       <a:srgbClr val="FFFFFF"/>
                     </a:solidFill>
@@ -16781,7 +17270,7 @@
                       </a:r>
                     </a:p>
                   </a:txBody>
-                  <a:tcPr anchor="ctr" marL="73152" marR="73152">
+                  <a:tcPr marL="73152" marR="73152" anchor="ctr">
                     <a:solidFill>
                       <a:srgbClr val="FFFFFF"/>
                     </a:solidFill>
@@ -16804,12 +17293,17 @@
                       </a:r>
                     </a:p>
                   </a:txBody>
-                  <a:tcPr anchor="ctr" marL="73152" marR="73152">
+                  <a:tcPr marL="73152" marR="73152" anchor="ctr">
                     <a:solidFill>
                       <a:srgbClr val="FFFFFF"/>
                     </a:solidFill>
                   </a:tcPr>
                 </a:tc>
+                <a:extLst>
+                  <a:ext uri="{0D108BD9-81ED-4DB2-BD59-A6C34878D82A}">
+                    <a16:rowId xmlns:a16="http://schemas.microsoft.com/office/drawing/2014/main" val="10001"/>
+                  </a:ext>
+                </a:extLst>
               </a:tr>
               <a:tr h="548640">
                 <a:tc>
@@ -16829,7 +17323,7 @@
                       </a:r>
                     </a:p>
                   </a:txBody>
-                  <a:tcPr anchor="ctr" marL="73152" marR="73152">
+                  <a:tcPr marL="73152" marR="73152" anchor="ctr">
                     <a:solidFill>
                       <a:srgbClr val="ECECEC"/>
                     </a:solidFill>
@@ -16852,7 +17346,7 @@
                       </a:r>
                     </a:p>
                   </a:txBody>
-                  <a:tcPr anchor="ctr" marL="73152" marR="73152">
+                  <a:tcPr marL="73152" marR="73152" anchor="ctr">
                     <a:solidFill>
                       <a:srgbClr val="ECECEC"/>
                     </a:solidFill>
@@ -16875,12 +17369,17 @@
                       </a:r>
                     </a:p>
                   </a:txBody>
-                  <a:tcPr anchor="ctr" marL="73152" marR="73152">
+                  <a:tcPr marL="73152" marR="73152" anchor="ctr">
                     <a:solidFill>
                       <a:srgbClr val="ECECEC"/>
                     </a:solidFill>
                   </a:tcPr>
                 </a:tc>
+                <a:extLst>
+                  <a:ext uri="{0D108BD9-81ED-4DB2-BD59-A6C34878D82A}">
+                    <a16:rowId xmlns:a16="http://schemas.microsoft.com/office/drawing/2014/main" val="10002"/>
+                  </a:ext>
+                </a:extLst>
               </a:tr>
               <a:tr h="548640">
                 <a:tc>
@@ -16900,7 +17399,7 @@
                       </a:r>
                     </a:p>
                   </a:txBody>
-                  <a:tcPr anchor="ctr" marL="73152" marR="73152">
+                  <a:tcPr marL="73152" marR="73152" anchor="ctr">
                     <a:solidFill>
                       <a:srgbClr val="FFFFFF"/>
                     </a:solidFill>
@@ -16923,7 +17422,7 @@
                       </a:r>
                     </a:p>
                   </a:txBody>
-                  <a:tcPr anchor="ctr" marL="73152" marR="73152">
+                  <a:tcPr marL="73152" marR="73152" anchor="ctr">
                     <a:solidFill>
                       <a:srgbClr val="FFFFFF"/>
                     </a:solidFill>
@@ -16946,12 +17445,17 @@
                       </a:r>
                     </a:p>
                   </a:txBody>
-                  <a:tcPr anchor="ctr" marL="73152" marR="73152">
+                  <a:tcPr marL="73152" marR="73152" anchor="ctr">
                     <a:solidFill>
                       <a:srgbClr val="FFFFFF"/>
                     </a:solidFill>
                   </a:tcPr>
                 </a:tc>
+                <a:extLst>
+                  <a:ext uri="{0D108BD9-81ED-4DB2-BD59-A6C34878D82A}">
+                    <a16:rowId xmlns:a16="http://schemas.microsoft.com/office/drawing/2014/main" val="10003"/>
+                  </a:ext>
+                </a:extLst>
               </a:tr>
             </a:tbl>
           </a:graphicData>
@@ -17045,7 +17549,7 @@
 </file>
 
 <file path=ppt/slides/slide31.xml><?xml version="1.0" encoding="utf-8"?>
-<p:sld xmlns:a="http://schemas.openxmlformats.org/drawingml/2006/main" xmlns:p="http://schemas.openxmlformats.org/presentationml/2006/main" xmlns:r="http://schemas.openxmlformats.org/officeDocument/2006/relationships">
+<p:sld xmlns:a="http://schemas.openxmlformats.org/drawingml/2006/main" xmlns:r="http://schemas.openxmlformats.org/officeDocument/2006/relationships" xmlns:p="http://schemas.openxmlformats.org/presentationml/2006/main">
   <p:cSld>
     <p:bg>
       <p:bgPr>
@@ -17061,7 +17565,14 @@
         <p:cNvGrpSpPr/>
         <p:nvPr/>
       </p:nvGrpSpPr>
-      <p:grpSpPr/>
+      <p:grpSpPr>
+        <a:xfrm>
+          <a:off x="0" y="0"/>
+          <a:ext cx="0" cy="0"/>
+          <a:chOff x="0" y="0"/>
+          <a:chExt cx="0" cy="0"/>
+        </a:xfrm>
+      </p:grpSpPr>
       <p:pic>
         <p:nvPicPr>
           <p:cNvPr id="2" name="Picture 1" descr="image.png"/>
@@ -17126,6 +17637,7 @@
           <a:lstStyle/>
           <a:p>
             <a:pPr algn="ctr"/>
+            <a:endParaRPr/>
           </a:p>
         </p:txBody>
       </p:sp>
@@ -17239,6 +17751,7 @@
           <a:lstStyle/>
           <a:p>
             <a:pPr algn="ctr"/>
+            <a:endParaRPr/>
           </a:p>
         </p:txBody>
       </p:sp>
@@ -17296,10 +17809,34 @@
                 <a:tableStyleId>{5C22544A-7EE6-4342-B048-85BDC9FD1C3A}</a:tableStyleId>
               </a:tblPr>
               <a:tblGrid>
-                <a:gridCol w="1828800"/>
-                <a:gridCol w="2743200"/>
-                <a:gridCol w="2743200"/>
-                <a:gridCol w="4114800"/>
+                <a:gridCol w="1828800">
+                  <a:extLst>
+                    <a:ext uri="{9D8B030D-6E8A-4147-A177-3AD203B41FA5}">
+                      <a16:colId xmlns:a16="http://schemas.microsoft.com/office/drawing/2014/main" val="20000"/>
+                    </a:ext>
+                  </a:extLst>
+                </a:gridCol>
+                <a:gridCol w="2743200">
+                  <a:extLst>
+                    <a:ext uri="{9D8B030D-6E8A-4147-A177-3AD203B41FA5}">
+                      <a16:colId xmlns:a16="http://schemas.microsoft.com/office/drawing/2014/main" val="20001"/>
+                    </a:ext>
+                  </a:extLst>
+                </a:gridCol>
+                <a:gridCol w="2743200">
+                  <a:extLst>
+                    <a:ext uri="{9D8B030D-6E8A-4147-A177-3AD203B41FA5}">
+                      <a16:colId xmlns:a16="http://schemas.microsoft.com/office/drawing/2014/main" val="20002"/>
+                    </a:ext>
+                  </a:extLst>
+                </a:gridCol>
+                <a:gridCol w="4114800">
+                  <a:extLst>
+                    <a:ext uri="{9D8B030D-6E8A-4147-A177-3AD203B41FA5}">
+                      <a16:colId xmlns:a16="http://schemas.microsoft.com/office/drawing/2014/main" val="20003"/>
+                    </a:ext>
+                  </a:extLst>
+                </a:gridCol>
               </a:tblGrid>
               <a:tr h="548640">
                 <a:tc>
@@ -17319,7 +17856,7 @@
                       </a:r>
                     </a:p>
                   </a:txBody>
-                  <a:tcPr anchor="ctr" marL="73152" marR="73152">
+                  <a:tcPr marL="73152" marR="73152" anchor="ctr">
                     <a:solidFill>
                       <a:srgbClr val="CC0E1E"/>
                     </a:solidFill>
@@ -17342,7 +17879,7 @@
                       </a:r>
                     </a:p>
                   </a:txBody>
-                  <a:tcPr anchor="ctr" marL="73152" marR="73152">
+                  <a:tcPr marL="73152" marR="73152" anchor="ctr">
                     <a:solidFill>
                       <a:srgbClr val="CC0E1E"/>
                     </a:solidFill>
@@ -17365,7 +17902,7 @@
                       </a:r>
                     </a:p>
                   </a:txBody>
-                  <a:tcPr anchor="ctr" marL="73152" marR="73152">
+                  <a:tcPr marL="73152" marR="73152" anchor="ctr">
                     <a:solidFill>
                       <a:srgbClr val="CC0E1E"/>
                     </a:solidFill>
@@ -17388,12 +17925,17 @@
                       </a:r>
                     </a:p>
                   </a:txBody>
-                  <a:tcPr anchor="ctr" marL="73152" marR="73152">
+                  <a:tcPr marL="73152" marR="73152" anchor="ctr">
                     <a:solidFill>
                       <a:srgbClr val="CC0E1E"/>
                     </a:solidFill>
                   </a:tcPr>
                 </a:tc>
+                <a:extLst>
+                  <a:ext uri="{0D108BD9-81ED-4DB2-BD59-A6C34878D82A}">
+                    <a16:rowId xmlns:a16="http://schemas.microsoft.com/office/drawing/2014/main" val="10000"/>
+                  </a:ext>
+                </a:extLst>
               </a:tr>
               <a:tr h="548640">
                 <a:tc>
@@ -17413,7 +17955,7 @@
                       </a:r>
                     </a:p>
                   </a:txBody>
-                  <a:tcPr anchor="ctr" marL="73152" marR="73152">
+                  <a:tcPr marL="73152" marR="73152" anchor="ctr">
                     <a:solidFill>
                       <a:srgbClr val="FFFFFF"/>
                     </a:solidFill>
@@ -17436,7 +17978,7 @@
                       </a:r>
                     </a:p>
                   </a:txBody>
-                  <a:tcPr anchor="ctr" marL="73152" marR="73152">
+                  <a:tcPr marL="73152" marR="73152" anchor="ctr">
                     <a:solidFill>
                       <a:srgbClr val="FFFFFF"/>
                     </a:solidFill>
@@ -17459,7 +18001,7 @@
                       </a:r>
                     </a:p>
                   </a:txBody>
-                  <a:tcPr anchor="ctr" marL="73152" marR="73152">
+                  <a:tcPr marL="73152" marR="73152" anchor="ctr">
                     <a:solidFill>
                       <a:srgbClr val="FFFFFF"/>
                     </a:solidFill>
@@ -17482,12 +18024,17 @@
                       </a:r>
                     </a:p>
                   </a:txBody>
-                  <a:tcPr anchor="ctr" marL="73152" marR="73152">
+                  <a:tcPr marL="73152" marR="73152" anchor="ctr">
                     <a:solidFill>
                       <a:srgbClr val="FFFFFF"/>
                     </a:solidFill>
                   </a:tcPr>
                 </a:tc>
+                <a:extLst>
+                  <a:ext uri="{0D108BD9-81ED-4DB2-BD59-A6C34878D82A}">
+                    <a16:rowId xmlns:a16="http://schemas.microsoft.com/office/drawing/2014/main" val="10001"/>
+                  </a:ext>
+                </a:extLst>
               </a:tr>
               <a:tr h="548640">
                 <a:tc>
@@ -17507,7 +18054,7 @@
                       </a:r>
                     </a:p>
                   </a:txBody>
-                  <a:tcPr anchor="ctr" marL="73152" marR="73152">
+                  <a:tcPr marL="73152" marR="73152" anchor="ctr">
                     <a:solidFill>
                       <a:srgbClr val="ECECEC"/>
                     </a:solidFill>
@@ -17530,7 +18077,7 @@
                       </a:r>
                     </a:p>
                   </a:txBody>
-                  <a:tcPr anchor="ctr" marL="73152" marR="73152">
+                  <a:tcPr marL="73152" marR="73152" anchor="ctr">
                     <a:solidFill>
                       <a:srgbClr val="ECECEC"/>
                     </a:solidFill>
@@ -17553,7 +18100,7 @@
                       </a:r>
                     </a:p>
                   </a:txBody>
-                  <a:tcPr anchor="ctr" marL="73152" marR="73152">
+                  <a:tcPr marL="73152" marR="73152" anchor="ctr">
                     <a:solidFill>
                       <a:srgbClr val="ECECEC"/>
                     </a:solidFill>
@@ -17576,12 +18123,17 @@
                       </a:r>
                     </a:p>
                   </a:txBody>
-                  <a:tcPr anchor="ctr" marL="73152" marR="73152">
+                  <a:tcPr marL="73152" marR="73152" anchor="ctr">
                     <a:solidFill>
                       <a:srgbClr val="ECECEC"/>
                     </a:solidFill>
                   </a:tcPr>
                 </a:tc>
+                <a:extLst>
+                  <a:ext uri="{0D108BD9-81ED-4DB2-BD59-A6C34878D82A}">
+                    <a16:rowId xmlns:a16="http://schemas.microsoft.com/office/drawing/2014/main" val="10002"/>
+                  </a:ext>
+                </a:extLst>
               </a:tr>
               <a:tr h="548640">
                 <a:tc>
@@ -17601,7 +18153,7 @@
                       </a:r>
                     </a:p>
                   </a:txBody>
-                  <a:tcPr anchor="ctr" marL="73152" marR="73152">
+                  <a:tcPr marL="73152" marR="73152" anchor="ctr">
                     <a:solidFill>
                       <a:srgbClr val="FFFFFF"/>
                     </a:solidFill>
@@ -17624,7 +18176,7 @@
                       </a:r>
                     </a:p>
                   </a:txBody>
-                  <a:tcPr anchor="ctr" marL="73152" marR="73152">
+                  <a:tcPr marL="73152" marR="73152" anchor="ctr">
                     <a:solidFill>
                       <a:srgbClr val="FFFFFF"/>
                     </a:solidFill>
@@ -17647,7 +18199,7 @@
                       </a:r>
                     </a:p>
                   </a:txBody>
-                  <a:tcPr anchor="ctr" marL="73152" marR="73152">
+                  <a:tcPr marL="73152" marR="73152" anchor="ctr">
                     <a:solidFill>
                       <a:srgbClr val="FFFFFF"/>
                     </a:solidFill>
@@ -17670,12 +18222,17 @@
                       </a:r>
                     </a:p>
                   </a:txBody>
-                  <a:tcPr anchor="ctr" marL="73152" marR="73152">
+                  <a:tcPr marL="73152" marR="73152" anchor="ctr">
                     <a:solidFill>
                       <a:srgbClr val="FFFFFF"/>
                     </a:solidFill>
                   </a:tcPr>
                 </a:tc>
+                <a:extLst>
+                  <a:ext uri="{0D108BD9-81ED-4DB2-BD59-A6C34878D82A}">
+                    <a16:rowId xmlns:a16="http://schemas.microsoft.com/office/drawing/2014/main" val="10003"/>
+                  </a:ext>
+                </a:extLst>
               </a:tr>
             </a:tbl>
           </a:graphicData>
@@ -17769,7 +18326,7 @@
 </file>
 
 <file path=ppt/slides/slide32.xml><?xml version="1.0" encoding="utf-8"?>
-<p:sld xmlns:a="http://schemas.openxmlformats.org/drawingml/2006/main" xmlns:p="http://schemas.openxmlformats.org/presentationml/2006/main" xmlns:r="http://schemas.openxmlformats.org/officeDocument/2006/relationships">
+<p:sld xmlns:a="http://schemas.openxmlformats.org/drawingml/2006/main" xmlns:r="http://schemas.openxmlformats.org/officeDocument/2006/relationships" xmlns:p="http://schemas.openxmlformats.org/presentationml/2006/main">
   <p:cSld>
     <p:bg>
       <p:bgPr>
@@ -17785,7 +18342,14 @@
         <p:cNvGrpSpPr/>
         <p:nvPr/>
       </p:nvGrpSpPr>
-      <p:grpSpPr/>
+      <p:grpSpPr>
+        <a:xfrm>
+          <a:off x="0" y="0"/>
+          <a:ext cx="0" cy="0"/>
+          <a:chOff x="0" y="0"/>
+          <a:chExt cx="0" cy="0"/>
+        </a:xfrm>
+      </p:grpSpPr>
       <p:pic>
         <p:nvPicPr>
           <p:cNvPr id="2" name="Picture 1" descr="image.png"/>
@@ -17850,6 +18414,7 @@
           <a:lstStyle/>
           <a:p>
             <a:pPr algn="ctr"/>
+            <a:endParaRPr/>
           </a:p>
         </p:txBody>
       </p:sp>
@@ -17963,6 +18528,7 @@
           <a:lstStyle/>
           <a:p>
             <a:pPr algn="ctr"/>
+            <a:endParaRPr/>
           </a:p>
         </p:txBody>
       </p:sp>
@@ -18044,6 +18610,7 @@
           <a:lstStyle/>
           <a:p>
             <a:pPr algn="ctr"/>
+            <a:endParaRPr/>
           </a:p>
         </p:txBody>
       </p:sp>
@@ -18084,7 +18651,7 @@
           </a:fontRef>
         </p:style>
         <p:txBody>
-          <a:bodyPr rtlCol="0" anchor="ctr" lIns="0" rIns="0" tIns="0" bIns="0"/>
+          <a:bodyPr lIns="0" tIns="0" rIns="0" bIns="0" rtlCol="0" anchor="ctr"/>
           <a:lstStyle/>
           <a:p>
             <a:pPr algn="ctr"/>
@@ -18285,6 +18852,7 @@
           <a:lstStyle/>
           <a:p>
             <a:pPr algn="ctr"/>
+            <a:endParaRPr/>
           </a:p>
         </p:txBody>
       </p:sp>
@@ -18325,7 +18893,7 @@
           </a:fontRef>
         </p:style>
         <p:txBody>
-          <a:bodyPr rtlCol="0" anchor="ctr" lIns="0" rIns="0" tIns="0" bIns="0"/>
+          <a:bodyPr lIns="0" tIns="0" rIns="0" bIns="0" rtlCol="0" anchor="ctr"/>
           <a:lstStyle/>
           <a:p>
             <a:pPr algn="ctr"/>
@@ -18543,7 +19111,7 @@
 </file>
 
 <file path=ppt/slides/slide33.xml><?xml version="1.0" encoding="utf-8"?>
-<p:sld xmlns:a="http://schemas.openxmlformats.org/drawingml/2006/main" xmlns:p="http://schemas.openxmlformats.org/presentationml/2006/main" xmlns:r="http://schemas.openxmlformats.org/officeDocument/2006/relationships">
+<p:sld xmlns:a="http://schemas.openxmlformats.org/drawingml/2006/main" xmlns:r="http://schemas.openxmlformats.org/officeDocument/2006/relationships" xmlns:p="http://schemas.openxmlformats.org/presentationml/2006/main">
   <p:cSld>
     <p:bg>
       <p:bgPr>
@@ -18559,7 +19127,14 @@
         <p:cNvGrpSpPr/>
         <p:nvPr/>
       </p:nvGrpSpPr>
-      <p:grpSpPr/>
+      <p:grpSpPr>
+        <a:xfrm>
+          <a:off x="0" y="0"/>
+          <a:ext cx="0" cy="0"/>
+          <a:chOff x="0" y="0"/>
+          <a:chExt cx="0" cy="0"/>
+        </a:xfrm>
+      </p:grpSpPr>
       <p:pic>
         <p:nvPicPr>
           <p:cNvPr id="2" name="Picture 1" descr="image.png"/>
@@ -18624,6 +19199,7 @@
           <a:lstStyle/>
           <a:p>
             <a:pPr algn="ctr"/>
+            <a:endParaRPr/>
           </a:p>
         </p:txBody>
       </p:sp>
@@ -18737,6 +19313,7 @@
           <a:lstStyle/>
           <a:p>
             <a:pPr algn="ctr"/>
+            <a:endParaRPr/>
           </a:p>
         </p:txBody>
       </p:sp>
@@ -18794,8 +19371,20 @@
                 <a:tableStyleId>{5C22544A-7EE6-4342-B048-85BDC9FD1C3A}</a:tableStyleId>
               </a:tblPr>
               <a:tblGrid>
-                <a:gridCol w="3840480"/>
-                <a:gridCol w="7589520"/>
+                <a:gridCol w="3840480">
+                  <a:extLst>
+                    <a:ext uri="{9D8B030D-6E8A-4147-A177-3AD203B41FA5}">
+                      <a16:colId xmlns:a16="http://schemas.microsoft.com/office/drawing/2014/main" val="20000"/>
+                    </a:ext>
+                  </a:extLst>
+                </a:gridCol>
+                <a:gridCol w="7589520">
+                  <a:extLst>
+                    <a:ext uri="{9D8B030D-6E8A-4147-A177-3AD203B41FA5}">
+                      <a16:colId xmlns:a16="http://schemas.microsoft.com/office/drawing/2014/main" val="20001"/>
+                    </a:ext>
+                  </a:extLst>
+                </a:gridCol>
               </a:tblGrid>
               <a:tr h="960120">
                 <a:tc>
@@ -18815,7 +19404,7 @@
                       </a:r>
                     </a:p>
                   </a:txBody>
-                  <a:tcPr anchor="ctr" marL="73152" marR="73152">
+                  <a:tcPr marL="73152" marR="73152" anchor="ctr">
                     <a:solidFill>
                       <a:srgbClr val="CC0E1E"/>
                     </a:solidFill>
@@ -18838,12 +19427,17 @@
                       </a:r>
                     </a:p>
                   </a:txBody>
-                  <a:tcPr anchor="ctr" marL="73152" marR="73152">
+                  <a:tcPr marL="73152" marR="73152" anchor="ctr">
                     <a:solidFill>
                       <a:srgbClr val="CC0E1E"/>
                     </a:solidFill>
                   </a:tcPr>
                 </a:tc>
+                <a:extLst>
+                  <a:ext uri="{0D108BD9-81ED-4DB2-BD59-A6C34878D82A}">
+                    <a16:rowId xmlns:a16="http://schemas.microsoft.com/office/drawing/2014/main" val="10000"/>
+                  </a:ext>
+                </a:extLst>
               </a:tr>
               <a:tr h="960120">
                 <a:tc>
@@ -18863,7 +19457,7 @@
                       </a:r>
                     </a:p>
                   </a:txBody>
-                  <a:tcPr anchor="ctr" marL="73152" marR="73152">
+                  <a:tcPr marL="73152" marR="73152" anchor="ctr">
                     <a:solidFill>
                       <a:srgbClr val="FFFFFF"/>
                     </a:solidFill>
@@ -18886,12 +19480,17 @@
                       </a:r>
                     </a:p>
                   </a:txBody>
-                  <a:tcPr anchor="ctr" marL="73152" marR="73152">
+                  <a:tcPr marL="73152" marR="73152" anchor="ctr">
                     <a:solidFill>
                       <a:srgbClr val="FFFFFF"/>
                     </a:solidFill>
                   </a:tcPr>
                 </a:tc>
+                <a:extLst>
+                  <a:ext uri="{0D108BD9-81ED-4DB2-BD59-A6C34878D82A}">
+                    <a16:rowId xmlns:a16="http://schemas.microsoft.com/office/drawing/2014/main" val="10001"/>
+                  </a:ext>
+                </a:extLst>
               </a:tr>
               <a:tr h="960120">
                 <a:tc>
@@ -18911,7 +19510,7 @@
                       </a:r>
                     </a:p>
                   </a:txBody>
-                  <a:tcPr anchor="ctr" marL="73152" marR="73152">
+                  <a:tcPr marL="73152" marR="73152" anchor="ctr">
                     <a:solidFill>
                       <a:srgbClr val="ECECEC"/>
                     </a:solidFill>
@@ -18934,12 +19533,17 @@
                       </a:r>
                     </a:p>
                   </a:txBody>
-                  <a:tcPr anchor="ctr" marL="73152" marR="73152">
+                  <a:tcPr marL="73152" marR="73152" anchor="ctr">
                     <a:solidFill>
                       <a:srgbClr val="ECECEC"/>
                     </a:solidFill>
                   </a:tcPr>
                 </a:tc>
+                <a:extLst>
+                  <a:ext uri="{0D108BD9-81ED-4DB2-BD59-A6C34878D82A}">
+                    <a16:rowId xmlns:a16="http://schemas.microsoft.com/office/drawing/2014/main" val="10002"/>
+                  </a:ext>
+                </a:extLst>
               </a:tr>
               <a:tr h="960120">
                 <a:tc>
@@ -18959,7 +19563,7 @@
                       </a:r>
                     </a:p>
                   </a:txBody>
-                  <a:tcPr anchor="ctr" marL="73152" marR="73152">
+                  <a:tcPr marL="73152" marR="73152" anchor="ctr">
                     <a:solidFill>
                       <a:srgbClr val="FFFFFF"/>
                     </a:solidFill>
@@ -18982,12 +19586,17 @@
                       </a:r>
                     </a:p>
                   </a:txBody>
-                  <a:tcPr anchor="ctr" marL="73152" marR="73152">
+                  <a:tcPr marL="73152" marR="73152" anchor="ctr">
                     <a:solidFill>
                       <a:srgbClr val="FFFFFF"/>
                     </a:solidFill>
                   </a:tcPr>
                 </a:tc>
+                <a:extLst>
+                  <a:ext uri="{0D108BD9-81ED-4DB2-BD59-A6C34878D82A}">
+                    <a16:rowId xmlns:a16="http://schemas.microsoft.com/office/drawing/2014/main" val="10003"/>
+                  </a:ext>
+                </a:extLst>
               </a:tr>
             </a:tbl>
           </a:graphicData>
@@ -19002,7 +19611,7 @@
 </file>
 
 <file path=ppt/slides/slide34.xml><?xml version="1.0" encoding="utf-8"?>
-<p:sld xmlns:a="http://schemas.openxmlformats.org/drawingml/2006/main" xmlns:p="http://schemas.openxmlformats.org/presentationml/2006/main" xmlns:r="http://schemas.openxmlformats.org/officeDocument/2006/relationships">
+<p:sld xmlns:a="http://schemas.openxmlformats.org/drawingml/2006/main" xmlns:r="http://schemas.openxmlformats.org/officeDocument/2006/relationships" xmlns:p="http://schemas.openxmlformats.org/presentationml/2006/main">
   <p:cSld>
     <p:bg>
       <p:bgPr>
@@ -19018,7 +19627,14 @@
         <p:cNvGrpSpPr/>
         <p:nvPr/>
       </p:nvGrpSpPr>
-      <p:grpSpPr/>
+      <p:grpSpPr>
+        <a:xfrm>
+          <a:off x="0" y="0"/>
+          <a:ext cx="0" cy="0"/>
+          <a:chOff x="0" y="0"/>
+          <a:chExt cx="0" cy="0"/>
+        </a:xfrm>
+      </p:grpSpPr>
       <p:sp>
         <p:nvSpPr>
           <p:cNvPr id="2" name="Rectangle 1"/>
@@ -19059,6 +19675,7 @@
           <a:lstStyle/>
           <a:p>
             <a:pPr algn="ctr"/>
+            <a:endParaRPr/>
           </a:p>
         </p:txBody>
       </p:sp>
@@ -19130,7 +19747,7 @@
 </file>
 
 <file path=ppt/slides/slide4.xml><?xml version="1.0" encoding="utf-8"?>
-<p:sld xmlns:a="http://schemas.openxmlformats.org/drawingml/2006/main" xmlns:p="http://schemas.openxmlformats.org/presentationml/2006/main" xmlns:r="http://schemas.openxmlformats.org/officeDocument/2006/relationships">
+<p:sld xmlns:a="http://schemas.openxmlformats.org/drawingml/2006/main" xmlns:r="http://schemas.openxmlformats.org/officeDocument/2006/relationships" xmlns:p="http://schemas.openxmlformats.org/presentationml/2006/main">
   <p:cSld>
     <p:bg>
       <p:bgPr>
@@ -19146,7 +19763,14 @@
         <p:cNvGrpSpPr/>
         <p:nvPr/>
       </p:nvGrpSpPr>
-      <p:grpSpPr/>
+      <p:grpSpPr>
+        <a:xfrm>
+          <a:off x="0" y="0"/>
+          <a:ext cx="0" cy="0"/>
+          <a:chOff x="0" y="0"/>
+          <a:chExt cx="0" cy="0"/>
+        </a:xfrm>
+      </p:grpSpPr>
       <p:pic>
         <p:nvPicPr>
           <p:cNvPr id="2" name="Picture 1" descr="isuzu_logo_red.png"/>
@@ -19211,6 +19835,7 @@
           <a:lstStyle/>
           <a:p>
             <a:pPr algn="ctr"/>
+            <a:endParaRPr/>
           </a:p>
         </p:txBody>
       </p:sp>
@@ -19324,6 +19949,7 @@
           <a:lstStyle/>
           <a:p>
             <a:pPr algn="ctr"/>
+            <a:endParaRPr/>
           </a:p>
         </p:txBody>
       </p:sp>
@@ -19592,7 +20218,7 @@
 </file>
 
 <file path=ppt/slides/slide5.xml><?xml version="1.0" encoding="utf-8"?>
-<p:sld xmlns:a="http://schemas.openxmlformats.org/drawingml/2006/main" xmlns:p="http://schemas.openxmlformats.org/presentationml/2006/main" xmlns:r="http://schemas.openxmlformats.org/officeDocument/2006/relationships">
+<p:sld xmlns:a="http://schemas.openxmlformats.org/drawingml/2006/main" xmlns:r="http://schemas.openxmlformats.org/officeDocument/2006/relationships" xmlns:p="http://schemas.openxmlformats.org/presentationml/2006/main">
   <p:cSld>
     <p:bg>
       <p:bgPr>
@@ -19608,7 +20234,14 @@
         <p:cNvGrpSpPr/>
         <p:nvPr/>
       </p:nvGrpSpPr>
-      <p:grpSpPr/>
+      <p:grpSpPr>
+        <a:xfrm>
+          <a:off x="0" y="0"/>
+          <a:ext cx="0" cy="0"/>
+          <a:chOff x="0" y="0"/>
+          <a:chExt cx="0" cy="0"/>
+        </a:xfrm>
+      </p:grpSpPr>
       <p:pic>
         <p:nvPicPr>
           <p:cNvPr id="2" name="Picture 1" descr="isuzu_logo_red.png"/>
@@ -19673,6 +20306,7 @@
           <a:lstStyle/>
           <a:p>
             <a:pPr algn="ctr"/>
+            <a:endParaRPr/>
           </a:p>
         </p:txBody>
       </p:sp>
@@ -19786,6 +20420,7 @@
           <a:lstStyle/>
           <a:p>
             <a:pPr algn="ctr"/>
+            <a:endParaRPr/>
           </a:p>
         </p:txBody>
       </p:sp>
@@ -20110,7 +20745,7 @@
 </file>
 
 <file path=ppt/slides/slide6.xml><?xml version="1.0" encoding="utf-8"?>
-<p:sld xmlns:a="http://schemas.openxmlformats.org/drawingml/2006/main" xmlns:p="http://schemas.openxmlformats.org/presentationml/2006/main" xmlns:r="http://schemas.openxmlformats.org/officeDocument/2006/relationships">
+<p:sld xmlns:a="http://schemas.openxmlformats.org/drawingml/2006/main" xmlns:r="http://schemas.openxmlformats.org/officeDocument/2006/relationships" xmlns:p="http://schemas.openxmlformats.org/presentationml/2006/main">
   <p:cSld>
     <p:bg>
       <p:bgPr>
@@ -20126,7 +20761,14 @@
         <p:cNvGrpSpPr/>
         <p:nvPr/>
       </p:nvGrpSpPr>
-      <p:grpSpPr/>
+      <p:grpSpPr>
+        <a:xfrm>
+          <a:off x="0" y="0"/>
+          <a:ext cx="0" cy="0"/>
+          <a:chOff x="0" y="0"/>
+          <a:chExt cx="0" cy="0"/>
+        </a:xfrm>
+      </p:grpSpPr>
       <p:pic>
         <p:nvPicPr>
           <p:cNvPr id="2" name="Picture 1" descr="isuzu_logo_red.png"/>
@@ -20191,6 +20833,7 @@
           <a:lstStyle/>
           <a:p>
             <a:pPr algn="ctr"/>
+            <a:endParaRPr/>
           </a:p>
         </p:txBody>
       </p:sp>
@@ -20304,6 +20947,7 @@
           <a:lstStyle/>
           <a:p>
             <a:pPr algn="ctr"/>
+            <a:endParaRPr/>
           </a:p>
         </p:txBody>
       </p:sp>
@@ -20544,7 +21188,7 @@
 </file>
 
 <file path=ppt/slides/slide7.xml><?xml version="1.0" encoding="utf-8"?>
-<p:sld xmlns:a="http://schemas.openxmlformats.org/drawingml/2006/main" xmlns:p="http://schemas.openxmlformats.org/presentationml/2006/main" xmlns:r="http://schemas.openxmlformats.org/officeDocument/2006/relationships">
+<p:sld xmlns:a="http://schemas.openxmlformats.org/drawingml/2006/main" xmlns:r="http://schemas.openxmlformats.org/officeDocument/2006/relationships" xmlns:p="http://schemas.openxmlformats.org/presentationml/2006/main">
   <p:cSld>
     <p:bg>
       <p:bgPr>
@@ -20560,7 +21204,14 @@
         <p:cNvGrpSpPr/>
         <p:nvPr/>
       </p:nvGrpSpPr>
-      <p:grpSpPr/>
+      <p:grpSpPr>
+        <a:xfrm>
+          <a:off x="0" y="0"/>
+          <a:ext cx="0" cy="0"/>
+          <a:chOff x="0" y="0"/>
+          <a:chExt cx="0" cy="0"/>
+        </a:xfrm>
+      </p:grpSpPr>
       <p:pic>
         <p:nvPicPr>
           <p:cNvPr id="2" name="Picture 1" descr="isuzu_logo_red.png"/>
@@ -20625,6 +21276,7 @@
           <a:lstStyle/>
           <a:p>
             <a:pPr algn="ctr"/>
+            <a:endParaRPr/>
           </a:p>
         </p:txBody>
       </p:sp>
@@ -20738,6 +21390,7 @@
           <a:lstStyle/>
           <a:p>
             <a:pPr algn="ctr"/>
+            <a:endParaRPr/>
           </a:p>
         </p:txBody>
       </p:sp>
@@ -20795,10 +21448,34 @@
                 <a:tableStyleId>{5C22544A-7EE6-4342-B048-85BDC9FD1C3A}</a:tableStyleId>
               </a:tblPr>
               <a:tblGrid>
-                <a:gridCol w="2194560"/>
-                <a:gridCol w="4480560"/>
-                <a:gridCol w="2468880"/>
-                <a:gridCol w="2468880"/>
+                <a:gridCol w="2194560">
+                  <a:extLst>
+                    <a:ext uri="{9D8B030D-6E8A-4147-A177-3AD203B41FA5}">
+                      <a16:colId xmlns:a16="http://schemas.microsoft.com/office/drawing/2014/main" val="20000"/>
+                    </a:ext>
+                  </a:extLst>
+                </a:gridCol>
+                <a:gridCol w="4480560">
+                  <a:extLst>
+                    <a:ext uri="{9D8B030D-6E8A-4147-A177-3AD203B41FA5}">
+                      <a16:colId xmlns:a16="http://schemas.microsoft.com/office/drawing/2014/main" val="20001"/>
+                    </a:ext>
+                  </a:extLst>
+                </a:gridCol>
+                <a:gridCol w="2468880">
+                  <a:extLst>
+                    <a:ext uri="{9D8B030D-6E8A-4147-A177-3AD203B41FA5}">
+                      <a16:colId xmlns:a16="http://schemas.microsoft.com/office/drawing/2014/main" val="20002"/>
+                    </a:ext>
+                  </a:extLst>
+                </a:gridCol>
+                <a:gridCol w="2468880">
+                  <a:extLst>
+                    <a:ext uri="{9D8B030D-6E8A-4147-A177-3AD203B41FA5}">
+                      <a16:colId xmlns:a16="http://schemas.microsoft.com/office/drawing/2014/main" val="20003"/>
+                    </a:ext>
+                  </a:extLst>
+                </a:gridCol>
               </a:tblGrid>
               <a:tr h="339634">
                 <a:tc>
@@ -20818,7 +21495,7 @@
                       </a:r>
                     </a:p>
                   </a:txBody>
-                  <a:tcPr anchor="ctr" marL="73152" marR="73152">
+                  <a:tcPr marL="73152" marR="73152" anchor="ctr">
                     <a:solidFill>
                       <a:srgbClr val="CC0E1E"/>
                     </a:solidFill>
@@ -20841,7 +21518,7 @@
                       </a:r>
                     </a:p>
                   </a:txBody>
-                  <a:tcPr anchor="ctr" marL="73152" marR="73152">
+                  <a:tcPr marL="73152" marR="73152" anchor="ctr">
                     <a:solidFill>
                       <a:srgbClr val="CC0E1E"/>
                     </a:solidFill>
@@ -20864,7 +21541,7 @@
                       </a:r>
                     </a:p>
                   </a:txBody>
-                  <a:tcPr anchor="ctr" marL="73152" marR="73152">
+                  <a:tcPr marL="73152" marR="73152" anchor="ctr">
                     <a:solidFill>
                       <a:srgbClr val="CC0E1E"/>
                     </a:solidFill>
@@ -20887,12 +21564,17 @@
                       </a:r>
                     </a:p>
                   </a:txBody>
-                  <a:tcPr anchor="ctr" marL="73152" marR="73152">
+                  <a:tcPr marL="73152" marR="73152" anchor="ctr">
                     <a:solidFill>
                       <a:srgbClr val="CC0E1E"/>
                     </a:solidFill>
                   </a:tcPr>
                 </a:tc>
+                <a:extLst>
+                  <a:ext uri="{0D108BD9-81ED-4DB2-BD59-A6C34878D82A}">
+                    <a16:rowId xmlns:a16="http://schemas.microsoft.com/office/drawing/2014/main" val="10000"/>
+                  </a:ext>
+                </a:extLst>
               </a:tr>
               <a:tr h="339634">
                 <a:tc>
@@ -20912,7 +21594,7 @@
                       </a:r>
                     </a:p>
                   </a:txBody>
-                  <a:tcPr anchor="ctr" marL="73152" marR="73152">
+                  <a:tcPr marL="73152" marR="73152" anchor="ctr">
                     <a:solidFill>
                       <a:srgbClr val="FFFFFF"/>
                     </a:solidFill>
@@ -20935,7 +21617,7 @@
                       </a:r>
                     </a:p>
                   </a:txBody>
-                  <a:tcPr anchor="ctr" marL="73152" marR="73152">
+                  <a:tcPr marL="73152" marR="73152" anchor="ctr">
                     <a:solidFill>
                       <a:srgbClr val="FFFFFF"/>
                     </a:solidFill>
@@ -20958,7 +21640,7 @@
                       </a:r>
                     </a:p>
                   </a:txBody>
-                  <a:tcPr anchor="ctr" marL="73152" marR="73152">
+                  <a:tcPr marL="73152" marR="73152" anchor="ctr">
                     <a:solidFill>
                       <a:srgbClr val="FFFFFF"/>
                     </a:solidFill>
@@ -20981,12 +21663,17 @@
                       </a:r>
                     </a:p>
                   </a:txBody>
-                  <a:tcPr anchor="ctr" marL="73152" marR="73152">
+                  <a:tcPr marL="73152" marR="73152" anchor="ctr">
                     <a:solidFill>
                       <a:srgbClr val="FFFFFF"/>
                     </a:solidFill>
                   </a:tcPr>
                 </a:tc>
+                <a:extLst>
+                  <a:ext uri="{0D108BD9-81ED-4DB2-BD59-A6C34878D82A}">
+                    <a16:rowId xmlns:a16="http://schemas.microsoft.com/office/drawing/2014/main" val="10001"/>
+                  </a:ext>
+                </a:extLst>
               </a:tr>
               <a:tr h="339634">
                 <a:tc>
@@ -21006,7 +21693,7 @@
                       </a:r>
                     </a:p>
                   </a:txBody>
-                  <a:tcPr anchor="ctr" marL="73152" marR="73152">
+                  <a:tcPr marL="73152" marR="73152" anchor="ctr">
                     <a:solidFill>
                       <a:srgbClr val="ECECEC"/>
                     </a:solidFill>
@@ -21029,7 +21716,7 @@
                       </a:r>
                     </a:p>
                   </a:txBody>
-                  <a:tcPr anchor="ctr" marL="73152" marR="73152">
+                  <a:tcPr marL="73152" marR="73152" anchor="ctr">
                     <a:solidFill>
                       <a:srgbClr val="ECECEC"/>
                     </a:solidFill>
@@ -21052,7 +21739,7 @@
                       </a:r>
                     </a:p>
                   </a:txBody>
-                  <a:tcPr anchor="ctr" marL="73152" marR="73152">
+                  <a:tcPr marL="73152" marR="73152" anchor="ctr">
                     <a:solidFill>
                       <a:srgbClr val="ECECEC"/>
                     </a:solidFill>
@@ -21075,12 +21762,17 @@
                       </a:r>
                     </a:p>
                   </a:txBody>
-                  <a:tcPr anchor="ctr" marL="73152" marR="73152">
+                  <a:tcPr marL="73152" marR="73152" anchor="ctr">
                     <a:solidFill>
                       <a:srgbClr val="ECECEC"/>
                     </a:solidFill>
                   </a:tcPr>
                 </a:tc>
+                <a:extLst>
+                  <a:ext uri="{0D108BD9-81ED-4DB2-BD59-A6C34878D82A}">
+                    <a16:rowId xmlns:a16="http://schemas.microsoft.com/office/drawing/2014/main" val="10002"/>
+                  </a:ext>
+                </a:extLst>
               </a:tr>
               <a:tr h="339634">
                 <a:tc>
@@ -21100,7 +21792,7 @@
                       </a:r>
                     </a:p>
                   </a:txBody>
-                  <a:tcPr anchor="ctr" marL="73152" marR="73152">
+                  <a:tcPr marL="73152" marR="73152" anchor="ctr">
                     <a:solidFill>
                       <a:srgbClr val="FFFFFF"/>
                     </a:solidFill>
@@ -21123,7 +21815,7 @@
                       </a:r>
                     </a:p>
                   </a:txBody>
-                  <a:tcPr anchor="ctr" marL="73152" marR="73152">
+                  <a:tcPr marL="73152" marR="73152" anchor="ctr">
                     <a:solidFill>
                       <a:srgbClr val="FFFFFF"/>
                     </a:solidFill>
@@ -21146,7 +21838,7 @@
                       </a:r>
                     </a:p>
                   </a:txBody>
-                  <a:tcPr anchor="ctr" marL="73152" marR="73152">
+                  <a:tcPr marL="73152" marR="73152" anchor="ctr">
                     <a:solidFill>
                       <a:srgbClr val="FFFFFF"/>
                     </a:solidFill>
@@ -21169,12 +21861,17 @@
                       </a:r>
                     </a:p>
                   </a:txBody>
-                  <a:tcPr anchor="ctr" marL="73152" marR="73152">
+                  <a:tcPr marL="73152" marR="73152" anchor="ctr">
                     <a:solidFill>
                       <a:srgbClr val="FFFFFF"/>
                     </a:solidFill>
                   </a:tcPr>
                 </a:tc>
+                <a:extLst>
+                  <a:ext uri="{0D108BD9-81ED-4DB2-BD59-A6C34878D82A}">
+                    <a16:rowId xmlns:a16="http://schemas.microsoft.com/office/drawing/2014/main" val="10003"/>
+                  </a:ext>
+                </a:extLst>
               </a:tr>
               <a:tr h="339634">
                 <a:tc>
@@ -21194,7 +21891,7 @@
                       </a:r>
                     </a:p>
                   </a:txBody>
-                  <a:tcPr anchor="ctr" marL="73152" marR="73152">
+                  <a:tcPr marL="73152" marR="73152" anchor="ctr">
                     <a:solidFill>
                       <a:srgbClr val="ECECEC"/>
                     </a:solidFill>
@@ -21217,7 +21914,7 @@
                       </a:r>
                     </a:p>
                   </a:txBody>
-                  <a:tcPr anchor="ctr" marL="73152" marR="73152">
+                  <a:tcPr marL="73152" marR="73152" anchor="ctr">
                     <a:solidFill>
                       <a:srgbClr val="ECECEC"/>
                     </a:solidFill>
@@ -21240,7 +21937,7 @@
                       </a:r>
                     </a:p>
                   </a:txBody>
-                  <a:tcPr anchor="ctr" marL="73152" marR="73152">
+                  <a:tcPr marL="73152" marR="73152" anchor="ctr">
                     <a:solidFill>
                       <a:srgbClr val="ECECEC"/>
                     </a:solidFill>
@@ -21263,12 +21960,17 @@
                       </a:r>
                     </a:p>
                   </a:txBody>
-                  <a:tcPr anchor="ctr" marL="73152" marR="73152">
+                  <a:tcPr marL="73152" marR="73152" anchor="ctr">
                     <a:solidFill>
                       <a:srgbClr val="ECECEC"/>
                     </a:solidFill>
                   </a:tcPr>
                 </a:tc>
+                <a:extLst>
+                  <a:ext uri="{0D108BD9-81ED-4DB2-BD59-A6C34878D82A}">
+                    <a16:rowId xmlns:a16="http://schemas.microsoft.com/office/drawing/2014/main" val="10004"/>
+                  </a:ext>
+                </a:extLst>
               </a:tr>
               <a:tr h="339634">
                 <a:tc>
@@ -21288,7 +21990,7 @@
                       </a:r>
                     </a:p>
                   </a:txBody>
-                  <a:tcPr anchor="ctr" marL="73152" marR="73152">
+                  <a:tcPr marL="73152" marR="73152" anchor="ctr">
                     <a:solidFill>
                       <a:srgbClr val="FFFFFF"/>
                     </a:solidFill>
@@ -21311,7 +22013,7 @@
                       </a:r>
                     </a:p>
                   </a:txBody>
-                  <a:tcPr anchor="ctr" marL="73152" marR="73152">
+                  <a:tcPr marL="73152" marR="73152" anchor="ctr">
                     <a:solidFill>
                       <a:srgbClr val="FFFFFF"/>
                     </a:solidFill>
@@ -21334,7 +22036,7 @@
                       </a:r>
                     </a:p>
                   </a:txBody>
-                  <a:tcPr anchor="ctr" marL="73152" marR="73152">
+                  <a:tcPr marL="73152" marR="73152" anchor="ctr">
                     <a:solidFill>
                       <a:srgbClr val="FFFFFF"/>
                     </a:solidFill>
@@ -21357,12 +22059,17 @@
                       </a:r>
                     </a:p>
                   </a:txBody>
-                  <a:tcPr anchor="ctr" marL="73152" marR="73152">
+                  <a:tcPr marL="73152" marR="73152" anchor="ctr">
                     <a:solidFill>
                       <a:srgbClr val="FFFFFF"/>
                     </a:solidFill>
                   </a:tcPr>
                 </a:tc>
+                <a:extLst>
+                  <a:ext uri="{0D108BD9-81ED-4DB2-BD59-A6C34878D82A}">
+                    <a16:rowId xmlns:a16="http://schemas.microsoft.com/office/drawing/2014/main" val="10005"/>
+                  </a:ext>
+                </a:extLst>
               </a:tr>
               <a:tr h="339636">
                 <a:tc>
@@ -21382,7 +22089,7 @@
                       </a:r>
                     </a:p>
                   </a:txBody>
-                  <a:tcPr anchor="ctr" marL="73152" marR="73152">
+                  <a:tcPr marL="73152" marR="73152" anchor="ctr">
                     <a:solidFill>
                       <a:srgbClr val="ECECEC"/>
                     </a:solidFill>
@@ -21405,7 +22112,7 @@
                       </a:r>
                     </a:p>
                   </a:txBody>
-                  <a:tcPr anchor="ctr" marL="73152" marR="73152">
+                  <a:tcPr marL="73152" marR="73152" anchor="ctr">
                     <a:solidFill>
                       <a:srgbClr val="ECECEC"/>
                     </a:solidFill>
@@ -21428,7 +22135,7 @@
                       </a:r>
                     </a:p>
                   </a:txBody>
-                  <a:tcPr anchor="ctr" marL="73152" marR="73152">
+                  <a:tcPr marL="73152" marR="73152" anchor="ctr">
                     <a:solidFill>
                       <a:srgbClr val="ECECEC"/>
                     </a:solidFill>
@@ -21451,12 +22158,17 @@
                       </a:r>
                     </a:p>
                   </a:txBody>
-                  <a:tcPr anchor="ctr" marL="73152" marR="73152">
+                  <a:tcPr marL="73152" marR="73152" anchor="ctr">
                     <a:solidFill>
                       <a:srgbClr val="ECECEC"/>
                     </a:solidFill>
                   </a:tcPr>
                 </a:tc>
+                <a:extLst>
+                  <a:ext uri="{0D108BD9-81ED-4DB2-BD59-A6C34878D82A}">
+                    <a16:rowId xmlns:a16="http://schemas.microsoft.com/office/drawing/2014/main" val="10006"/>
+                  </a:ext>
+                </a:extLst>
               </a:tr>
             </a:tbl>
           </a:graphicData>
@@ -21578,7 +22290,7 @@
 </file>
 
 <file path=ppt/slides/slide8.xml><?xml version="1.0" encoding="utf-8"?>
-<p:sld xmlns:a="http://schemas.openxmlformats.org/drawingml/2006/main" xmlns:p="http://schemas.openxmlformats.org/presentationml/2006/main" xmlns:r="http://schemas.openxmlformats.org/officeDocument/2006/relationships">
+<p:sld xmlns:a="http://schemas.openxmlformats.org/drawingml/2006/main" xmlns:r="http://schemas.openxmlformats.org/officeDocument/2006/relationships" xmlns:p="http://schemas.openxmlformats.org/presentationml/2006/main">
   <p:cSld>
     <p:bg>
       <p:bgPr>
@@ -21594,7 +22306,14 @@
         <p:cNvGrpSpPr/>
         <p:nvPr/>
       </p:nvGrpSpPr>
-      <p:grpSpPr/>
+      <p:grpSpPr>
+        <a:xfrm>
+          <a:off x="0" y="0"/>
+          <a:ext cx="0" cy="0"/>
+          <a:chOff x="0" y="0"/>
+          <a:chExt cx="0" cy="0"/>
+        </a:xfrm>
+      </p:grpSpPr>
       <p:pic>
         <p:nvPicPr>
           <p:cNvPr id="2" name="Picture 1" descr="isuzu_logo_red.png"/>
@@ -21659,6 +22378,7 @@
           <a:lstStyle/>
           <a:p>
             <a:pPr algn="ctr"/>
+            <a:endParaRPr/>
           </a:p>
         </p:txBody>
       </p:sp>
@@ -21772,6 +22492,7 @@
           <a:lstStyle/>
           <a:p>
             <a:pPr algn="ctr"/>
+            <a:endParaRPr/>
           </a:p>
         </p:txBody>
       </p:sp>
@@ -21829,10 +22550,34 @@
                 <a:tableStyleId>{5C22544A-7EE6-4342-B048-85BDC9FD1C3A}</a:tableStyleId>
               </a:tblPr>
               <a:tblGrid>
-                <a:gridCol w="2194560"/>
-                <a:gridCol w="4023360"/>
-                <a:gridCol w="2194560"/>
-                <a:gridCol w="3200400"/>
+                <a:gridCol w="2194560">
+                  <a:extLst>
+                    <a:ext uri="{9D8B030D-6E8A-4147-A177-3AD203B41FA5}">
+                      <a16:colId xmlns:a16="http://schemas.microsoft.com/office/drawing/2014/main" val="20000"/>
+                    </a:ext>
+                  </a:extLst>
+                </a:gridCol>
+                <a:gridCol w="4023360">
+                  <a:extLst>
+                    <a:ext uri="{9D8B030D-6E8A-4147-A177-3AD203B41FA5}">
+                      <a16:colId xmlns:a16="http://schemas.microsoft.com/office/drawing/2014/main" val="20001"/>
+                    </a:ext>
+                  </a:extLst>
+                </a:gridCol>
+                <a:gridCol w="2194560">
+                  <a:extLst>
+                    <a:ext uri="{9D8B030D-6E8A-4147-A177-3AD203B41FA5}">
+                      <a16:colId xmlns:a16="http://schemas.microsoft.com/office/drawing/2014/main" val="20002"/>
+                    </a:ext>
+                  </a:extLst>
+                </a:gridCol>
+                <a:gridCol w="3200400">
+                  <a:extLst>
+                    <a:ext uri="{9D8B030D-6E8A-4147-A177-3AD203B41FA5}">
+                      <a16:colId xmlns:a16="http://schemas.microsoft.com/office/drawing/2014/main" val="20003"/>
+                    </a:ext>
+                  </a:extLst>
+                </a:gridCol>
               </a:tblGrid>
               <a:tr h="365760">
                 <a:tc>
@@ -21852,7 +22597,7 @@
                       </a:r>
                     </a:p>
                   </a:txBody>
-                  <a:tcPr anchor="ctr" marL="73152" marR="73152">
+                  <a:tcPr marL="73152" marR="73152" anchor="ctr">
                     <a:solidFill>
                       <a:srgbClr val="CC0E1E"/>
                     </a:solidFill>
@@ -21875,7 +22620,7 @@
                       </a:r>
                     </a:p>
                   </a:txBody>
-                  <a:tcPr anchor="ctr" marL="73152" marR="73152">
+                  <a:tcPr marL="73152" marR="73152" anchor="ctr">
                     <a:solidFill>
                       <a:srgbClr val="CC0E1E"/>
                     </a:solidFill>
@@ -21898,7 +22643,7 @@
                       </a:r>
                     </a:p>
                   </a:txBody>
-                  <a:tcPr anchor="ctr" marL="73152" marR="73152">
+                  <a:tcPr marL="73152" marR="73152" anchor="ctr">
                     <a:solidFill>
                       <a:srgbClr val="CC0E1E"/>
                     </a:solidFill>
@@ -21921,12 +22666,17 @@
                       </a:r>
                     </a:p>
                   </a:txBody>
-                  <a:tcPr anchor="ctr" marL="73152" marR="73152">
+                  <a:tcPr marL="73152" marR="73152" anchor="ctr">
                     <a:solidFill>
                       <a:srgbClr val="CC0E1E"/>
                     </a:solidFill>
                   </a:tcPr>
                 </a:tc>
+                <a:extLst>
+                  <a:ext uri="{0D108BD9-81ED-4DB2-BD59-A6C34878D82A}">
+                    <a16:rowId xmlns:a16="http://schemas.microsoft.com/office/drawing/2014/main" val="10000"/>
+                  </a:ext>
+                </a:extLst>
               </a:tr>
               <a:tr h="365760">
                 <a:tc>
@@ -21946,7 +22696,7 @@
                       </a:r>
                     </a:p>
                   </a:txBody>
-                  <a:tcPr anchor="ctr" marL="73152" marR="73152">
+                  <a:tcPr marL="73152" marR="73152" anchor="ctr">
                     <a:solidFill>
                       <a:srgbClr val="FFFFFF"/>
                     </a:solidFill>
@@ -21969,7 +22719,7 @@
                       </a:r>
                     </a:p>
                   </a:txBody>
-                  <a:tcPr anchor="ctr" marL="73152" marR="73152">
+                  <a:tcPr marL="73152" marR="73152" anchor="ctr">
                     <a:solidFill>
                       <a:srgbClr val="FFFFFF"/>
                     </a:solidFill>
@@ -21992,7 +22742,7 @@
                       </a:r>
                     </a:p>
                   </a:txBody>
-                  <a:tcPr anchor="ctr" marL="73152" marR="73152">
+                  <a:tcPr marL="73152" marR="73152" anchor="ctr">
                     <a:solidFill>
                       <a:srgbClr val="FFFFFF"/>
                     </a:solidFill>
@@ -22015,12 +22765,17 @@
                       </a:r>
                     </a:p>
                   </a:txBody>
-                  <a:tcPr anchor="ctr" marL="73152" marR="73152">
+                  <a:tcPr marL="73152" marR="73152" anchor="ctr">
                     <a:solidFill>
                       <a:srgbClr val="FFFFFF"/>
                     </a:solidFill>
                   </a:tcPr>
                 </a:tc>
+                <a:extLst>
+                  <a:ext uri="{0D108BD9-81ED-4DB2-BD59-A6C34878D82A}">
+                    <a16:rowId xmlns:a16="http://schemas.microsoft.com/office/drawing/2014/main" val="10001"/>
+                  </a:ext>
+                </a:extLst>
               </a:tr>
               <a:tr h="365760">
                 <a:tc>
@@ -22040,7 +22795,7 @@
                       </a:r>
                     </a:p>
                   </a:txBody>
-                  <a:tcPr anchor="ctr" marL="73152" marR="73152">
+                  <a:tcPr marL="73152" marR="73152" anchor="ctr">
                     <a:solidFill>
                       <a:srgbClr val="ECECEC"/>
                     </a:solidFill>
@@ -22063,7 +22818,7 @@
                       </a:r>
                     </a:p>
                   </a:txBody>
-                  <a:tcPr anchor="ctr" marL="73152" marR="73152">
+                  <a:tcPr marL="73152" marR="73152" anchor="ctr">
                     <a:solidFill>
                       <a:srgbClr val="ECECEC"/>
                     </a:solidFill>
@@ -22086,7 +22841,7 @@
                       </a:r>
                     </a:p>
                   </a:txBody>
-                  <a:tcPr anchor="ctr" marL="73152" marR="73152">
+                  <a:tcPr marL="73152" marR="73152" anchor="ctr">
                     <a:solidFill>
                       <a:srgbClr val="ECECEC"/>
                     </a:solidFill>
@@ -22109,12 +22864,17 @@
                       </a:r>
                     </a:p>
                   </a:txBody>
-                  <a:tcPr anchor="ctr" marL="73152" marR="73152">
+                  <a:tcPr marL="73152" marR="73152" anchor="ctr">
                     <a:solidFill>
                       <a:srgbClr val="ECECEC"/>
                     </a:solidFill>
                   </a:tcPr>
                 </a:tc>
+                <a:extLst>
+                  <a:ext uri="{0D108BD9-81ED-4DB2-BD59-A6C34878D82A}">
+                    <a16:rowId xmlns:a16="http://schemas.microsoft.com/office/drawing/2014/main" val="10002"/>
+                  </a:ext>
+                </a:extLst>
               </a:tr>
               <a:tr h="365760">
                 <a:tc>
@@ -22134,7 +22894,7 @@
                       </a:r>
                     </a:p>
                   </a:txBody>
-                  <a:tcPr anchor="ctr" marL="73152" marR="73152">
+                  <a:tcPr marL="73152" marR="73152" anchor="ctr">
                     <a:solidFill>
                       <a:srgbClr val="FFFFFF"/>
                     </a:solidFill>
@@ -22157,7 +22917,7 @@
                       </a:r>
                     </a:p>
                   </a:txBody>
-                  <a:tcPr anchor="ctr" marL="73152" marR="73152">
+                  <a:tcPr marL="73152" marR="73152" anchor="ctr">
                     <a:solidFill>
                       <a:srgbClr val="FFFFFF"/>
                     </a:solidFill>
@@ -22180,7 +22940,7 @@
                       </a:r>
                     </a:p>
                   </a:txBody>
-                  <a:tcPr anchor="ctr" marL="73152" marR="73152">
+                  <a:tcPr marL="73152" marR="73152" anchor="ctr">
                     <a:solidFill>
                       <a:srgbClr val="FFFFFF"/>
                     </a:solidFill>
@@ -22203,12 +22963,17 @@
                       </a:r>
                     </a:p>
                   </a:txBody>
-                  <a:tcPr anchor="ctr" marL="73152" marR="73152">
+                  <a:tcPr marL="73152" marR="73152" anchor="ctr">
                     <a:solidFill>
                       <a:srgbClr val="FFFFFF"/>
                     </a:solidFill>
                   </a:tcPr>
                 </a:tc>
+                <a:extLst>
+                  <a:ext uri="{0D108BD9-81ED-4DB2-BD59-A6C34878D82A}">
+                    <a16:rowId xmlns:a16="http://schemas.microsoft.com/office/drawing/2014/main" val="10003"/>
+                  </a:ext>
+                </a:extLst>
               </a:tr>
               <a:tr h="365760">
                 <a:tc>
@@ -22228,7 +22993,7 @@
                       </a:r>
                     </a:p>
                   </a:txBody>
-                  <a:tcPr anchor="ctr" marL="73152" marR="73152">
+                  <a:tcPr marL="73152" marR="73152" anchor="ctr">
                     <a:solidFill>
                       <a:srgbClr val="ECECEC"/>
                     </a:solidFill>
@@ -22251,7 +23016,7 @@
                       </a:r>
                     </a:p>
                   </a:txBody>
-                  <a:tcPr anchor="ctr" marL="73152" marR="73152">
+                  <a:tcPr marL="73152" marR="73152" anchor="ctr">
                     <a:solidFill>
                       <a:srgbClr val="ECECEC"/>
                     </a:solidFill>
@@ -22274,7 +23039,7 @@
                       </a:r>
                     </a:p>
                   </a:txBody>
-                  <a:tcPr anchor="ctr" marL="73152" marR="73152">
+                  <a:tcPr marL="73152" marR="73152" anchor="ctr">
                     <a:solidFill>
                       <a:srgbClr val="ECECEC"/>
                     </a:solidFill>
@@ -22297,12 +23062,17 @@
                       </a:r>
                     </a:p>
                   </a:txBody>
-                  <a:tcPr anchor="ctr" marL="73152" marR="73152">
+                  <a:tcPr marL="73152" marR="73152" anchor="ctr">
                     <a:solidFill>
                       <a:srgbClr val="ECECEC"/>
                     </a:solidFill>
                   </a:tcPr>
                 </a:tc>
+                <a:extLst>
+                  <a:ext uri="{0D108BD9-81ED-4DB2-BD59-A6C34878D82A}">
+                    <a16:rowId xmlns:a16="http://schemas.microsoft.com/office/drawing/2014/main" val="10004"/>
+                  </a:ext>
+                </a:extLst>
               </a:tr>
               <a:tr h="365760">
                 <a:tc>
@@ -22322,7 +23092,7 @@
                       </a:r>
                     </a:p>
                   </a:txBody>
-                  <a:tcPr anchor="ctr" marL="73152" marR="73152">
+                  <a:tcPr marL="73152" marR="73152" anchor="ctr">
                     <a:solidFill>
                       <a:srgbClr val="FFFFFF"/>
                     </a:solidFill>
@@ -22345,7 +23115,7 @@
                       </a:r>
                     </a:p>
                   </a:txBody>
-                  <a:tcPr anchor="ctr" marL="73152" marR="73152">
+                  <a:tcPr marL="73152" marR="73152" anchor="ctr">
                     <a:solidFill>
                       <a:srgbClr val="FFFFFF"/>
                     </a:solidFill>
@@ -22368,7 +23138,7 @@
                       </a:r>
                     </a:p>
                   </a:txBody>
-                  <a:tcPr anchor="ctr" marL="73152" marR="73152">
+                  <a:tcPr marL="73152" marR="73152" anchor="ctr">
                     <a:solidFill>
                       <a:srgbClr val="FFFFFF"/>
                     </a:solidFill>
@@ -22391,12 +23161,17 @@
                       </a:r>
                     </a:p>
                   </a:txBody>
-                  <a:tcPr anchor="ctr" marL="73152" marR="73152">
+                  <a:tcPr marL="73152" marR="73152" anchor="ctr">
                     <a:solidFill>
                       <a:srgbClr val="FFFFFF"/>
                     </a:solidFill>
                   </a:tcPr>
                 </a:tc>
+                <a:extLst>
+                  <a:ext uri="{0D108BD9-81ED-4DB2-BD59-A6C34878D82A}">
+                    <a16:rowId xmlns:a16="http://schemas.microsoft.com/office/drawing/2014/main" val="10005"/>
+                  </a:ext>
+                </a:extLst>
               </a:tr>
               <a:tr h="365760">
                 <a:tc>
@@ -22416,7 +23191,7 @@
                       </a:r>
                     </a:p>
                   </a:txBody>
-                  <a:tcPr anchor="ctr" marL="73152" marR="73152">
+                  <a:tcPr marL="73152" marR="73152" anchor="ctr">
                     <a:solidFill>
                       <a:srgbClr val="ECECEC"/>
                     </a:solidFill>
@@ -22439,7 +23214,7 @@
                       </a:r>
                     </a:p>
                   </a:txBody>
-                  <a:tcPr anchor="ctr" marL="73152" marR="73152">
+                  <a:tcPr marL="73152" marR="73152" anchor="ctr">
                     <a:solidFill>
                       <a:srgbClr val="ECECEC"/>
                     </a:solidFill>
@@ -22462,7 +23237,7 @@
                       </a:r>
                     </a:p>
                   </a:txBody>
-                  <a:tcPr anchor="ctr" marL="73152" marR="73152">
+                  <a:tcPr marL="73152" marR="73152" anchor="ctr">
                     <a:solidFill>
                       <a:srgbClr val="ECECEC"/>
                     </a:solidFill>
@@ -22485,12 +23260,17 @@
                       </a:r>
                     </a:p>
                   </a:txBody>
-                  <a:tcPr anchor="ctr" marL="73152" marR="73152">
+                  <a:tcPr marL="73152" marR="73152" anchor="ctr">
                     <a:solidFill>
                       <a:srgbClr val="ECECEC"/>
                     </a:solidFill>
                   </a:tcPr>
                 </a:tc>
+                <a:extLst>
+                  <a:ext uri="{0D108BD9-81ED-4DB2-BD59-A6C34878D82A}">
+                    <a16:rowId xmlns:a16="http://schemas.microsoft.com/office/drawing/2014/main" val="10006"/>
+                  </a:ext>
+                </a:extLst>
               </a:tr>
             </a:tbl>
           </a:graphicData>
@@ -22584,7 +23364,7 @@
 </file>
 
 <file path=ppt/slides/slide9.xml><?xml version="1.0" encoding="utf-8"?>
-<p:sld xmlns:a="http://schemas.openxmlformats.org/drawingml/2006/main" xmlns:p="http://schemas.openxmlformats.org/presentationml/2006/main" xmlns:r="http://schemas.openxmlformats.org/officeDocument/2006/relationships">
+<p:sld xmlns:a="http://schemas.openxmlformats.org/drawingml/2006/main" xmlns:r="http://schemas.openxmlformats.org/officeDocument/2006/relationships" xmlns:p="http://schemas.openxmlformats.org/presentationml/2006/main">
   <p:cSld>
     <p:bg>
       <p:bgPr>
@@ -22600,7 +23380,14 @@
         <p:cNvGrpSpPr/>
         <p:nvPr/>
       </p:nvGrpSpPr>
-      <p:grpSpPr/>
+      <p:grpSpPr>
+        <a:xfrm>
+          <a:off x="0" y="0"/>
+          <a:ext cx="0" cy="0"/>
+          <a:chOff x="0" y="0"/>
+          <a:chExt cx="0" cy="0"/>
+        </a:xfrm>
+      </p:grpSpPr>
       <p:pic>
         <p:nvPicPr>
           <p:cNvPr id="2" name="Picture 1" descr="isuzu_logo_red.png"/>
@@ -22665,6 +23452,7 @@
           <a:lstStyle/>
           <a:p>
             <a:pPr algn="ctr"/>
+            <a:endParaRPr/>
           </a:p>
         </p:txBody>
       </p:sp>
@@ -22778,6 +23566,7 @@
           <a:lstStyle/>
           <a:p>
             <a:pPr algn="ctr"/>
+            <a:endParaRPr/>
           </a:p>
         </p:txBody>
       </p:sp>

</xml_diff>